<commit_message>
Move sequence diagram slides to white background
Slides 6, 11 and 13 now use the light template layout with a palette
tuned for white: dark arrows and labels, darker brand outlines, and
light participant boxes.

Co-Authored-By: Claude Opus 5.5 <noreply@anthropic.com>
Claude-Session: https://claude.ai/code/session_0161UfSgfoLg2WkzVi8freAH
</commit_message>
<xml_diff>
--- a/deck/Memorial-Hermann-Event-Platform.pptx
+++ b/deck/Memorial-Hermann-Event-Platform.pptx
@@ -132,14 +132,14 @@
   <p:extLst>
     <p:ext uri="{521415D9-36F7-43E2-AB2F-B90AF26B5E84}">
       <p14:sectionLst xmlns:p14="http://schemas.microsoft.com/office/powerpoint/2010/main">
-        <p14:section name="Introduction" id="{e3479ca7-9daf-dd6a-f5f7-806fc403effb}">
+        <p14:section name="Introduction" id="{bbf1abc1-159d-f461-fde9-32051e32f79d}">
           <p14:sldIdLst>
             <p14:sldId id="256"/>
             <p14:sldId id="257"/>
             <p14:sldId id="258"/>
           </p14:sldIdLst>
         </p14:section>
-        <p14:section name="The solution" id="{d190dae1-3c12-73a7-6cb1-c361cd79e491}">
+        <p14:section name="The solution" id="{54b3c046-ccfb-9a45-13a4-9363b7effc88}">
           <p14:sldIdLst>
             <p14:sldId id="259"/>
             <p14:sldId id="260"/>
@@ -153,14 +153,14 @@
             <p14:sldId id="268"/>
           </p14:sldIdLst>
         </p14:section>
-        <p14:section name="Delivery plan" id="{9bed81af-68b1-e08a-e27b-9cb959d7b3f1}">
+        <p14:section name="Delivery plan" id="{ffd33b23-e400-7169-7b3d-2b6763c70132}">
           <p14:sldIdLst>
             <p14:sldId id="269"/>
             <p14:sldId id="270"/>
             <p14:sldId id="271"/>
           </p14:sldIdLst>
         </p14:section>
-        <p14:section name="Beyond the event" id="{d723d0bc-6010-d434-e1ad-3aa55cded8b1}">
+        <p14:section name="Beyond the event" id="{21898343-8e27-6f12-2ba9-ae34f8481233}">
           <p14:sldIdLst>
             <p14:sldId id="272"/>
             <p14:sldId id="273"/>
@@ -170,7 +170,7 @@
             <p14:sldId id="277"/>
           </p14:sldIdLst>
         </p14:section>
-        <p14:section name="Roadmap and next steps" id="{cadcd1b0-e7a9-cf21-acbe-80657a54889c}">
+        <p14:section name="Roadmap and next steps" id="{1e055a5b-d0fd-8d8f-78e4-af12201f910b}">
           <p14:sldIdLst>
             <p14:sldId id="278"/>
             <p14:sldId id="279"/>
@@ -6270,7 +6270,7 @@
             <a:r>
               <a:rPr lang="en-US" sz="3200" b="1" dirty="0">
                 <a:solidFill>
-                  <a:schemeClr val="bg1"/>
+                  <a:schemeClr val="tx1"/>
                 </a:solidFill>
               </a:rPr>
               <a:t>Design detail: registration and seat flow</a:t>
@@ -6296,11 +6296,11 @@
             </a:avLst>
           </a:prstGeom>
           <a:solidFill>
-            <a:srgbClr val="17171B"/>
+            <a:srgbClr val="F2F2F2"/>
           </a:solidFill>
           <a:ln w="15875">
             <a:solidFill>
-              <a:srgbClr val="6A6A75"/>
+              <a:srgbClr val="B8B8C0"/>
             </a:solidFill>
             <a:prstDash val="solid"/>
           </a:ln>
@@ -6333,7 +6333,7 @@
             <a:r>
               <a:rPr lang="en-US" sz="1050" b="1" dirty="0">
                 <a:solidFill>
-                  <a:srgbClr val="FFFFFF"/>
+                  <a:srgbClr val="000000"/>
                 </a:solidFill>
               </a:rPr>
               <a:t>Registrant</a:t>
@@ -6359,7 +6359,7 @@
           <a:noFill/>
           <a:ln w="12700">
             <a:solidFill>
-              <a:srgbClr val="4A4A55"/>
+              <a:srgbClr val="B0B0B8"/>
             </a:solidFill>
             <a:prstDash val="dash"/>
           </a:ln>
@@ -6382,11 +6382,11 @@
             </a:avLst>
           </a:prstGeom>
           <a:solidFill>
-            <a:srgbClr val="17171B"/>
+            <a:srgbClr val="F2F2F2"/>
           </a:solidFill>
-          <a:ln w="15875">
+          <a:ln w="22225">
             <a:solidFill>
-              <a:srgbClr val="00D6F2"/>
+              <a:srgbClr val="00A9C0"/>
             </a:solidFill>
             <a:prstDash val="solid"/>
           </a:ln>
@@ -6419,7 +6419,7 @@
             <a:r>
               <a:rPr lang="en-US" sz="1050" b="1" dirty="0">
                 <a:solidFill>
-                  <a:srgbClr val="FFFFFF"/>
+                  <a:srgbClr val="000000"/>
                 </a:solidFill>
               </a:rPr>
               <a:t>Edge and waiting room</a:t>
@@ -6445,7 +6445,7 @@
           <a:noFill/>
           <a:ln w="12700">
             <a:solidFill>
-              <a:srgbClr val="4A4A55"/>
+              <a:srgbClr val="B0B0B8"/>
             </a:solidFill>
             <a:prstDash val="dash"/>
           </a:ln>
@@ -6468,11 +6468,11 @@
             </a:avLst>
           </a:prstGeom>
           <a:solidFill>
-            <a:srgbClr val="17171B"/>
+            <a:srgbClr val="F2F2F2"/>
           </a:solidFill>
-          <a:ln w="15875">
+          <a:ln w="22225">
             <a:solidFill>
-              <a:srgbClr val="FED700"/>
+              <a:srgbClr val="D9B200"/>
             </a:solidFill>
             <a:prstDash val="solid"/>
           </a:ln>
@@ -6505,7 +6505,7 @@
             <a:r>
               <a:rPr lang="en-US" sz="1050" b="1" dirty="0">
                 <a:solidFill>
-                  <a:srgbClr val="FFFFFF"/>
+                  <a:srgbClr val="000000"/>
                 </a:solidFill>
               </a:rPr>
               <a:t>Registration service</a:t>
@@ -6531,7 +6531,7 @@
           <a:noFill/>
           <a:ln w="12700">
             <a:solidFill>
-              <a:srgbClr val="4A4A55"/>
+              <a:srgbClr val="B0B0B8"/>
             </a:solidFill>
             <a:prstDash val="dash"/>
           </a:ln>
@@ -6554,11 +6554,11 @@
             </a:avLst>
           </a:prstGeom>
           <a:solidFill>
-            <a:srgbClr val="17171B"/>
+            <a:srgbClr val="F2F2F2"/>
           </a:solidFill>
-          <a:ln w="15875">
+          <a:ln w="22225">
             <a:solidFill>
-              <a:srgbClr val="FED700"/>
+              <a:srgbClr val="D9B200"/>
             </a:solidFill>
             <a:prstDash val="solid"/>
           </a:ln>
@@ -6591,7 +6591,7 @@
             <a:r>
               <a:rPr lang="en-US" sz="1050" b="1" dirty="0">
                 <a:solidFill>
-                  <a:srgbClr val="FFFFFF"/>
+                  <a:srgbClr val="000000"/>
                 </a:solidFill>
               </a:rPr>
               <a:t>Seat inventory</a:t>
@@ -6617,7 +6617,7 @@
           <a:noFill/>
           <a:ln w="12700">
             <a:solidFill>
-              <a:srgbClr val="4A4A55"/>
+              <a:srgbClr val="B0B0B8"/>
             </a:solidFill>
             <a:prstDash val="dash"/>
           </a:ln>
@@ -6640,11 +6640,11 @@
             </a:avLst>
           </a:prstGeom>
           <a:solidFill>
-            <a:srgbClr val="17171B"/>
+            <a:srgbClr val="F2F2F2"/>
           </a:solidFill>
           <a:ln w="15875">
             <a:solidFill>
-              <a:srgbClr val="6A6A75"/>
+              <a:srgbClr val="B8B8C0"/>
             </a:solidFill>
             <a:prstDash val="solid"/>
           </a:ln>
@@ -6677,7 +6677,7 @@
             <a:r>
               <a:rPr lang="en-US" sz="1050" b="1" dirty="0">
                 <a:solidFill>
-                  <a:srgbClr val="FFFFFF"/>
+                  <a:srgbClr val="000000"/>
                 </a:solidFill>
               </a:rPr>
               <a:t>Payment page</a:t>
@@ -6703,7 +6703,7 @@
           <a:noFill/>
           <a:ln w="12700">
             <a:solidFill>
-              <a:srgbClr val="4A4A55"/>
+              <a:srgbClr val="B0B0B8"/>
             </a:solidFill>
             <a:prstDash val="dash"/>
           </a:ln>
@@ -6726,11 +6726,11 @@
             </a:avLst>
           </a:prstGeom>
           <a:solidFill>
-            <a:srgbClr val="17171B"/>
+            <a:srgbClr val="F2F2F2"/>
           </a:solidFill>
-          <a:ln w="15875">
+          <a:ln w="22225">
             <a:solidFill>
-              <a:srgbClr val="00D6F2"/>
+              <a:srgbClr val="00A9C0"/>
             </a:solidFill>
             <a:prstDash val="solid"/>
           </a:ln>
@@ -6763,7 +6763,7 @@
             <a:r>
               <a:rPr lang="en-US" sz="1050" b="1" dirty="0">
                 <a:solidFill>
-                  <a:srgbClr val="FFFFFF"/>
+                  <a:srgbClr val="000000"/>
                 </a:solidFill>
               </a:rPr>
               <a:t>Salesforce</a:t>
@@ -6789,7 +6789,7 @@
           <a:noFill/>
           <a:ln w="12700">
             <a:solidFill>
-              <a:srgbClr val="4A4A55"/>
+              <a:srgbClr val="B0B0B8"/>
             </a:solidFill>
             <a:prstDash val="dash"/>
           </a:ln>
@@ -6812,9 +6812,9 @@
             </a:avLst>
           </a:prstGeom>
           <a:solidFill>
-            <a:srgbClr val="17171B"/>
+            <a:srgbClr val="F2F2F2"/>
           </a:solidFill>
-          <a:ln w="15875">
+          <a:ln w="22225">
             <a:solidFill>
               <a:srgbClr val="FF0068"/>
             </a:solidFill>
@@ -6849,7 +6849,7 @@
             <a:r>
               <a:rPr lang="en-US" sz="1050" b="1" dirty="0">
                 <a:solidFill>
-                  <a:srgbClr val="FFFFFF"/>
+                  <a:srgbClr val="000000"/>
                 </a:solidFill>
               </a:rPr>
               <a:t>Marketing Cloud</a:t>
@@ -6875,7 +6875,7 @@
           <a:noFill/>
           <a:ln w="12700">
             <a:solidFill>
-              <a:srgbClr val="4A4A55"/>
+              <a:srgbClr val="B0B0B8"/>
             </a:solidFill>
             <a:prstDash val="dash"/>
           </a:ln>
@@ -6898,7 +6898,7 @@
           <a:noFill/>
           <a:ln w="15875">
             <a:solidFill>
-              <a:srgbClr val="FFFFFF"/>
+              <a:srgbClr val="1A1A1A"/>
             </a:solidFill>
             <a:prstDash val="solid"/>
             <a:tailEnd type="triangle"/>
@@ -6920,11 +6920,11 @@
             <a:avLst/>
           </a:prstGeom>
           <a:solidFill>
-            <a:srgbClr val="00D6F2"/>
+            <a:srgbClr val="00A9C0"/>
           </a:solidFill>
           <a:ln w="12700">
             <a:solidFill>
-              <a:srgbClr val="00D6F2"/>
+              <a:srgbClr val="00A9C0"/>
             </a:solidFill>
             <a:prstDash val="solid"/>
           </a:ln>
@@ -6993,7 +6993,7 @@
             <a:r>
               <a:rPr lang="en-US" sz="1000" dirty="0">
                 <a:solidFill>
-                  <a:srgbClr val="FFFFFF"/>
+                  <a:srgbClr val="000000"/>
                 </a:solidFill>
               </a:rPr>
               <a:t>Click Register</a:t>
@@ -7019,7 +7019,7 @@
           <a:noFill/>
           <a:ln w="15875">
             <a:solidFill>
-              <a:srgbClr val="9AA7B4"/>
+              <a:srgbClr val="6B7280"/>
             </a:solidFill>
             <a:prstDash val="dash"/>
             <a:headEnd type="triangle"/>
@@ -7041,11 +7041,11 @@
             <a:avLst/>
           </a:prstGeom>
           <a:solidFill>
-            <a:srgbClr val="00D6F2"/>
+            <a:srgbClr val="00A9C0"/>
           </a:solidFill>
           <a:ln w="12700">
             <a:solidFill>
-              <a:srgbClr val="00D6F2"/>
+              <a:srgbClr val="00A9C0"/>
             </a:solidFill>
             <a:prstDash val="solid"/>
           </a:ln>
@@ -7114,7 +7114,7 @@
             <a:r>
               <a:rPr lang="en-US" sz="1000" dirty="0">
                 <a:solidFill>
-                  <a:srgbClr val="D0D6DC"/>
+                  <a:srgbClr val="4D4D4D"/>
                 </a:solidFill>
               </a:rPr>
               <a:t>Place in line shown</a:t>
@@ -7140,7 +7140,7 @@
           <a:noFill/>
           <a:ln w="15875">
             <a:solidFill>
-              <a:srgbClr val="FFFFFF"/>
+              <a:srgbClr val="1A1A1A"/>
             </a:solidFill>
             <a:prstDash val="solid"/>
             <a:tailEnd type="triangle"/>
@@ -7162,11 +7162,11 @@
             <a:avLst/>
           </a:prstGeom>
           <a:solidFill>
-            <a:srgbClr val="00D6F2"/>
+            <a:srgbClr val="00A9C0"/>
           </a:solidFill>
           <a:ln w="12700">
             <a:solidFill>
-              <a:srgbClr val="00D6F2"/>
+              <a:srgbClr val="00A9C0"/>
             </a:solidFill>
             <a:prstDash val="solid"/>
           </a:ln>
@@ -7235,7 +7235,7 @@
             <a:r>
               <a:rPr lang="en-US" sz="1000" dirty="0">
                 <a:solidFill>
-                  <a:srgbClr val="FFFFFF"/>
+                  <a:srgbClr val="000000"/>
                 </a:solidFill>
               </a:rPr>
               <a:t>Admit at a safe rate</a:t>
@@ -7261,7 +7261,7 @@
           <a:noFill/>
           <a:ln w="15875">
             <a:solidFill>
-              <a:srgbClr val="FFFFFF"/>
+              <a:srgbClr val="1A1A1A"/>
             </a:solidFill>
             <a:prstDash val="solid"/>
             <a:tailEnd type="triangle"/>
@@ -7283,11 +7283,11 @@
             <a:avLst/>
           </a:prstGeom>
           <a:solidFill>
-            <a:srgbClr val="00D6F2"/>
+            <a:srgbClr val="00A9C0"/>
           </a:solidFill>
           <a:ln w="12700">
             <a:solidFill>
-              <a:srgbClr val="00D6F2"/>
+              <a:srgbClr val="00A9C0"/>
             </a:solidFill>
             <a:prstDash val="solid"/>
           </a:ln>
@@ -7356,7 +7356,7 @@
             <a:r>
               <a:rPr lang="en-US" sz="1000" dirty="0">
                 <a:solidFill>
-                  <a:srgbClr val="FFFFFF"/>
+                  <a:srgbClr val="000000"/>
                 </a:solidFill>
               </a:rPr>
               <a:t>Hold one seat (atomic)</a:t>
@@ -7382,11 +7382,11 @@
             </a:avLst>
           </a:prstGeom>
           <a:solidFill>
-            <a:srgbClr val="2A2508"/>
+            <a:srgbClr val="FFF6CC"/>
           </a:solidFill>
           <a:ln w="12700">
             <a:solidFill>
-              <a:srgbClr val="FED700"/>
+              <a:srgbClr val="D9B200"/>
             </a:solidFill>
             <a:prstDash val="solid"/>
           </a:ln>
@@ -7419,7 +7419,7 @@
             <a:r>
               <a:rPr lang="en-US" sz="950" b="1" dirty="0">
                 <a:solidFill>
-                  <a:srgbClr val="FED700"/>
+                  <a:srgbClr val="6B5600"/>
                 </a:solidFill>
               </a:rPr>
               <a:t>If a seat is available</a:t>
@@ -7445,7 +7445,7 @@
           <a:noFill/>
           <a:ln w="15875">
             <a:solidFill>
-              <a:srgbClr val="9AA7B4"/>
+              <a:srgbClr val="6B7280"/>
             </a:solidFill>
             <a:prstDash val="dash"/>
             <a:headEnd type="triangle"/>
@@ -7467,11 +7467,11 @@
             <a:avLst/>
           </a:prstGeom>
           <a:solidFill>
-            <a:srgbClr val="00D6F2"/>
+            <a:srgbClr val="00A9C0"/>
           </a:solidFill>
           <a:ln w="12700">
             <a:solidFill>
-              <a:srgbClr val="00D6F2"/>
+              <a:srgbClr val="00A9C0"/>
             </a:solidFill>
             <a:prstDash val="solid"/>
           </a:ln>
@@ -7540,7 +7540,7 @@
             <a:r>
               <a:rPr lang="en-US" sz="1000" dirty="0">
                 <a:solidFill>
-                  <a:srgbClr val="D0D6DC"/>
+                  <a:srgbClr val="4D4D4D"/>
                 </a:solidFill>
               </a:rPr>
               <a:t>Hold granted, 10 minutes</a:t>
@@ -7566,7 +7566,7 @@
           <a:noFill/>
           <a:ln w="15875">
             <a:solidFill>
-              <a:srgbClr val="9AA7B4"/>
+              <a:srgbClr val="6B7280"/>
             </a:solidFill>
             <a:prstDash val="dash"/>
             <a:headEnd type="triangle"/>
@@ -7588,11 +7588,11 @@
             <a:avLst/>
           </a:prstGeom>
           <a:solidFill>
-            <a:srgbClr val="00D6F2"/>
+            <a:srgbClr val="00A9C0"/>
           </a:solidFill>
           <a:ln w="12700">
             <a:solidFill>
-              <a:srgbClr val="00D6F2"/>
+              <a:srgbClr val="00A9C0"/>
             </a:solidFill>
             <a:prstDash val="solid"/>
           </a:ln>
@@ -7661,7 +7661,7 @@
             <a:r>
               <a:rPr lang="en-US" sz="1000" dirty="0">
                 <a:solidFill>
-                  <a:srgbClr val="D0D6DC"/>
+                  <a:srgbClr val="4D4D4D"/>
                 </a:solidFill>
               </a:rPr>
               <a:t>Your seat is held, pay now</a:t>
@@ -7687,7 +7687,7 @@
           <a:noFill/>
           <a:ln w="15875">
             <a:solidFill>
-              <a:srgbClr val="FFFFFF"/>
+              <a:srgbClr val="1A1A1A"/>
             </a:solidFill>
             <a:prstDash val="solid"/>
             <a:tailEnd type="triangle"/>
@@ -7709,11 +7709,11 @@
             <a:avLst/>
           </a:prstGeom>
           <a:solidFill>
-            <a:srgbClr val="00D6F2"/>
+            <a:srgbClr val="00A9C0"/>
           </a:solidFill>
           <a:ln w="12700">
             <a:solidFill>
-              <a:srgbClr val="00D6F2"/>
+              <a:srgbClr val="00A9C0"/>
             </a:solidFill>
             <a:prstDash val="solid"/>
           </a:ln>
@@ -7782,7 +7782,7 @@
             <a:r>
               <a:rPr lang="en-US" sz="1000" dirty="0">
                 <a:solidFill>
-                  <a:srgbClr val="FFFFFF"/>
+                  <a:srgbClr val="000000"/>
                 </a:solidFill>
               </a:rPr>
               <a:t>Pay on hosted page</a:t>
@@ -7808,7 +7808,7 @@
           <a:noFill/>
           <a:ln w="15875">
             <a:solidFill>
-              <a:srgbClr val="9AA7B4"/>
+              <a:srgbClr val="6B7280"/>
             </a:solidFill>
             <a:prstDash val="dash"/>
             <a:headEnd type="triangle"/>
@@ -7830,11 +7830,11 @@
             <a:avLst/>
           </a:prstGeom>
           <a:solidFill>
-            <a:srgbClr val="00D6F2"/>
+            <a:srgbClr val="00A9C0"/>
           </a:solidFill>
           <a:ln w="12700">
             <a:solidFill>
-              <a:srgbClr val="00D6F2"/>
+              <a:srgbClr val="00A9C0"/>
             </a:solidFill>
             <a:prstDash val="solid"/>
           </a:ln>
@@ -7903,7 +7903,7 @@
             <a:r>
               <a:rPr lang="en-US" sz="1000" dirty="0">
                 <a:solidFill>
-                  <a:srgbClr val="D0D6DC"/>
+                  <a:srgbClr val="4D4D4D"/>
                 </a:solidFill>
               </a:rPr>
               <a:t>Signed payment webhook</a:t>
@@ -7929,7 +7929,7 @@
           <a:noFill/>
           <a:ln w="15875">
             <a:solidFill>
-              <a:srgbClr val="FFFFFF"/>
+              <a:srgbClr val="1A1A1A"/>
             </a:solidFill>
             <a:prstDash val="solid"/>
             <a:tailEnd type="triangle"/>
@@ -7951,11 +7951,11 @@
             <a:avLst/>
           </a:prstGeom>
           <a:solidFill>
-            <a:srgbClr val="00D6F2"/>
+            <a:srgbClr val="00A9C0"/>
           </a:solidFill>
           <a:ln w="12700">
             <a:solidFill>
-              <a:srgbClr val="00D6F2"/>
+              <a:srgbClr val="00A9C0"/>
             </a:solidFill>
             <a:prstDash val="solid"/>
           </a:ln>
@@ -8024,7 +8024,7 @@
             <a:r>
               <a:rPr lang="en-US" sz="1000" dirty="0">
                 <a:solidFill>
-                  <a:srgbClr val="FFFFFF"/>
+                  <a:srgbClr val="000000"/>
                 </a:solidFill>
               </a:rPr>
               <a:t>Create registration (idempotent, via queue)</a:t>
@@ -8050,7 +8050,7 @@
           <a:noFill/>
           <a:ln w="15875">
             <a:solidFill>
-              <a:srgbClr val="FFFFFF"/>
+              <a:srgbClr val="1A1A1A"/>
             </a:solidFill>
             <a:prstDash val="solid"/>
             <a:tailEnd type="triangle"/>
@@ -8072,11 +8072,11 @@
             <a:avLst/>
           </a:prstGeom>
           <a:solidFill>
-            <a:srgbClr val="00D6F2"/>
+            <a:srgbClr val="00A9C0"/>
           </a:solidFill>
           <a:ln w="12700">
             <a:solidFill>
-              <a:srgbClr val="00D6F2"/>
+              <a:srgbClr val="00A9C0"/>
             </a:solidFill>
             <a:prstDash val="solid"/>
           </a:ln>
@@ -8145,7 +8145,7 @@
             <a:r>
               <a:rPr lang="en-US" sz="1000" dirty="0">
                 <a:solidFill>
-                  <a:srgbClr val="FFFFFF"/>
+                  <a:srgbClr val="000000"/>
                 </a:solidFill>
               </a:rPr>
               <a:t>Registration event</a:t>
@@ -8171,7 +8171,7 @@
           <a:noFill/>
           <a:ln w="15875">
             <a:solidFill>
-              <a:srgbClr val="9AA7B4"/>
+              <a:srgbClr val="6B7280"/>
             </a:solidFill>
             <a:prstDash val="dash"/>
             <a:headEnd type="triangle"/>
@@ -8193,11 +8193,11 @@
             <a:avLst/>
           </a:prstGeom>
           <a:solidFill>
-            <a:srgbClr val="00D6F2"/>
+            <a:srgbClr val="00A9C0"/>
           </a:solidFill>
           <a:ln w="12700">
             <a:solidFill>
-              <a:srgbClr val="00D6F2"/>
+              <a:srgbClr val="00A9C0"/>
             </a:solidFill>
             <a:prstDash val="solid"/>
           </a:ln>
@@ -8266,7 +8266,7 @@
             <a:r>
               <a:rPr lang="en-US" sz="1000" dirty="0">
                 <a:solidFill>
-                  <a:srgbClr val="D0D6DC"/>
+                  <a:srgbClr val="4D4D4D"/>
                 </a:solidFill>
               </a:rPr>
               <a:t>Confirmation, QR code, calendar invite</a:t>
@@ -8292,7 +8292,7 @@
           <a:noFill/>
           <a:ln w="12700">
             <a:solidFill>
-              <a:srgbClr val="8C8C8C"/>
+              <a:srgbClr val="9A9AA2"/>
             </a:solidFill>
             <a:prstDash val="dash"/>
           </a:ln>
@@ -8315,11 +8315,11 @@
             </a:avLst>
           </a:prstGeom>
           <a:solidFill>
-            <a:srgbClr val="2A2508"/>
+            <a:srgbClr val="FFF6CC"/>
           </a:solidFill>
           <a:ln w="12700">
             <a:solidFill>
-              <a:srgbClr val="FED700"/>
+              <a:srgbClr val="D9B200"/>
             </a:solidFill>
             <a:prstDash val="solid"/>
           </a:ln>
@@ -8352,7 +8352,7 @@
             <a:r>
               <a:rPr lang="en-US" sz="950" b="1" dirty="0">
                 <a:solidFill>
-                  <a:srgbClr val="FED700"/>
+                  <a:srgbClr val="6B5600"/>
                 </a:solidFill>
               </a:rPr>
               <a:t>If sold out</a:t>
@@ -8378,7 +8378,7 @@
           <a:noFill/>
           <a:ln w="15875">
             <a:solidFill>
-              <a:srgbClr val="9AA7B4"/>
+              <a:srgbClr val="6B7280"/>
             </a:solidFill>
             <a:prstDash val="dash"/>
             <a:headEnd type="triangle"/>
@@ -8400,11 +8400,11 @@
             <a:avLst/>
           </a:prstGeom>
           <a:solidFill>
-            <a:srgbClr val="00D6F2"/>
+            <a:srgbClr val="00A9C0"/>
           </a:solidFill>
           <a:ln w="12700">
             <a:solidFill>
-              <a:srgbClr val="00D6F2"/>
+              <a:srgbClr val="00A9C0"/>
             </a:solidFill>
             <a:prstDash val="solid"/>
           </a:ln>
@@ -8473,7 +8473,7 @@
             <a:r>
               <a:rPr lang="en-US" sz="1000" dirty="0">
                 <a:solidFill>
-                  <a:srgbClr val="D0D6DC"/>
+                  <a:srgbClr val="4D4D4D"/>
                 </a:solidFill>
               </a:rPr>
               <a:t>No seats left</a:t>
@@ -8499,7 +8499,7 @@
           <a:noFill/>
           <a:ln w="15875">
             <a:solidFill>
-              <a:srgbClr val="9AA7B4"/>
+              <a:srgbClr val="6B7280"/>
             </a:solidFill>
             <a:prstDash val="dash"/>
             <a:headEnd type="triangle"/>
@@ -8521,11 +8521,11 @@
             <a:avLst/>
           </a:prstGeom>
           <a:solidFill>
-            <a:srgbClr val="00D6F2"/>
+            <a:srgbClr val="00A9C0"/>
           </a:solidFill>
           <a:ln w="12700">
             <a:solidFill>
-              <a:srgbClr val="00D6F2"/>
+              <a:srgbClr val="00A9C0"/>
             </a:solidFill>
             <a:prstDash val="solid"/>
           </a:ln>
@@ -8594,7 +8594,7 @@
             <a:r>
               <a:rPr lang="en-US" sz="1000" dirty="0">
                 <a:solidFill>
-                  <a:srgbClr val="D0D6DC"/>
+                  <a:srgbClr val="4D4D4D"/>
                 </a:solidFill>
               </a:rPr>
               <a:t>Join waitlist or get notified of new dates</a:t>
@@ -8620,7 +8620,7 @@
           <a:noFill/>
           <a:ln w="15875">
             <a:solidFill>
-              <a:srgbClr val="FFFFFF"/>
+              <a:srgbClr val="1A1A1A"/>
             </a:solidFill>
             <a:prstDash val="solid"/>
             <a:tailEnd type="triangle"/>
@@ -8642,11 +8642,11 @@
             <a:avLst/>
           </a:prstGeom>
           <a:solidFill>
-            <a:srgbClr val="00D6F2"/>
+            <a:srgbClr val="00A9C0"/>
           </a:solidFill>
           <a:ln w="12700">
             <a:solidFill>
-              <a:srgbClr val="00D6F2"/>
+              <a:srgbClr val="00A9C0"/>
             </a:solidFill>
             <a:prstDash val="solid"/>
           </a:ln>
@@ -8715,7 +8715,7 @@
             <a:r>
               <a:rPr lang="en-US" sz="1000" dirty="0">
                 <a:solidFill>
-                  <a:srgbClr val="FFFFFF"/>
+                  <a:srgbClr val="000000"/>
                 </a:solidFill>
               </a:rPr>
               <a:t>Waitlist or interest record</a:t>
@@ -8740,7 +8740,7 @@
           </a:prstGeom>
           <a:ln w="12700">
             <a:solidFill>
-              <a:srgbClr val="8C8C8C"/>
+              <a:srgbClr val="9A9AA2"/>
             </a:solidFill>
             <a:prstDash val="dash"/>
           </a:ln>
@@ -8837,7 +8837,7 @@
             <a:lvl1pPr>
               <a:defRPr sz="900">
                 <a:solidFill>
-                  <a:schemeClr val="bg1"/>
+                  <a:schemeClr val="tx1"/>
                 </a:solidFill>
               </a:defRPr>
             </a:lvl1pPr>
@@ -10594,7 +10594,7 @@
             <a:r>
               <a:rPr lang="en-US" sz="3200" b="1" dirty="0">
                 <a:solidFill>
-                  <a:schemeClr val="bg1"/>
+                  <a:schemeClr val="tx1"/>
                 </a:solidFill>
               </a:rPr>
               <a:t>Design detail: payment sequence</a:t>
@@ -10620,11 +10620,11 @@
             </a:avLst>
           </a:prstGeom>
           <a:solidFill>
-            <a:srgbClr val="17171B"/>
+            <a:srgbClr val="F2F2F2"/>
           </a:solidFill>
           <a:ln w="15875">
             <a:solidFill>
-              <a:srgbClr val="6A6A75"/>
+              <a:srgbClr val="B8B8C0"/>
             </a:solidFill>
             <a:prstDash val="solid"/>
           </a:ln>
@@ -10657,7 +10657,7 @@
             <a:r>
               <a:rPr lang="en-US" sz="1050" b="1" dirty="0">
                 <a:solidFill>
-                  <a:srgbClr val="FFFFFF"/>
+                  <a:srgbClr val="000000"/>
                 </a:solidFill>
               </a:rPr>
               <a:t>Registrant (web or app)</a:t>
@@ -10683,7 +10683,7 @@
           <a:noFill/>
           <a:ln w="12700">
             <a:solidFill>
-              <a:srgbClr val="4A4A55"/>
+              <a:srgbClr val="B0B0B8"/>
             </a:solidFill>
             <a:prstDash val="dash"/>
           </a:ln>
@@ -10706,11 +10706,11 @@
             </a:avLst>
           </a:prstGeom>
           <a:solidFill>
-            <a:srgbClr val="17171B"/>
+            <a:srgbClr val="F2F2F2"/>
           </a:solidFill>
-          <a:ln w="15875">
+          <a:ln w="22225">
             <a:solidFill>
-              <a:srgbClr val="FED700"/>
+              <a:srgbClr val="D9B200"/>
             </a:solidFill>
             <a:prstDash val="solid"/>
           </a:ln>
@@ -10743,7 +10743,7 @@
             <a:r>
               <a:rPr lang="en-US" sz="1050" b="1" dirty="0">
                 <a:solidFill>
-                  <a:srgbClr val="FFFFFF"/>
+                  <a:srgbClr val="000000"/>
                 </a:solidFill>
               </a:rPr>
               <a:t>Registration service</a:t>
@@ -10769,7 +10769,7 @@
           <a:noFill/>
           <a:ln w="12700">
             <a:solidFill>
-              <a:srgbClr val="4A4A55"/>
+              <a:srgbClr val="B0B0B8"/>
             </a:solidFill>
             <a:prstDash val="dash"/>
           </a:ln>
@@ -10792,9 +10792,9 @@
             </a:avLst>
           </a:prstGeom>
           <a:solidFill>
-            <a:srgbClr val="17171B"/>
+            <a:srgbClr val="F2F2F2"/>
           </a:solidFill>
-          <a:ln w="15875">
+          <a:ln w="22225">
             <a:solidFill>
               <a:srgbClr val="FF0068"/>
             </a:solidFill>
@@ -10829,7 +10829,7 @@
             <a:r>
               <a:rPr lang="en-US" sz="1050" b="1" dirty="0">
                 <a:solidFill>
-                  <a:srgbClr val="FFFFFF"/>
+                  <a:srgbClr val="000000"/>
                 </a:solidFill>
               </a:rPr>
               <a:t>Gateway hosted page</a:t>
@@ -10855,7 +10855,7 @@
           <a:noFill/>
           <a:ln w="12700">
             <a:solidFill>
-              <a:srgbClr val="4A4A55"/>
+              <a:srgbClr val="B0B0B8"/>
             </a:solidFill>
             <a:prstDash val="dash"/>
           </a:ln>
@@ -10878,11 +10878,11 @@
             </a:avLst>
           </a:prstGeom>
           <a:solidFill>
-            <a:srgbClr val="17171B"/>
+            <a:srgbClr val="F2F2F2"/>
           </a:solidFill>
-          <a:ln w="15875">
+          <a:ln w="22225">
             <a:solidFill>
-              <a:srgbClr val="00D6F2"/>
+              <a:srgbClr val="00A9C0"/>
             </a:solidFill>
             <a:prstDash val="solid"/>
           </a:ln>
@@ -10915,7 +10915,7 @@
             <a:r>
               <a:rPr lang="en-US" sz="1050" b="1" dirty="0">
                 <a:solidFill>
-                  <a:srgbClr val="FFFFFF"/>
+                  <a:srgbClr val="000000"/>
                 </a:solidFill>
               </a:rPr>
               <a:t>Salesforce</a:t>
@@ -10941,7 +10941,7 @@
           <a:noFill/>
           <a:ln w="12700">
             <a:solidFill>
-              <a:srgbClr val="4A4A55"/>
+              <a:srgbClr val="B0B0B8"/>
             </a:solidFill>
             <a:prstDash val="dash"/>
           </a:ln>
@@ -10964,7 +10964,7 @@
           <a:noFill/>
           <a:ln w="15875">
             <a:solidFill>
-              <a:srgbClr val="FFFFFF"/>
+              <a:srgbClr val="1A1A1A"/>
             </a:solidFill>
             <a:prstDash val="solid"/>
             <a:tailEnd type="triangle"/>
@@ -10986,11 +10986,11 @@
             <a:avLst/>
           </a:prstGeom>
           <a:solidFill>
-            <a:srgbClr val="00D6F2"/>
+            <a:srgbClr val="00A9C0"/>
           </a:solidFill>
           <a:ln w="12700">
             <a:solidFill>
-              <a:srgbClr val="00D6F2"/>
+              <a:srgbClr val="00A9C0"/>
             </a:solidFill>
             <a:prstDash val="solid"/>
           </a:ln>
@@ -11059,7 +11059,7 @@
             <a:r>
               <a:rPr lang="en-US" sz="1000" dirty="0">
                 <a:solidFill>
-                  <a:srgbClr val="FFFFFF"/>
+                  <a:srgbClr val="000000"/>
                 </a:solidFill>
               </a:rPr>
               <a:t>Create payment session (amount, reference)</a:t>
@@ -11085,7 +11085,7 @@
           <a:noFill/>
           <a:ln w="15875">
             <a:solidFill>
-              <a:srgbClr val="9AA7B4"/>
+              <a:srgbClr val="6B7280"/>
             </a:solidFill>
             <a:prstDash val="dash"/>
             <a:headEnd type="triangle"/>
@@ -11107,11 +11107,11 @@
             <a:avLst/>
           </a:prstGeom>
           <a:solidFill>
-            <a:srgbClr val="00D6F2"/>
+            <a:srgbClr val="00A9C0"/>
           </a:solidFill>
           <a:ln w="12700">
             <a:solidFill>
-              <a:srgbClr val="00D6F2"/>
+              <a:srgbClr val="00A9C0"/>
             </a:solidFill>
             <a:prstDash val="solid"/>
           </a:ln>
@@ -11180,7 +11180,7 @@
             <a:r>
               <a:rPr lang="en-US" sz="1000" dirty="0">
                 <a:solidFill>
-                  <a:srgbClr val="D0D6DC"/>
+                  <a:srgbClr val="4D4D4D"/>
                 </a:solidFill>
               </a:rPr>
               <a:t>Session token</a:t>
@@ -11206,7 +11206,7 @@
           <a:noFill/>
           <a:ln w="15875">
             <a:solidFill>
-              <a:srgbClr val="9AA7B4"/>
+              <a:srgbClr val="6B7280"/>
             </a:solidFill>
             <a:prstDash val="dash"/>
             <a:headEnd type="triangle"/>
@@ -11228,11 +11228,11 @@
             <a:avLst/>
           </a:prstGeom>
           <a:solidFill>
-            <a:srgbClr val="00D6F2"/>
+            <a:srgbClr val="00A9C0"/>
           </a:solidFill>
           <a:ln w="12700">
             <a:solidFill>
-              <a:srgbClr val="00D6F2"/>
+              <a:srgbClr val="00A9C0"/>
             </a:solidFill>
             <a:prstDash val="solid"/>
           </a:ln>
@@ -11301,7 +11301,7 @@
             <a:r>
               <a:rPr lang="en-US" sz="1000" dirty="0">
                 <a:solidFill>
-                  <a:srgbClr val="D0D6DC"/>
+                  <a:srgbClr val="4D4D4D"/>
                 </a:solidFill>
               </a:rPr>
               <a:t>Open hosted payment page</a:t>
@@ -11327,7 +11327,7 @@
           <a:noFill/>
           <a:ln w="15875">
             <a:solidFill>
-              <a:srgbClr val="FFFFFF"/>
+              <a:srgbClr val="1A1A1A"/>
             </a:solidFill>
             <a:prstDash val="solid"/>
             <a:tailEnd type="triangle"/>
@@ -11349,11 +11349,11 @@
             <a:avLst/>
           </a:prstGeom>
           <a:solidFill>
-            <a:srgbClr val="00D6F2"/>
+            <a:srgbClr val="00A9C0"/>
           </a:solidFill>
           <a:ln w="12700">
             <a:solidFill>
-              <a:srgbClr val="00D6F2"/>
+              <a:srgbClr val="00A9C0"/>
             </a:solidFill>
             <a:prstDash val="solid"/>
           </a:ln>
@@ -11422,7 +11422,7 @@
             <a:r>
               <a:rPr lang="en-US" sz="1000" dirty="0">
                 <a:solidFill>
-                  <a:srgbClr val="FFFFFF"/>
+                  <a:srgbClr val="000000"/>
                 </a:solidFill>
               </a:rPr>
               <a:t>Card details typed into the gateway page</a:t>
@@ -11448,7 +11448,7 @@
           <a:noFill/>
           <a:ln w="15875">
             <a:solidFill>
-              <a:srgbClr val="9AA7B4"/>
+              <a:srgbClr val="6B7280"/>
             </a:solidFill>
             <a:prstDash val="dash"/>
             <a:headEnd type="triangle"/>
@@ -11470,11 +11470,11 @@
             <a:avLst/>
           </a:prstGeom>
           <a:solidFill>
-            <a:srgbClr val="00D6F2"/>
+            <a:srgbClr val="00A9C0"/>
           </a:solidFill>
           <a:ln w="12700">
             <a:solidFill>
-              <a:srgbClr val="00D6F2"/>
+              <a:srgbClr val="00A9C0"/>
             </a:solidFill>
             <a:prstDash val="solid"/>
           </a:ln>
@@ -11543,7 +11543,7 @@
             <a:r>
               <a:rPr lang="en-US" sz="1000" dirty="0">
                 <a:solidFill>
-                  <a:srgbClr val="D0D6DC"/>
+                  <a:srgbClr val="4D4D4D"/>
                 </a:solidFill>
               </a:rPr>
               <a:t>Approved</a:t>
@@ -11569,7 +11569,7 @@
           <a:noFill/>
           <a:ln w="15875">
             <a:solidFill>
-              <a:srgbClr val="FFFFFF"/>
+              <a:srgbClr val="1A1A1A"/>
             </a:solidFill>
             <a:prstDash val="solid"/>
             <a:headEnd type="triangle"/>
@@ -11591,11 +11591,11 @@
             <a:avLst/>
           </a:prstGeom>
           <a:solidFill>
-            <a:srgbClr val="00D6F2"/>
+            <a:srgbClr val="00A9C0"/>
           </a:solidFill>
           <a:ln w="12700">
             <a:solidFill>
-              <a:srgbClr val="00D6F2"/>
+              <a:srgbClr val="00A9C0"/>
             </a:solidFill>
             <a:prstDash val="solid"/>
           </a:ln>
@@ -11664,7 +11664,7 @@
             <a:r>
               <a:rPr lang="en-US" sz="1000" dirty="0">
                 <a:solidFill>
-                  <a:srgbClr val="FFFFFF"/>
+                  <a:srgbClr val="000000"/>
                 </a:solidFill>
               </a:rPr>
               <a:t>Signed webhook (token, last 4, approval code)</a:t>
@@ -11690,7 +11690,7 @@
           <a:noFill/>
           <a:ln w="15875">
             <a:solidFill>
-              <a:srgbClr val="FFFFFF"/>
+              <a:srgbClr val="1A1A1A"/>
             </a:solidFill>
             <a:prstDash val="solid"/>
           </a:ln>
@@ -11713,7 +11713,7 @@
           <a:noFill/>
           <a:ln w="15875">
             <a:solidFill>
-              <a:srgbClr val="FFFFFF"/>
+              <a:srgbClr val="1A1A1A"/>
             </a:solidFill>
             <a:prstDash val="solid"/>
           </a:ln>
@@ -11736,7 +11736,7 @@
           <a:noFill/>
           <a:ln w="15875">
             <a:solidFill>
-              <a:srgbClr val="FFFFFF"/>
+              <a:srgbClr val="1A1A1A"/>
             </a:solidFill>
             <a:prstDash val="solid"/>
             <a:headEnd type="triangle"/>
@@ -11758,11 +11758,11 @@
             <a:avLst/>
           </a:prstGeom>
           <a:solidFill>
-            <a:srgbClr val="00D6F2"/>
+            <a:srgbClr val="00A9C0"/>
           </a:solidFill>
           <a:ln w="12700">
             <a:solidFill>
-              <a:srgbClr val="00D6F2"/>
+              <a:srgbClr val="00A9C0"/>
             </a:solidFill>
             <a:prstDash val="solid"/>
           </a:ln>
@@ -11831,7 +11831,7 @@
             <a:r>
               <a:rPr lang="en-US" sz="1000" dirty="0">
                 <a:solidFill>
-                  <a:srgbClr val="FFFFFF"/>
+                  <a:srgbClr val="000000"/>
                 </a:solidFill>
               </a:rPr>
               <a:t>Verify signature, idempotency check</a:t>
@@ -11857,7 +11857,7 @@
           <a:noFill/>
           <a:ln w="15875">
             <a:solidFill>
-              <a:srgbClr val="FFFFFF"/>
+              <a:srgbClr val="1A1A1A"/>
             </a:solidFill>
             <a:prstDash val="solid"/>
             <a:tailEnd type="triangle"/>
@@ -11879,11 +11879,11 @@
             <a:avLst/>
           </a:prstGeom>
           <a:solidFill>
-            <a:srgbClr val="00D6F2"/>
+            <a:srgbClr val="00A9C0"/>
           </a:solidFill>
           <a:ln w="12700">
             <a:solidFill>
-              <a:srgbClr val="00D6F2"/>
+              <a:srgbClr val="00A9C0"/>
             </a:solidFill>
             <a:prstDash val="solid"/>
           </a:ln>
@@ -11952,7 +11952,7 @@
             <a:r>
               <a:rPr lang="en-US" sz="1000" dirty="0">
                 <a:solidFill>
-                  <a:srgbClr val="FFFFFF"/>
+                  <a:srgbClr val="000000"/>
                 </a:solidFill>
               </a:rPr>
               <a:t>Payment record: token, last 4, amount, status</a:t>
@@ -12049,7 +12049,7 @@
             <a:r>
               <a:rPr lang="en-US" sz="1600" b="1" dirty="0">
                 <a:solidFill>
-                  <a:schemeClr val="bg1"/>
+                  <a:schemeClr val="tx1"/>
                 </a:solidFill>
               </a:rPr>
               <a:t>Gateway choice</a:t>
@@ -12075,11 +12075,11 @@
             </a:avLst>
           </a:prstGeom>
           <a:solidFill>
-            <a:srgbClr val="17171B"/>
+            <a:srgbClr val="F2F2F2"/>
           </a:solidFill>
           <a:ln w="12700">
             <a:solidFill>
-              <a:srgbClr val="3A3A42"/>
+              <a:srgbClr val="D0D0D6"/>
             </a:solidFill>
             <a:prstDash val="solid"/>
           </a:ln>
@@ -12112,7 +12112,7 @@
             <a:r>
               <a:rPr lang="en-US" sz="900" b="1" spc="200" kern="0" dirty="0">
                 <a:solidFill>
-                  <a:srgbClr val="00D6F2"/>
+                  <a:srgbClr val="007C8C"/>
                 </a:solidFill>
               </a:rPr>
               <a:t>OPTION A</a:t>
@@ -12148,7 +12148,7 @@
             <a:r>
               <a:rPr lang="en-US" sz="1300" b="1" dirty="0">
                 <a:solidFill>
-                  <a:schemeClr val="bg1"/>
+                  <a:schemeClr val="tx1"/>
                 </a:solidFill>
               </a:rPr>
               <a:t>Keep both</a:t>
@@ -12184,7 +12184,7 @@
             <a:r>
               <a:rPr lang="en-US" sz="1100" dirty="0">
                 <a:solidFill>
-                  <a:srgbClr val="BFBFBF"/>
+                  <a:srgbClr val="4D4D4D"/>
                 </a:solidFill>
               </a:rPr>
               <a:t>Chase for classes, Authorize.net for conferences</a:t>
@@ -12210,11 +12210,11 @@
             </a:avLst>
           </a:prstGeom>
           <a:solidFill>
-            <a:srgbClr val="17171B"/>
+            <a:srgbClr val="F2F2F2"/>
           </a:solidFill>
           <a:ln w="12700">
             <a:solidFill>
-              <a:srgbClr val="3A3A42"/>
+              <a:srgbClr val="D0D0D6"/>
             </a:solidFill>
             <a:prstDash val="solid"/>
           </a:ln>
@@ -12247,7 +12247,7 @@
             <a:r>
               <a:rPr lang="en-US" sz="900" b="1" spc="200" kern="0" dirty="0">
                 <a:solidFill>
-                  <a:srgbClr val="FF0068"/>
+                  <a:srgbClr val="C8005A"/>
                 </a:solidFill>
               </a:rPr>
               <a:t>OPTION B</a:t>
@@ -12283,7 +12283,7 @@
             <a:r>
               <a:rPr lang="en-US" sz="1300" b="1" dirty="0">
                 <a:solidFill>
-                  <a:schemeClr val="bg1"/>
+                  <a:schemeClr val="tx1"/>
                 </a:solidFill>
               </a:rPr>
               <a:t>Consolidate on one</a:t>
@@ -12319,7 +12319,7 @@
             <a:r>
               <a:rPr lang="en-US" sz="1100" dirty="0">
                 <a:solidFill>
-                  <a:srgbClr val="BFBFBF"/>
+                  <a:srgbClr val="4D4D4D"/>
                 </a:solidFill>
               </a:rPr>
               <a:t>One gateway for every event; simpler reconciliation</a:t>
@@ -12355,7 +12355,7 @@
             <a:r>
               <a:rPr lang="en-US" sz="1600" b="1" dirty="0">
                 <a:solidFill>
-                  <a:schemeClr val="bg1"/>
+                  <a:schemeClr val="tx1"/>
                 </a:solidFill>
               </a:rPr>
               <a:t>After payment</a:t>
@@ -12395,7 +12395,7 @@
             <a:r>
               <a:rPr lang="en-US" sz="1200" dirty="0">
                 <a:solidFill>
-                  <a:srgbClr val="BFBFBF"/>
+                  <a:srgbClr val="4D4D4D"/>
                 </a:solidFill>
               </a:rPr>
               <a:t>Full and partial refunds by token from Salesforce</a:t>
@@ -12413,7 +12413,7 @@
             <a:r>
               <a:rPr lang="en-US" sz="1200" dirty="0">
                 <a:solidFill>
-                  <a:srgbClr val="BFBFBF"/>
+                  <a:srgbClr val="4D4D4D"/>
                 </a:solidFill>
               </a:rPr>
               <a:t>Automatic receipts</a:t>
@@ -12431,7 +12431,7 @@
             <a:r>
               <a:rPr lang="en-US" sz="1200" dirty="0">
                 <a:solidFill>
-                  <a:srgbClr val="BFBFBF"/>
+                  <a:srgbClr val="4D4D4D"/>
                 </a:solidFill>
               </a:rPr>
               <a:t>Daily settlement reconciliation</a:t>
@@ -12470,7 +12470,7 @@
             <a:lvl1pPr>
               <a:defRPr sz="900">
                 <a:solidFill>
-                  <a:schemeClr val="bg1"/>
+                  <a:schemeClr val="tx1"/>
                 </a:solidFill>
               </a:defRPr>
             </a:lvl1pPr>
@@ -24066,7 +24066,7 @@
             <a:r>
               <a:rPr lang="en-US" sz="3200" b="1" dirty="0">
                 <a:solidFill>
-                  <a:schemeClr val="bg1"/>
+                  <a:schemeClr val="tx1"/>
                 </a:solidFill>
               </a:rPr>
               <a:t>Overall solution design</a:t>
@@ -24102,7 +24102,7 @@
             <a:r>
               <a:rPr lang="en-US" sz="1400" dirty="0">
                 <a:solidFill>
-                  <a:srgbClr val="BFBFBF"/>
+                  <a:srgbClr val="4D4D4D"/>
                 </a:solidFill>
               </a:rPr>
               <a:t>One flow from sign-up to follow-up for classes and conferences, replacing the home-built class tool and Certain</a:t>
@@ -24128,11 +24128,11 @@
             </a:avLst>
           </a:prstGeom>
           <a:solidFill>
-            <a:srgbClr val="17171B"/>
+            <a:srgbClr val="F2F2F2"/>
           </a:solidFill>
           <a:ln w="15875">
             <a:solidFill>
-              <a:srgbClr val="6A6A75"/>
+              <a:srgbClr val="B8B8C0"/>
             </a:solidFill>
             <a:prstDash val="solid"/>
           </a:ln>
@@ -24165,7 +24165,7 @@
             <a:r>
               <a:rPr lang="en-US" sz="1050" b="1" dirty="0">
                 <a:solidFill>
-                  <a:srgbClr val="FFFFFF"/>
+                  <a:srgbClr val="000000"/>
                 </a:solidFill>
               </a:rPr>
               <a:t>Registrant</a:t>
@@ -24191,7 +24191,7 @@
           <a:noFill/>
           <a:ln w="12700">
             <a:solidFill>
-              <a:srgbClr val="4A4A55"/>
+              <a:srgbClr val="B0B0B8"/>
             </a:solidFill>
             <a:prstDash val="dash"/>
           </a:ln>
@@ -24214,11 +24214,11 @@
             </a:avLst>
           </a:prstGeom>
           <a:solidFill>
-            <a:srgbClr val="17171B"/>
+            <a:srgbClr val="F2F2F2"/>
           </a:solidFill>
-          <a:ln w="15875">
+          <a:ln w="22225">
             <a:solidFill>
-              <a:srgbClr val="00D6F2"/>
+              <a:srgbClr val="00A9C0"/>
             </a:solidFill>
             <a:prstDash val="solid"/>
           </a:ln>
@@ -24251,7 +24251,7 @@
             <a:r>
               <a:rPr lang="en-US" sz="1050" b="1" dirty="0">
                 <a:solidFill>
-                  <a:srgbClr val="FFFFFF"/>
+                  <a:srgbClr val="000000"/>
                 </a:solidFill>
               </a:rPr>
               <a:t>Website or My MH app</a:t>
@@ -24277,7 +24277,7 @@
           <a:noFill/>
           <a:ln w="12700">
             <a:solidFill>
-              <a:srgbClr val="4A4A55"/>
+              <a:srgbClr val="B0B0B8"/>
             </a:solidFill>
             <a:prstDash val="dash"/>
           </a:ln>
@@ -24300,11 +24300,11 @@
             </a:avLst>
           </a:prstGeom>
           <a:solidFill>
-            <a:srgbClr val="17171B"/>
+            <a:srgbClr val="F2F2F2"/>
           </a:solidFill>
-          <a:ln w="15875">
+          <a:ln w="22225">
             <a:solidFill>
-              <a:srgbClr val="FED700"/>
+              <a:srgbClr val="D9B200"/>
             </a:solidFill>
             <a:prstDash val="solid"/>
           </a:ln>
@@ -24337,7 +24337,7 @@
             <a:r>
               <a:rPr lang="en-US" sz="1050" b="1" dirty="0">
                 <a:solidFill>
-                  <a:srgbClr val="FFFFFF"/>
+                  <a:srgbClr val="000000"/>
                 </a:solidFill>
               </a:rPr>
               <a:t>Registration service</a:t>
@@ -24363,7 +24363,7 @@
           <a:noFill/>
           <a:ln w="12700">
             <a:solidFill>
-              <a:srgbClr val="4A4A55"/>
+              <a:srgbClr val="B0B0B8"/>
             </a:solidFill>
             <a:prstDash val="dash"/>
           </a:ln>
@@ -24386,11 +24386,11 @@
             </a:avLst>
           </a:prstGeom>
           <a:solidFill>
-            <a:srgbClr val="17171B"/>
+            <a:srgbClr val="F2F2F2"/>
           </a:solidFill>
           <a:ln w="15875">
             <a:solidFill>
-              <a:srgbClr val="6A6A75"/>
+              <a:srgbClr val="B8B8C0"/>
             </a:solidFill>
             <a:prstDash val="solid"/>
           </a:ln>
@@ -24423,7 +24423,7 @@
             <a:r>
               <a:rPr lang="en-US" sz="1050" b="1" dirty="0">
                 <a:solidFill>
-                  <a:srgbClr val="FFFFFF"/>
+                  <a:srgbClr val="000000"/>
                 </a:solidFill>
               </a:rPr>
               <a:t>Payment gateway</a:t>
@@ -24449,7 +24449,7 @@
           <a:noFill/>
           <a:ln w="12700">
             <a:solidFill>
-              <a:srgbClr val="4A4A55"/>
+              <a:srgbClr val="B0B0B8"/>
             </a:solidFill>
             <a:prstDash val="dash"/>
           </a:ln>
@@ -24472,11 +24472,11 @@
             </a:avLst>
           </a:prstGeom>
           <a:solidFill>
-            <a:srgbClr val="17171B"/>
+            <a:srgbClr val="F2F2F2"/>
           </a:solidFill>
-          <a:ln w="15875">
+          <a:ln w="22225">
             <a:solidFill>
-              <a:srgbClr val="00D6F2"/>
+              <a:srgbClr val="00A9C0"/>
             </a:solidFill>
             <a:prstDash val="solid"/>
           </a:ln>
@@ -24509,7 +24509,7 @@
             <a:r>
               <a:rPr lang="en-US" sz="1050" b="1" dirty="0">
                 <a:solidFill>
-                  <a:srgbClr val="FFFFFF"/>
+                  <a:srgbClr val="000000"/>
                 </a:solidFill>
               </a:rPr>
               <a:t>Salesforce event app</a:t>
@@ -24535,7 +24535,7 @@
           <a:noFill/>
           <a:ln w="12700">
             <a:solidFill>
-              <a:srgbClr val="4A4A55"/>
+              <a:srgbClr val="B0B0B8"/>
             </a:solidFill>
             <a:prstDash val="dash"/>
           </a:ln>
@@ -24558,9 +24558,9 @@
             </a:avLst>
           </a:prstGeom>
           <a:solidFill>
-            <a:srgbClr val="17171B"/>
+            <a:srgbClr val="F2F2F2"/>
           </a:solidFill>
-          <a:ln w="15875">
+          <a:ln w="22225">
             <a:solidFill>
               <a:srgbClr val="FF0068"/>
             </a:solidFill>
@@ -24595,7 +24595,7 @@
             <a:r>
               <a:rPr lang="en-US" sz="1050" b="1" dirty="0">
                 <a:solidFill>
-                  <a:srgbClr val="FFFFFF"/>
+                  <a:srgbClr val="000000"/>
                 </a:solidFill>
               </a:rPr>
               <a:t>Marketing Cloud</a:t>
@@ -24621,7 +24621,7 @@
           <a:noFill/>
           <a:ln w="12700">
             <a:solidFill>
-              <a:srgbClr val="4A4A55"/>
+              <a:srgbClr val="B0B0B8"/>
             </a:solidFill>
             <a:prstDash val="dash"/>
           </a:ln>
@@ -24644,11 +24644,11 @@
             </a:avLst>
           </a:prstGeom>
           <a:solidFill>
-            <a:srgbClr val="17171B"/>
+            <a:srgbClr val="F2F2F2"/>
           </a:solidFill>
           <a:ln w="15875">
             <a:solidFill>
-              <a:srgbClr val="6A6A75"/>
+              <a:srgbClr val="B8B8C0"/>
             </a:solidFill>
             <a:prstDash val="solid"/>
           </a:ln>
@@ -24681,7 +24681,7 @@
             <a:r>
               <a:rPr lang="en-US" sz="1050" b="1" dirty="0">
                 <a:solidFill>
-                  <a:srgbClr val="FFFFFF"/>
+                  <a:srgbClr val="000000"/>
                 </a:solidFill>
               </a:rPr>
               <a:t>Event staff</a:t>
@@ -24707,7 +24707,7 @@
           <a:noFill/>
           <a:ln w="12700">
             <a:solidFill>
-              <a:srgbClr val="4A4A55"/>
+              <a:srgbClr val="B0B0B8"/>
             </a:solidFill>
             <a:prstDash val="dash"/>
           </a:ln>
@@ -24740,7 +24740,7 @@
             <a:r>
               <a:rPr lang="en-US" sz="950" b="1" spc="200" kern="0" dirty="0">
                 <a:solidFill>
-                  <a:srgbClr val="00D6F2"/>
+                  <a:srgbClr val="007C8C"/>
                 </a:solidFill>
               </a:rPr>
               <a:t>REGISTER</a:t>
@@ -24766,7 +24766,7 @@
           <a:noFill/>
           <a:ln w="15875">
             <a:solidFill>
-              <a:srgbClr val="FFFFFF"/>
+              <a:srgbClr val="1A1A1A"/>
             </a:solidFill>
             <a:prstDash val="solid"/>
             <a:tailEnd type="triangle"/>
@@ -24788,11 +24788,11 @@
             <a:avLst/>
           </a:prstGeom>
           <a:solidFill>
-            <a:srgbClr val="00D6F2"/>
+            <a:srgbClr val="00A9C0"/>
           </a:solidFill>
           <a:ln w="12700">
             <a:solidFill>
-              <a:srgbClr val="00D6F2"/>
+              <a:srgbClr val="00A9C0"/>
             </a:solidFill>
             <a:prstDash val="solid"/>
           </a:ln>
@@ -24861,7 +24861,7 @@
             <a:r>
               <a:rPr lang="en-US" sz="1000" dirty="0">
                 <a:solidFill>
-                  <a:srgbClr val="FFFFFF"/>
+                  <a:srgbClr val="000000"/>
                 </a:solidFill>
               </a:rPr>
               <a:t>Find a class or conference</a:t>
@@ -24887,7 +24887,7 @@
           <a:noFill/>
           <a:ln w="15875">
             <a:solidFill>
-              <a:srgbClr val="FFFFFF"/>
+              <a:srgbClr val="1A1A1A"/>
             </a:solidFill>
             <a:prstDash val="solid"/>
             <a:tailEnd type="triangle"/>
@@ -24909,11 +24909,11 @@
             <a:avLst/>
           </a:prstGeom>
           <a:solidFill>
-            <a:srgbClr val="00D6F2"/>
+            <a:srgbClr val="00A9C0"/>
           </a:solidFill>
           <a:ln w="12700">
             <a:solidFill>
-              <a:srgbClr val="00D6F2"/>
+              <a:srgbClr val="00A9C0"/>
             </a:solidFill>
             <a:prstDash val="solid"/>
           </a:ln>
@@ -24982,7 +24982,7 @@
             <a:r>
               <a:rPr lang="en-US" sz="1000" dirty="0">
                 <a:solidFill>
-                  <a:srgbClr val="FFFFFF"/>
+                  <a:srgbClr val="000000"/>
                 </a:solidFill>
               </a:rPr>
               <a:t>Register and hold a seat</a:t>
@@ -25008,7 +25008,7 @@
           <a:noFill/>
           <a:ln w="15875">
             <a:solidFill>
-              <a:srgbClr val="9AA7B4"/>
+              <a:srgbClr val="6B7280"/>
             </a:solidFill>
             <a:prstDash val="dash"/>
             <a:headEnd type="triangle"/>
@@ -25030,11 +25030,11 @@
             <a:avLst/>
           </a:prstGeom>
           <a:solidFill>
-            <a:srgbClr val="00D6F2"/>
+            <a:srgbClr val="00A9C0"/>
           </a:solidFill>
           <a:ln w="12700">
             <a:solidFill>
-              <a:srgbClr val="00D6F2"/>
+              <a:srgbClr val="00A9C0"/>
             </a:solidFill>
             <a:prstDash val="solid"/>
           </a:ln>
@@ -25103,7 +25103,7 @@
             <a:r>
               <a:rPr lang="en-US" sz="1000" dirty="0">
                 <a:solidFill>
-                  <a:srgbClr val="D0D6DC"/>
+                  <a:srgbClr val="4D4D4D"/>
                 </a:solidFill>
               </a:rPr>
               <a:t>Seat held for 10 minutes</a:t>
@@ -25129,7 +25129,7 @@
           <a:noFill/>
           <a:ln w="9525">
             <a:solidFill>
-              <a:srgbClr val="33333B"/>
+              <a:srgbClr val="D4D4DA"/>
             </a:solidFill>
             <a:prstDash val="sysDot"/>
           </a:ln>
@@ -25162,7 +25162,7 @@
             <a:r>
               <a:rPr lang="en-US" sz="950" b="1" spc="200" kern="0" dirty="0">
                 <a:solidFill>
-                  <a:srgbClr val="00D6F2"/>
+                  <a:srgbClr val="007C8C"/>
                 </a:solidFill>
               </a:rPr>
               <a:t>PAY</a:t>
@@ -25188,7 +25188,7 @@
           <a:noFill/>
           <a:ln w="15875">
             <a:solidFill>
-              <a:srgbClr val="FFFFFF"/>
+              <a:srgbClr val="1A1A1A"/>
             </a:solidFill>
             <a:prstDash val="solid"/>
             <a:tailEnd type="triangle"/>
@@ -25210,11 +25210,11 @@
             <a:avLst/>
           </a:prstGeom>
           <a:solidFill>
-            <a:srgbClr val="00D6F2"/>
+            <a:srgbClr val="00A9C0"/>
           </a:solidFill>
           <a:ln w="12700">
             <a:solidFill>
-              <a:srgbClr val="00D6F2"/>
+              <a:srgbClr val="00A9C0"/>
             </a:solidFill>
             <a:prstDash val="solid"/>
           </a:ln>
@@ -25283,7 +25283,7 @@
             <a:r>
               <a:rPr lang="en-US" sz="1000" dirty="0">
                 <a:solidFill>
-                  <a:srgbClr val="FFFFFF"/>
+                  <a:srgbClr val="000000"/>
                 </a:solidFill>
               </a:rPr>
               <a:t>Pay on hosted page (free events skip this)</a:t>
@@ -25309,7 +25309,7 @@
           <a:noFill/>
           <a:ln w="15875">
             <a:solidFill>
-              <a:srgbClr val="9AA7B4"/>
+              <a:srgbClr val="6B7280"/>
             </a:solidFill>
             <a:prstDash val="dash"/>
             <a:headEnd type="triangle"/>
@@ -25331,11 +25331,11 @@
             <a:avLst/>
           </a:prstGeom>
           <a:solidFill>
-            <a:srgbClr val="00D6F2"/>
+            <a:srgbClr val="00A9C0"/>
           </a:solidFill>
           <a:ln w="12700">
             <a:solidFill>
-              <a:srgbClr val="00D6F2"/>
+              <a:srgbClr val="00A9C0"/>
             </a:solidFill>
             <a:prstDash val="solid"/>
           </a:ln>
@@ -25404,7 +25404,7 @@
             <a:r>
               <a:rPr lang="en-US" sz="1000" dirty="0">
                 <a:solidFill>
-                  <a:srgbClr val="D0D6DC"/>
+                  <a:srgbClr val="4D4D4D"/>
                 </a:solidFill>
               </a:rPr>
               <a:t>Signed webhook, token only</a:t>
@@ -25430,7 +25430,7 @@
           <a:noFill/>
           <a:ln w="15875">
             <a:solidFill>
-              <a:srgbClr val="FFFFFF"/>
+              <a:srgbClr val="1A1A1A"/>
             </a:solidFill>
             <a:prstDash val="solid"/>
             <a:tailEnd type="triangle"/>
@@ -25452,11 +25452,11 @@
             <a:avLst/>
           </a:prstGeom>
           <a:solidFill>
-            <a:srgbClr val="00D6F2"/>
+            <a:srgbClr val="00A9C0"/>
           </a:solidFill>
           <a:ln w="12700">
             <a:solidFill>
-              <a:srgbClr val="00D6F2"/>
+              <a:srgbClr val="00A9C0"/>
             </a:solidFill>
             <a:prstDash val="solid"/>
           </a:ln>
@@ -25525,7 +25525,7 @@
             <a:r>
               <a:rPr lang="en-US" sz="1000" dirty="0">
                 <a:solidFill>
-                  <a:srgbClr val="FFFFFF"/>
+                  <a:srgbClr val="000000"/>
                 </a:solidFill>
               </a:rPr>
               <a:t>Create registration (queued, idempotent)</a:t>
@@ -25551,7 +25551,7 @@
           <a:noFill/>
           <a:ln w="9525">
             <a:solidFill>
-              <a:srgbClr val="33333B"/>
+              <a:srgbClr val="D4D4DA"/>
             </a:solidFill>
             <a:prstDash val="sysDot"/>
           </a:ln>
@@ -25584,7 +25584,7 @@
             <a:r>
               <a:rPr lang="en-US" sz="950" b="1" spc="200" kern="0" dirty="0">
                 <a:solidFill>
-                  <a:srgbClr val="00D6F2"/>
+                  <a:srgbClr val="007C8C"/>
                 </a:solidFill>
               </a:rPr>
               <a:t>CONFIRM</a:t>
@@ -25610,7 +25610,7 @@
           <a:noFill/>
           <a:ln w="15875">
             <a:solidFill>
-              <a:srgbClr val="FFFFFF"/>
+              <a:srgbClr val="1A1A1A"/>
             </a:solidFill>
             <a:prstDash val="solid"/>
             <a:tailEnd type="triangle"/>
@@ -25632,11 +25632,11 @@
             <a:avLst/>
           </a:prstGeom>
           <a:solidFill>
-            <a:srgbClr val="00D6F2"/>
+            <a:srgbClr val="00A9C0"/>
           </a:solidFill>
           <a:ln w="12700">
             <a:solidFill>
-              <a:srgbClr val="00D6F2"/>
+              <a:srgbClr val="00A9C0"/>
             </a:solidFill>
             <a:prstDash val="solid"/>
           </a:ln>
@@ -25705,7 +25705,7 @@
             <a:r>
               <a:rPr lang="en-US" sz="1000" dirty="0">
                 <a:solidFill>
-                  <a:srgbClr val="FFFFFF"/>
+                  <a:srgbClr val="000000"/>
                 </a:solidFill>
               </a:rPr>
               <a:t>Registration event</a:t>
@@ -25731,7 +25731,7 @@
           <a:noFill/>
           <a:ln w="15875">
             <a:solidFill>
-              <a:srgbClr val="9AA7B4"/>
+              <a:srgbClr val="6B7280"/>
             </a:solidFill>
             <a:prstDash val="dash"/>
             <a:headEnd type="triangle"/>
@@ -25753,11 +25753,11 @@
             <a:avLst/>
           </a:prstGeom>
           <a:solidFill>
-            <a:srgbClr val="00D6F2"/>
+            <a:srgbClr val="00A9C0"/>
           </a:solidFill>
           <a:ln w="12700">
             <a:solidFill>
-              <a:srgbClr val="00D6F2"/>
+              <a:srgbClr val="00A9C0"/>
             </a:solidFill>
             <a:prstDash val="solid"/>
           </a:ln>
@@ -25826,7 +25826,7 @@
             <a:r>
               <a:rPr lang="en-US" sz="1000" dirty="0">
                 <a:solidFill>
-                  <a:srgbClr val="D0D6DC"/>
+                  <a:srgbClr val="4D4D4D"/>
                 </a:solidFill>
               </a:rPr>
               <a:t>Confirmation, QR code, calendar invite, reminders</a:t>
@@ -25852,7 +25852,7 @@
           <a:noFill/>
           <a:ln w="9525">
             <a:solidFill>
-              <a:srgbClr val="33333B"/>
+              <a:srgbClr val="D4D4DA"/>
             </a:solidFill>
             <a:prstDash val="sysDot"/>
           </a:ln>
@@ -25885,7 +25885,7 @@
             <a:r>
               <a:rPr lang="en-US" sz="950" b="1" spc="200" kern="0" dirty="0">
                 <a:solidFill>
-                  <a:srgbClr val="00D6F2"/>
+                  <a:srgbClr val="007C8C"/>
                 </a:solidFill>
               </a:rPr>
               <a:t>ATTEND</a:t>
@@ -25911,7 +25911,7 @@
           <a:noFill/>
           <a:ln w="15875">
             <a:solidFill>
-              <a:srgbClr val="FFFFFF"/>
+              <a:srgbClr val="1A1A1A"/>
             </a:solidFill>
             <a:prstDash val="solid"/>
             <a:headEnd type="triangle"/>
@@ -25933,11 +25933,11 @@
             <a:avLst/>
           </a:prstGeom>
           <a:solidFill>
-            <a:srgbClr val="00D6F2"/>
+            <a:srgbClr val="00A9C0"/>
           </a:solidFill>
           <a:ln w="12700">
             <a:solidFill>
-              <a:srgbClr val="00D6F2"/>
+              <a:srgbClr val="00A9C0"/>
             </a:solidFill>
             <a:prstDash val="solid"/>
           </a:ln>
@@ -26006,7 +26006,7 @@
             <a:r>
               <a:rPr lang="en-US" sz="1000" dirty="0">
                 <a:solidFill>
-                  <a:srgbClr val="FFFFFF"/>
+                  <a:srgbClr val="000000"/>
                 </a:solidFill>
               </a:rPr>
               <a:t>QR check-in at the door</a:t>
@@ -26032,7 +26032,7 @@
           <a:noFill/>
           <a:ln w="9525">
             <a:solidFill>
-              <a:srgbClr val="33333B"/>
+              <a:srgbClr val="D4D4DA"/>
             </a:solidFill>
             <a:prstDash val="sysDot"/>
           </a:ln>
@@ -26065,7 +26065,7 @@
             <a:r>
               <a:rPr lang="en-US" sz="950" b="1" spc="200" kern="0" dirty="0">
                 <a:solidFill>
-                  <a:srgbClr val="00D6F2"/>
+                  <a:srgbClr val="007C8C"/>
                 </a:solidFill>
               </a:rPr>
               <a:t>ENGAGE</a:t>
@@ -26091,7 +26091,7 @@
           <a:noFill/>
           <a:ln w="15875">
             <a:solidFill>
-              <a:srgbClr val="FFFFFF"/>
+              <a:srgbClr val="1A1A1A"/>
             </a:solidFill>
             <a:prstDash val="solid"/>
             <a:tailEnd type="triangle"/>
@@ -26113,11 +26113,11 @@
             <a:avLst/>
           </a:prstGeom>
           <a:solidFill>
-            <a:srgbClr val="00D6F2"/>
+            <a:srgbClr val="00A9C0"/>
           </a:solidFill>
           <a:ln w="12700">
             <a:solidFill>
-              <a:srgbClr val="00D6F2"/>
+              <a:srgbClr val="00A9C0"/>
             </a:solidFill>
             <a:prstDash val="solid"/>
           </a:ln>
@@ -26186,7 +26186,7 @@
             <a:r>
               <a:rPr lang="en-US" sz="1000" dirty="0">
                 <a:solidFill>
-                  <a:srgbClr val="FFFFFF"/>
+                  <a:srgbClr val="000000"/>
                 </a:solidFill>
               </a:rPr>
               <a:t>Attendance and interests</a:t>
@@ -26212,7 +26212,7 @@
           <a:noFill/>
           <a:ln w="15875">
             <a:solidFill>
-              <a:srgbClr val="9AA7B4"/>
+              <a:srgbClr val="6B7280"/>
             </a:solidFill>
             <a:prstDash val="dash"/>
             <a:headEnd type="triangle"/>
@@ -26234,11 +26234,11 @@
             <a:avLst/>
           </a:prstGeom>
           <a:solidFill>
-            <a:srgbClr val="00D6F2"/>
+            <a:srgbClr val="00A9C0"/>
           </a:solidFill>
           <a:ln w="12700">
             <a:solidFill>
-              <a:srgbClr val="00D6F2"/>
+              <a:srgbClr val="00A9C0"/>
             </a:solidFill>
             <a:prstDash val="solid"/>
           </a:ln>
@@ -26307,7 +26307,7 @@
             <a:r>
               <a:rPr lang="en-US" sz="1000" dirty="0">
                 <a:solidFill>
-                  <a:srgbClr val="D0D6DC"/>
+                  <a:srgbClr val="4D4D4D"/>
                 </a:solidFill>
               </a:rPr>
               <a:t>PEIs: thank you, next class, app, find a doctor</a:t>
@@ -26333,7 +26333,7 @@
           <a:noFill/>
           <a:ln w="9525">
             <a:solidFill>
-              <a:srgbClr val="33333B"/>
+              <a:srgbClr val="D4D4DA"/>
             </a:solidFill>
             <a:prstDash val="sysDot"/>
           </a:ln>
@@ -26366,7 +26366,7 @@
             <a:r>
               <a:rPr lang="en-US" sz="950" b="1" spc="200" kern="0" dirty="0">
                 <a:solidFill>
-                  <a:srgbClr val="00D6F2"/>
+                  <a:srgbClr val="007C8C"/>
                 </a:solidFill>
               </a:rPr>
               <a:t>GROW</a:t>
@@ -26392,7 +26392,7 @@
           <a:noFill/>
           <a:ln w="15875">
             <a:solidFill>
-              <a:srgbClr val="9AA7B4"/>
+              <a:srgbClr val="6B7280"/>
             </a:solidFill>
             <a:prstDash val="dash"/>
             <a:tailEnd type="triangle"/>
@@ -26414,11 +26414,11 @@
             <a:avLst/>
           </a:prstGeom>
           <a:solidFill>
-            <a:srgbClr val="00D6F2"/>
+            <a:srgbClr val="00A9C0"/>
           </a:solidFill>
           <a:ln w="12700">
             <a:solidFill>
-              <a:srgbClr val="00D6F2"/>
+              <a:srgbClr val="00A9C0"/>
             </a:solidFill>
             <a:prstDash val="solid"/>
           </a:ln>
@@ -26487,7 +26487,7 @@
             <a:r>
               <a:rPr lang="en-US" sz="1000" dirty="0">
                 <a:solidFill>
-                  <a:srgbClr val="D0D6DC"/>
+                  <a:srgbClr val="4D4D4D"/>
                 </a:solidFill>
               </a:rPr>
               <a:t>Dashboards, waitlist and demand alerts</a:t>
@@ -26513,7 +26513,7 @@
           <a:noFill/>
           <a:ln w="15875">
             <a:solidFill>
-              <a:srgbClr val="FFFFFF"/>
+              <a:srgbClr val="1A1A1A"/>
             </a:solidFill>
             <a:prstDash val="solid"/>
             <a:headEnd type="triangle"/>
@@ -26535,11 +26535,11 @@
             <a:avLst/>
           </a:prstGeom>
           <a:solidFill>
-            <a:srgbClr val="00D6F2"/>
+            <a:srgbClr val="00A9C0"/>
           </a:solidFill>
           <a:ln w="12700">
             <a:solidFill>
-              <a:srgbClr val="00D6F2"/>
+              <a:srgbClr val="00A9C0"/>
             </a:solidFill>
             <a:prstDash val="solid"/>
           </a:ln>
@@ -26608,7 +26608,7 @@
             <a:r>
               <a:rPr lang="en-US" sz="1000" dirty="0">
                 <a:solidFill>
-                  <a:srgbClr val="FFFFFF"/>
+                  <a:srgbClr val="000000"/>
                 </a:solidFill>
               </a:rPr>
               <a:t>Add a session in one click</a:t>
@@ -26644,7 +26644,7 @@
             <a:r>
               <a:rPr lang="en-US" sz="1050" i="1" dirty="0">
                 <a:solidFill>
-                  <a:srgbClr val="BFBFBF"/>
+                  <a:srgbClr val="4D4D4D"/>
                 </a:solidFill>
               </a:rPr>
               <a:t>Conferences follow the same flow, adding sessions, speakers and My Agenda.</a:t>
@@ -26683,7 +26683,7 @@
             <a:lvl1pPr>
               <a:defRPr sz="900">
                 <a:solidFill>
-                  <a:schemeClr val="bg1"/>
+                  <a:schemeClr val="tx1"/>
                 </a:solidFill>
               </a:defRPr>
             </a:lvl1pPr>

</xml_diff>

<commit_message>
Label investment pricing as offshore delivery model
Co-Authored-By: Claude Opus 5.5 <noreply@anthropic.com>
Claude-Session: https://claude.ai/code/session_0161UfSgfoLg2WkzVi8freAH
</commit_message>
<xml_diff>
--- a/deck/Memorial-Hermann-Event-Platform.pptx
+++ b/deck/Memorial-Hermann-Event-Platform.pptx
@@ -134,14 +134,14 @@
   <p:extLst>
     <p:ext uri="{521415D9-36F7-43E2-AB2F-B90AF26B5E84}">
       <p14:sectionLst xmlns:p14="http://schemas.microsoft.com/office/powerpoint/2010/main">
-        <p14:section name="Introduction" id="{e5909832-393b-3af4-1ef7-43717ca90a29}">
+        <p14:section name="Introduction" id="{eaf5635d-731e-7883-4d8d-bbb5810a3003}">
           <p14:sldIdLst>
             <p14:sldId id="256"/>
             <p14:sldId id="257"/>
             <p14:sldId id="258"/>
           </p14:sldIdLst>
         </p14:section>
-        <p14:section name="The solution" id="{fbb8bfb6-d0be-4db6-742a-05f1e18ae36f}">
+        <p14:section name="The solution" id="{bf8c86fc-9b10-ca76-e03b-71aa6b5e72de}">
           <p14:sldIdLst>
             <p14:sldId id="259"/>
             <p14:sldId id="260"/>
@@ -155,7 +155,7 @@
             <p14:sldId id="268"/>
           </p14:sldIdLst>
         </p14:section>
-        <p14:section name="Delivery plan" id="{1e5c8ccb-6add-cb30-c3c0-915daac8a8ef}">
+        <p14:section name="Delivery plan" id="{51f72b25-c970-d400-8190-2e172d7426e5}">
           <p14:sldIdLst>
             <p14:sldId id="269"/>
             <p14:sldId id="270"/>
@@ -163,7 +163,7 @@
             <p14:sldId id="272"/>
           </p14:sldIdLst>
         </p14:section>
-        <p14:section name="Beyond the event" id="{a2bc7cd9-6cd3-4cce-c500-ff4b6d9b2bdc}">
+        <p14:section name="Beyond the event" id="{16fc056a-5311-f0df-8bd3-b817afb66541}">
           <p14:sldIdLst>
             <p14:sldId id="273"/>
             <p14:sldId id="274"/>
@@ -173,7 +173,7 @@
             <p14:sldId id="278"/>
           </p14:sldIdLst>
         </p14:section>
-        <p14:section name="Roadmap and next steps" id="{a3722bb0-38d1-ff6a-b39e-e56c0afea35d}">
+        <p14:section name="Roadmap and next steps" id="{83443c80-e417-425d-cadc-5272790311cb}">
           <p14:sldIdLst>
             <p14:sldId id="279"/>
             <p14:sldId id="280"/>
@@ -2170,7 +2170,7 @@
           <a:p>
             <a:r>
               <a:rPr lang="en-US" dirty="0"/>
-              <a:t>Standard program value is $700,000. As a strategic partner, Memorial Hermann receives a 50% partnership credit applied upfront, for an investment of $350,000. Billing follows sprint milestones. Licenses and third-party fees are outside this price.</a:t>
+              <a:t>Pricing is for an offshore delivery model. Standard program value is $700,000. As a strategic partner, Memorial Hermann receives a 50% partnership credit applied upfront, for an investment of $350,000. Billing follows sprint milestones. Licenses and third-party fees are outside this price.</a:t>
             </a:r>
             <a:endParaRPr lang="en-US" dirty="0"/>
           </a:p>
@@ -24522,7 +24522,7 @@
                   <a:srgbClr val="4D4D4D"/>
                 </a:solidFill>
               </a:rPr>
-              <a:t>Fixed-scope delivery by the five-person pod across 12 sprints</a:t>
+              <a:t>Offshore delivery model: fixed scope, five-person pod, 12 sprints</a:t>
             </a:r>
             <a:endParaRPr lang="en-US" sz="1400" dirty="0"/>
           </a:p>
@@ -24557,14 +24557,74 @@
       </p:sp>
       <p:sp>
         <p:nvSpPr>
-          <p:cNvPr id="5" name="Text 3"/>
+          <p:cNvPr id="5" name="Shape 3"/>
+          <p:cNvSpPr/>
+          <p:nvPr/>
+        </p:nvSpPr>
+        <p:spPr>
+          <a:xfrm>
+            <a:off x="3291840" y="2057400"/>
+            <a:ext cx="1097280" cy="292608"/>
+          </a:xfrm>
+          <a:prstGeom prst="roundRect">
+            <a:avLst>
+              <a:gd name="adj" fmla="val 50000"/>
+            </a:avLst>
+          </a:prstGeom>
+          <a:ln w="15875">
+            <a:solidFill>
+              <a:srgbClr val="00D6F2"/>
+            </a:solidFill>
+            <a:prstDash val="solid"/>
+          </a:ln>
+        </p:spPr>
+      </p:sp>
+      <p:sp>
+        <p:nvSpPr>
+          <p:cNvPr id="6" name="Text 4"/>
+          <p:cNvSpPr txBox="1"/>
+          <p:nvPr/>
+        </p:nvSpPr>
+        <p:spPr>
+          <a:xfrm>
+            <a:off x="3291840" y="2057400"/>
+            <a:ext cx="1097280" cy="292608"/>
+          </a:xfrm>
+          <a:prstGeom prst="rect">
+            <a:avLst/>
+          </a:prstGeom>
+          <a:noFill/>
+          <a:ln/>
+        </p:spPr>
+        <p:txBody>
+          <a:bodyPr wrap="square" lIns="0" tIns="0" rIns="0" bIns="0" rtlCol="0" anchor="ctr"/>
+          <a:lstStyle/>
+          <a:p>
+            <a:pPr algn="ctr" indent="0" marL="0">
+              <a:buNone/>
+            </a:pPr>
+            <a:r>
+              <a:rPr lang="en-US" sz="950" b="1" spc="200" kern="0" dirty="0">
+                <a:solidFill>
+                  <a:srgbClr val="00D6F2"/>
+                </a:solidFill>
+              </a:rPr>
+              <a:t>OFFSHORE</a:t>
+            </a:r>
+            <a:endParaRPr lang="en-US" sz="950" dirty="0"/>
+          </a:p>
+        </p:txBody>
+      </p:sp>
+      <p:sp>
+        <p:nvSpPr>
+          <p:cNvPr id="7" name="Text 5"/>
           <p:cNvSpPr txBox="1"/>
           <p:nvPr/>
         </p:nvSpPr>
         <p:spPr>
           <a:xfrm>
             <a:off x="822960" y="2103120"/>
-            <a:ext cx="3566160" cy="219456"/>
+            <a:ext cx="2377440" cy="219456"/>
           </a:xfrm>
           <a:prstGeom prst="rect">
             <a:avLst/>
@@ -24593,7 +24653,7 @@
       </p:sp>
       <p:sp>
         <p:nvSpPr>
-          <p:cNvPr id="6" name="Text 4"/>
+          <p:cNvPr id="8" name="Text 6"/>
           <p:cNvSpPr txBox="1"/>
           <p:nvPr/>
         </p:nvSpPr>
@@ -24632,7 +24692,7 @@
       </p:sp>
       <p:sp>
         <p:nvSpPr>
-          <p:cNvPr id="7" name="Shape 5"/>
+          <p:cNvPr id="9" name="Shape 7"/>
           <p:cNvSpPr/>
           <p:nvPr/>
         </p:nvSpPr>
@@ -24655,7 +24715,7 @@
       </p:sp>
       <p:sp>
         <p:nvSpPr>
-          <p:cNvPr id="8" name="Text 6"/>
+          <p:cNvPr id="10" name="Text 8"/>
           <p:cNvSpPr txBox="1"/>
           <p:nvPr/>
         </p:nvSpPr>
@@ -24691,7 +24751,7 @@
       </p:sp>
       <p:sp>
         <p:nvSpPr>
-          <p:cNvPr id="9" name="Text 7"/>
+          <p:cNvPr id="11" name="Text 9"/>
           <p:cNvSpPr txBox="1"/>
           <p:nvPr/>
         </p:nvSpPr>
@@ -24730,7 +24790,7 @@
       </p:sp>
       <p:sp>
         <p:nvSpPr>
-          <p:cNvPr id="10" name="Shape 8"/>
+          <p:cNvPr id="12" name="Shape 10"/>
           <p:cNvSpPr/>
           <p:nvPr/>
         </p:nvSpPr>
@@ -24757,7 +24817,7 @@
       </p:sp>
       <p:sp>
         <p:nvSpPr>
-          <p:cNvPr id="11" name="Text 9"/>
+          <p:cNvPr id="13" name="Text 11"/>
           <p:cNvSpPr txBox="1"/>
           <p:nvPr/>
         </p:nvSpPr>
@@ -24793,7 +24853,7 @@
       </p:sp>
       <p:sp>
         <p:nvSpPr>
-          <p:cNvPr id="12" name="Text 10"/>
+          <p:cNvPr id="14" name="Text 12"/>
           <p:cNvSpPr txBox="1"/>
           <p:nvPr/>
         </p:nvSpPr>
@@ -24829,7 +24889,7 @@
       </p:sp>
       <p:sp>
         <p:nvSpPr>
-          <p:cNvPr id="13" name="Text 11"/>
+          <p:cNvPr id="15" name="Text 13"/>
           <p:cNvSpPr txBox="1"/>
           <p:nvPr/>
         </p:nvSpPr>
@@ -24865,7 +24925,7 @@
       </p:sp>
       <p:sp>
         <p:nvSpPr>
-          <p:cNvPr id="14" name="Text 12"/>
+          <p:cNvPr id="16" name="Text 14"/>
           <p:cNvSpPr txBox="1"/>
           <p:nvPr/>
         </p:nvSpPr>
@@ -24901,7 +24961,7 @@
       </p:sp>
       <p:sp>
         <p:nvSpPr>
-          <p:cNvPr id="15" name="Text 13"/>
+          <p:cNvPr id="17" name="Text 15"/>
           <p:cNvSpPr txBox="1"/>
           <p:nvPr/>
         </p:nvSpPr>
@@ -24937,7 +24997,7 @@
       </p:sp>
       <p:sp>
         <p:nvSpPr>
-          <p:cNvPr id="16" name="Text 14"/>
+          <p:cNvPr id="18" name="Text 16"/>
           <p:cNvSpPr txBox="1"/>
           <p:nvPr/>
         </p:nvSpPr>
@@ -24973,7 +25033,7 @@
       </p:sp>
       <p:sp>
         <p:nvSpPr>
-          <p:cNvPr id="17" name="Shape 15"/>
+          <p:cNvPr id="19" name="Shape 17"/>
           <p:cNvSpPr/>
           <p:nvPr/>
         </p:nvSpPr>
@@ -24996,7 +25056,7 @@
       </p:sp>
       <p:sp>
         <p:nvSpPr>
-          <p:cNvPr id="18" name="Text 16"/>
+          <p:cNvPr id="20" name="Text 18"/>
           <p:cNvSpPr txBox="1"/>
           <p:nvPr/>
         </p:nvSpPr>
@@ -25032,7 +25092,7 @@
       </p:sp>
       <p:sp>
         <p:nvSpPr>
-          <p:cNvPr id="19" name="Text 17"/>
+          <p:cNvPr id="21" name="Text 19"/>
           <p:cNvSpPr txBox="1"/>
           <p:nvPr/>
         </p:nvSpPr>
@@ -25068,7 +25128,7 @@
       </p:sp>
       <p:sp>
         <p:nvSpPr>
-          <p:cNvPr id="20" name="Text 18"/>
+          <p:cNvPr id="22" name="Text 20"/>
           <p:cNvSpPr txBox="1"/>
           <p:nvPr/>
         </p:nvSpPr>
@@ -25104,7 +25164,7 @@
       </p:sp>
       <p:sp>
         <p:nvSpPr>
-          <p:cNvPr id="21" name="Text 19"/>
+          <p:cNvPr id="23" name="Text 21"/>
           <p:cNvSpPr txBox="1"/>
           <p:nvPr/>
         </p:nvSpPr>
@@ -25140,7 +25200,7 @@
       </p:sp>
       <p:sp>
         <p:nvSpPr>
-          <p:cNvPr id="22" name="Shape 20"/>
+          <p:cNvPr id="24" name="Shape 22"/>
           <p:cNvSpPr/>
           <p:nvPr/>
         </p:nvSpPr>
@@ -25163,7 +25223,7 @@
       </p:sp>
       <p:sp>
         <p:nvSpPr>
-          <p:cNvPr id="23" name="Text 21"/>
+          <p:cNvPr id="25" name="Text 23"/>
           <p:cNvSpPr txBox="1"/>
           <p:nvPr/>
         </p:nvSpPr>
@@ -25199,7 +25259,7 @@
       </p:sp>
       <p:sp>
         <p:nvSpPr>
-          <p:cNvPr id="24" name="Text 22"/>
+          <p:cNvPr id="26" name="Text 24"/>
           <p:cNvSpPr txBox="1"/>
           <p:nvPr/>
         </p:nvSpPr>
@@ -25235,7 +25295,7 @@
       </p:sp>
       <p:sp>
         <p:nvSpPr>
-          <p:cNvPr id="25" name="Text 23"/>
+          <p:cNvPr id="27" name="Text 25"/>
           <p:cNvSpPr txBox="1"/>
           <p:nvPr/>
         </p:nvSpPr>
@@ -25271,7 +25331,7 @@
       </p:sp>
       <p:sp>
         <p:nvSpPr>
-          <p:cNvPr id="26" name="Text 24"/>
+          <p:cNvPr id="28" name="Text 26"/>
           <p:cNvSpPr txBox="1"/>
           <p:nvPr/>
         </p:nvSpPr>
@@ -25307,7 +25367,7 @@
       </p:sp>
       <p:sp>
         <p:nvSpPr>
-          <p:cNvPr id="27" name="Shape 25"/>
+          <p:cNvPr id="29" name="Shape 27"/>
           <p:cNvSpPr/>
           <p:nvPr/>
         </p:nvSpPr>
@@ -25330,7 +25390,7 @@
       </p:sp>
       <p:sp>
         <p:nvSpPr>
-          <p:cNvPr id="28" name="Text 26"/>
+          <p:cNvPr id="30" name="Text 28"/>
           <p:cNvSpPr txBox="1"/>
           <p:nvPr/>
         </p:nvSpPr>
@@ -25366,7 +25426,7 @@
       </p:sp>
       <p:sp>
         <p:nvSpPr>
-          <p:cNvPr id="29" name="Text 27"/>
+          <p:cNvPr id="31" name="Text 29"/>
           <p:cNvSpPr txBox="1"/>
           <p:nvPr/>
         </p:nvSpPr>
@@ -25402,7 +25462,7 @@
       </p:sp>
       <p:sp>
         <p:nvSpPr>
-          <p:cNvPr id="30" name="Text 28"/>
+          <p:cNvPr id="32" name="Text 30"/>
           <p:cNvSpPr txBox="1"/>
           <p:nvPr/>
         </p:nvSpPr>
@@ -25438,7 +25498,7 @@
       </p:sp>
       <p:sp>
         <p:nvSpPr>
-          <p:cNvPr id="31" name="Text 29"/>
+          <p:cNvPr id="33" name="Text 31"/>
           <p:cNvSpPr txBox="1"/>
           <p:nvPr/>
         </p:nvSpPr>
@@ -25474,7 +25534,7 @@
       </p:sp>
       <p:sp>
         <p:nvSpPr>
-          <p:cNvPr id="32" name="Shape 30"/>
+          <p:cNvPr id="34" name="Shape 32"/>
           <p:cNvSpPr/>
           <p:nvPr/>
         </p:nvSpPr>
@@ -25497,7 +25557,7 @@
       </p:sp>
       <p:sp>
         <p:nvSpPr>
-          <p:cNvPr id="33" name="Text 31"/>
+          <p:cNvPr id="35" name="Text 33"/>
           <p:cNvSpPr txBox="1"/>
           <p:nvPr/>
         </p:nvSpPr>
@@ -25533,7 +25593,7 @@
       </p:sp>
       <p:sp>
         <p:nvSpPr>
-          <p:cNvPr id="34" name="Text 32"/>
+          <p:cNvPr id="36" name="Text 34"/>
           <p:cNvSpPr txBox="1"/>
           <p:nvPr/>
         </p:nvSpPr>
@@ -25565,7 +25625,7 @@
                   <a:srgbClr val="4D4D4D"/>
                 </a:solidFill>
               </a:rPr>
-              <a:t>Dedicated five-person pod for 24 weeks</a:t>
+              <a:t>Dedicated five-person offshore pod for 24 weeks</a:t>
             </a:r>
             <a:endParaRPr lang="en-US" sz="1100" dirty="0"/>
           </a:p>
@@ -25627,7 +25687,7 @@
       </p:sp>
       <p:sp>
         <p:nvSpPr>
-          <p:cNvPr id="35" name="Text 33"/>
+          <p:cNvPr id="37" name="Text 35"/>
           <p:cNvSpPr txBox="1"/>
           <p:nvPr/>
         </p:nvSpPr>
@@ -25663,7 +25723,7 @@
       </p:sp>
       <p:sp>
         <p:nvSpPr>
-          <p:cNvPr id="36" name="Text 34"/>
+          <p:cNvPr id="38" name="Text 36"/>
           <p:cNvSpPr txBox="1"/>
           <p:nvPr/>
         </p:nvSpPr>
@@ -25739,7 +25799,7 @@
       </p:sp>
       <p:sp>
         <p:nvSpPr>
-          <p:cNvPr id="37" name="Text 35"/>
+          <p:cNvPr id="39" name="Text 37"/>
           <p:cNvSpPr txBox="1"/>
           <p:nvPr/>
         </p:nvSpPr>
@@ -25767,7 +25827,7 @@
                   <a:srgbClr val="4D4D4D"/>
                 </a:solidFill>
               </a:rPr>
-              <a:t>Indicative pricing, billed at sprint milestones. Final commercials confirmed in the statement of work.</a:t>
+              <a:t>Pricing is for an offshore delivery model. Indicative, billed at sprint milestones; final commercials in the statement of work.</a:t>
             </a:r>
             <a:endParaRPr lang="en-US" sz="1050" dirty="0"/>
           </a:p>

</xml_diff>

<commit_message>
Use Chase for conference payments; Authorize.net retires with Certain
Co-Authored-By: Claude Opus 5.5 <noreply@anthropic.com>
Claude-Session: https://claude.ai/code/session_0161UfSgfoLg2WkzVi8freAH
</commit_message>
<xml_diff>
--- a/deck/Memorial-Hermann-Event-Platform.pptx
+++ b/deck/Memorial-Hermann-Event-Platform.pptx
@@ -136,7 +136,7 @@
   <p:extLst>
     <p:ext uri="{521415D9-36F7-43E2-AB2F-B90AF26B5E84}">
       <p14:sectionLst xmlns:p14="http://schemas.microsoft.com/office/powerpoint/2010/main">
-        <p14:section name="Introduction" id="{fbb4496a-eec3-5181-8e33-d1476773826a}">
+        <p14:section name="Introduction" id="{315e093c-7043-2a2f-11bf-a59eee0b1279}">
           <p14:sldIdLst>
             <p14:sldId id="256"/>
             <p14:sldId id="257"/>
@@ -144,7 +144,7 @@
             <p14:sldId id="259"/>
           </p14:sldIdLst>
         </p14:section>
-        <p14:section name="The solution" id="{ad431845-7781-8488-c729-19a0d12c0e26}">
+        <p14:section name="The solution" id="{0484e59e-844c-b001-6910-f13519f8623b}">
           <p14:sldIdLst>
             <p14:sldId id="260"/>
             <p14:sldId id="261"/>
@@ -158,7 +158,7 @@
             <p14:sldId id="269"/>
           </p14:sldIdLst>
         </p14:section>
-        <p14:section name="Delivery plan" id="{e6266f6b-dc0f-0fc5-bd11-ed63df1745c6}">
+        <p14:section name="Delivery plan" id="{7a80dea8-34de-49c3-1419-7aa0d7396058}">
           <p14:sldIdLst>
             <p14:sldId id="270"/>
             <p14:sldId id="271"/>
@@ -167,7 +167,7 @@
             <p14:sldId id="274"/>
           </p14:sldIdLst>
         </p14:section>
-        <p14:section name="Beyond the event" id="{88ed536f-ead7-d7f6-a586-5d84670c3365}">
+        <p14:section name="Beyond the event" id="{c9fe2cc7-291f-3154-f854-83035a51c62d}">
           <p14:sldIdLst>
             <p14:sldId id="275"/>
             <p14:sldId id="276"/>
@@ -177,7 +177,7 @@
             <p14:sldId id="280"/>
           </p14:sldIdLst>
         </p14:section>
-        <p14:section name="Roadmap and next steps" id="{779c2214-9497-706a-636d-12e32194e549}">
+        <p14:section name="Roadmap and next steps" id="{679fb597-e2b9-1921-cde8-72d2cb43e506}">
           <p14:sldIdLst>
             <p14:sldId id="281"/>
             <p14:sldId id="282"/>
@@ -1030,7 +1030,7 @@
           <a:p>
             <a:r>
               <a:rPr lang="en-US" dirty="0"/>
-              <a:t>The card is typed directly into the gateway page; the registration service only creates the session and receives a signed webhook with a token. Salesforce stores the token reference, last 4 digits, amount and status. Gateway choice is Memorial Hermann finance's decision; both are supported.</a:t>
+              <a:t>The card is typed directly into the gateway page; the registration service only creates the session and receives a signed webhook with a token. Salesforce stores the token reference, last 4 digits, amount and status. Chase already takes class payments in Salesforce, so conferences reuse that integration and Authorize.net retires with Certain: one gateway, one reconciliation. Merchant setup for conference fees to confirm with Memorial Hermann finance.</a:t>
             </a:r>
             <a:endParaRPr lang="en-US" dirty="0"/>
           </a:p>
@@ -9886,7 +9886,7 @@
                   <a:schemeClr val="tx1"/>
                 </a:solidFill>
               </a:rPr>
-              <a:t>Gateway hosted page</a:t>
+              <a:t>Chase hosted page</a:t>
             </a:r>
             <a:endParaRPr lang="en-US" sz="1200" dirty="0"/>
           </a:p>
@@ -9922,7 +9922,7 @@
                   <a:srgbClr val="4D4D4D"/>
                 </a:solidFill>
               </a:rPr>
-              <a:t>Card typed here (Chase or Authorize.net)</a:t>
+              <a:t>Card typed here (Chase, as for classes today)</a:t>
             </a:r>
             <a:endParaRPr lang="en-US" sz="1050" dirty="0"/>
           </a:p>
@@ -11515,7 +11515,7 @@
                   <a:srgbClr val="000000"/>
                 </a:solidFill>
               </a:rPr>
-              <a:t>Gateway hosted page</a:t>
+              <a:t>Chase hosted page</a:t>
             </a:r>
             <a:endParaRPr lang="en-US" sz="1050" dirty="0"/>
           </a:p>
@@ -12108,7 +12108,7 @@
                   <a:srgbClr val="000000"/>
                 </a:solidFill>
               </a:rPr>
-              <a:t>Card details typed into the gateway page</a:t>
+              <a:t>Card details typed into the Chase page</a:t>
             </a:r>
             <a:endParaRPr lang="en-US" sz="1000" dirty="0"/>
           </a:p>
@@ -12735,7 +12735,7 @@
                   <a:schemeClr val="tx1"/>
                 </a:solidFill>
               </a:rPr>
-              <a:t>Gateway choice</a:t>
+              <a:t>One gateway: Chase</a:t>
             </a:r>
             <a:endParaRPr lang="en-US" sz="1600" dirty="0"/>
           </a:p>
@@ -12798,7 +12798,7 @@
                   <a:srgbClr val="007C8C"/>
                 </a:solidFill>
               </a:rPr>
-              <a:t>OPTION A</a:t>
+              <a:t>RECOMMENDED</a:t>
             </a:r>
             <a:endParaRPr lang="en-US" sz="900" dirty="0"/>
           </a:p>
@@ -12834,7 +12834,7 @@
                   <a:schemeClr val="tx1"/>
                 </a:solidFill>
               </a:rPr>
-              <a:t>Keep both</a:t>
+              <a:t>Chase for every event</a:t>
             </a:r>
             <a:endParaRPr lang="en-US" sz="1300" dirty="0"/>
           </a:p>
@@ -12870,7 +12870,7 @@
                   <a:srgbClr val="4D4D4D"/>
                 </a:solidFill>
               </a:rPr>
-              <a:t>Chase for classes, Authorize.net for conferences</a:t>
+              <a:t>Reuse today’s class integration; Authorize.net retires with Certain</a:t>
             </a:r>
             <a:endParaRPr lang="en-US" sz="1100" dirty="0"/>
           </a:p>
@@ -12933,7 +12933,7 @@
                   <a:srgbClr val="C8005A"/>
                 </a:solidFill>
               </a:rPr>
-              <a:t>OPTION B</a:t>
+              <a:t>TO CONFIRM</a:t>
             </a:r>
             <a:endParaRPr lang="en-US" sz="900" dirty="0"/>
           </a:p>
@@ -12969,7 +12969,7 @@
                   <a:schemeClr val="tx1"/>
                 </a:solidFill>
               </a:rPr>
-              <a:t>Consolidate on one</a:t>
+              <a:t>Finance sign-off</a:t>
             </a:r>
             <a:endParaRPr lang="en-US" sz="1300" dirty="0"/>
           </a:p>
@@ -13005,7 +13005,7 @@
                   <a:srgbClr val="4D4D4D"/>
                 </a:solidFill>
               </a:rPr>
-              <a:t>One gateway for every event; simpler reconciliation</a:t>
+              <a:t>Chase merchant setup for conference fees [to confirm]</a:t>
             </a:r>
             <a:endParaRPr lang="en-US" sz="1100" dirty="0"/>
           </a:p>
@@ -14483,7 +14483,7 @@
                   <a:srgbClr val="4D4D4D"/>
                 </a:solidFill>
               </a:rPr>
-              <a:t>Authorize.net checkout, or one consolidated gateway</a:t>
+              <a:t>Chase checkout, reusing today’s class integration</a:t>
             </a:r>
             <a:endParaRPr lang="en-US" sz="1300" dirty="0"/>
           </a:p>
@@ -16252,7 +16252,7 @@
                   <a:srgbClr val="000000"/>
                 </a:solidFill>
               </a:rPr>
-              <a:t>Authorize.net checkout; badges; CME [to confirm]</a:t>
+              <a:t>Chase checkout for conferences; badges; CME [to confirm]</a:t>
             </a:r>
             <a:endParaRPr lang="en-US" sz="1100" dirty="0"/>
           </a:p>
@@ -27633,7 +27633,7 @@
                 <a:ea typeface="Trenda IG Text Light" pitchFamily="34" charset="-122"/>
                 <a:cs typeface="Trenda IG Text Light" pitchFamily="34" charset="-120"/>
               </a:rPr>
-              <a:t>Agree the payment approach: keep both gateways or consolidate</a:t>
+              <a:t>Confirm Chase for conference payments with finance</a:t>
             </a:r>
             <a:endParaRPr lang="en-US" sz="2000" dirty="0"/>
           </a:p>
@@ -28106,7 +28106,7 @@
                   <a:srgbClr val="D9D9D9"/>
                 </a:solidFill>
               </a:rPr>
-              <a:t>1 to 2 multi-day conferences a year, with session management, for providers, caregivers and consumers. Authorize.net today.</a:t>
+              <a:t>1 to 2 multi-day conferences a year, with session management, for providers, caregivers and consumers. Authorize.net today, moving to Chase.</a:t>
             </a:r>
             <a:endParaRPr lang="en-US" sz="1150" dirty="0"/>
           </a:p>
@@ -28381,7 +28381,7 @@
                   <a:srgbClr val="4D4D4D"/>
                 </a:solidFill>
               </a:rPr>
-              <a:t>Replace with Salesforce conference and session management</a:t>
+              <a:t>Replace with Salesforce conference and session management, paid through Chase</a:t>
             </a:r>
             <a:endParaRPr lang="en-US" sz="1250" dirty="0"/>
           </a:p>
@@ -29123,6 +29123,24 @@
                   <a:schemeClr val="tx1"/>
                 </a:solidFill>
               </a:rPr>
+              <a:t>Chase payments, now for conferences too</a:t>
+            </a:r>
+            <a:endParaRPr lang="en-US" sz="1300" dirty="0"/>
+          </a:p>
+          <a:p>
+            <a:pPr marL="342900" indent="-342900">
+              <a:spcAft>
+                <a:spcPts val="600"/>
+              </a:spcAft>
+              <a:buSzPct val="100000"/>
+              <a:buChar char="•"/>
+            </a:pPr>
+            <a:r>
+              <a:rPr lang="en-US" sz="1300" dirty="0">
+                <a:solidFill>
+                  <a:schemeClr val="tx1"/>
+                </a:solidFill>
+              </a:rPr>
               <a:t>Health Cloud and Marketing Cloud</a:t>
             </a:r>
             <a:endParaRPr lang="en-US" sz="1300" dirty="0"/>
@@ -29437,7 +29455,7 @@
                   <a:srgbClr val="FFFFFF"/>
                 </a:solidFill>
               </a:rPr>
-              <a:t>Authorize.net checkout inside the platform</a:t>
+              <a:t>Authorize.net, by reusing today’s Chase checkout</a:t>
             </a:r>
             <a:endParaRPr lang="en-US" sz="1300" dirty="0"/>
           </a:p>
@@ -30682,7 +30700,7 @@
                   <a:schemeClr val="bg1"/>
                 </a:solidFill>
               </a:rPr>
-              <a:t>Authorize.net</a:t>
+              <a:t>Experience Cloud</a:t>
             </a:r>
             <a:endParaRPr lang="en-US" sz="1300" dirty="0"/>
           </a:p>
@@ -31423,7 +31441,7 @@
                   <a:srgbClr val="000000"/>
                 </a:solidFill>
               </a:rPr>
-              <a:t>Payment gateway</a:t>
+              <a:t>Chase payment page</a:t>
             </a:r>
             <a:endParaRPr lang="en-US" sz="1050" dirty="0"/>
           </a:p>

</xml_diff>

<commit_message>
25-week plan with a 4-person pod; Certain transition in weeks 15-20
Co-Authored-By: Claude Opus 5.5 <noreply@anthropic.com>
Claude-Session: https://claude.ai/code/session_0161UfSgfoLg2WkzVi8freAH
</commit_message>
<xml_diff>
--- a/deck/Memorial-Hermann-Event-Platform.pptx
+++ b/deck/Memorial-Hermann-Event-Platform.pptx
@@ -137,7 +137,7 @@
   <p:extLst>
     <p:ext uri="{521415D9-36F7-43E2-AB2F-B90AF26B5E84}">
       <p14:sectionLst xmlns:p14="http://schemas.microsoft.com/office/powerpoint/2010/main">
-        <p14:section name="Introduction" id="{551ab69c-f523-ab43-1314-64c5ee58bb67}">
+        <p14:section name="Introduction" id="{2dcde034-44b1-21bb-306d-c9503d229d35}">
           <p14:sldIdLst>
             <p14:sldId id="256"/>
             <p14:sldId id="257"/>
@@ -145,7 +145,7 @@
             <p14:sldId id="259"/>
           </p14:sldIdLst>
         </p14:section>
-        <p14:section name="The solution" id="{80043d34-d962-5e6f-8ed9-0d180cf5b73a}">
+        <p14:section name="The solution" id="{d50c6d02-b9a3-2d26-d88d-f0cae36dc129}">
           <p14:sldIdLst>
             <p14:sldId id="260"/>
             <p14:sldId id="261"/>
@@ -159,7 +159,7 @@
             <p14:sldId id="269"/>
           </p14:sldIdLst>
         </p14:section>
-        <p14:section name="Delivery plan" id="{8b710d8c-14d9-8083-2b06-7bc6c3b0963c}">
+        <p14:section name="Delivery plan" id="{021d73d1-7677-0cee-5ff9-4a7cbab26dd3}">
           <p14:sldIdLst>
             <p14:sldId id="270"/>
             <p14:sldId id="271"/>
@@ -169,7 +169,7 @@
             <p14:sldId id="275"/>
           </p14:sldIdLst>
         </p14:section>
-        <p14:section name="Beyond the event" id="{eb628ef6-54bb-964d-01d4-4181fb5099eb}">
+        <p14:section name="Beyond the event" id="{bd8fae05-568e-9a2a-154f-c099bb1c23c4}">
           <p14:sldIdLst>
             <p14:sldId id="276"/>
             <p14:sldId id="277"/>
@@ -179,7 +179,7 @@
             <p14:sldId id="281"/>
           </p14:sldIdLst>
         </p14:section>
-        <p14:section name="Roadmap and next steps" id="{a2de19f8-e917-9def-9b29-218b4a4a2e69}">
+        <p14:section name="Roadmap and next steps" id="{851b9796-4ddd-9e18-4cea-389a1ddf7263}">
           <p14:sldIdLst>
             <p14:sldId id="282"/>
             <p14:sldId id="283"/>
@@ -1208,7 +1208,7 @@
           <a:p>
             <a:r>
               <a:rPr lang="en-US" dirty="0"/>
-              <a:t>Phase 1 replaces Certain around week 12, with a six-week Certain to Salesforce data transition in weeks 7 to 12; cutover is planned between conferences and before the Certain renewal. Phase 2 brings classes onto the same platform and improves them by week 20, without rebuilding the registration site. Engagement work can start once classes are on the shared model.</a:t>
+              <a:t>Phase 1 replaces Certain around week 20, with a six-week Certain to Salesforce data transition in weeks 15 to 20; cutover is planned between conferences and before the Certain renewal. Phase 2 brings classes onto the same platform and improves them by week 25, without rebuilding the registration site. Engagement work can start once classes are on the shared model.</a:t>
             </a:r>
             <a:endParaRPr lang="en-US" dirty="0"/>
           </a:p>
@@ -1384,7 +1384,7 @@
           <a:p>
             <a:r>
               <a:rPr lang="en-US" dirty="0"/>
-              <a:t>Data migration from Certain is planned as its own six-week workstream inside Phase 1 (weeks 7 to 12), so conferences go live on Salesforce with their data. A sample Certain export is reviewed in Sprint 1 so the event model fits Certain’s data; every record keeps its Certain ID. Two trial loads run with emails and journeys switched off and are reconciled before the final load. Cutover is planned between conferences so only history moves; if a conference is open, its registrations move with new QR codes and a welcome email. How many years of history to bring across is Memorial Hermann’s decision, agreed in discovery; older history can stay in an archive export. Card data is never migrated: payment history moves as a summary marked Authorize.net, and Authorize.net stays open only until refunds on past payments are done. For Phase 2 the shared model extends today’s class objects where possible, so classes need no second migration.</a:t>
+              <a:t>Data migration from Certain is planned as its own six-week workstream at the end of Phase 1 (weeks 15 to 20), so conferences go live on Salesforce with their data. A sample Certain export is reviewed in Sprint 1 so the event model fits Certain’s data; every record keeps its Certain ID. Two trial loads run with emails and journeys switched off and are reconciled before the final load. Cutover is planned between conferences so only history moves; if a conference is open, its registrations move with new QR codes and a welcome email. How many years of history to bring across is Memorial Hermann’s decision, agreed in discovery; older history can stay in an archive export. Card data is never migrated: payment history moves as a summary marked Authorize.net, and Authorize.net stays open only until refunds on past payments are done. For Phase 2 the shared model extends today’s class objects where possible, so classes need no second migration.</a:t>
             </a:r>
             <a:endParaRPr lang="en-US" dirty="0"/>
           </a:p>
@@ -1472,7 +1472,7 @@
           <a:p>
             <a:r>
               <a:rPr lang="en-US" dirty="0"/>
-              <a:t>Two-week sprints, each closing with a demo and a milestone Memorial Hermann signs off. Sprint 1 assesses today’s Experience Cloud site, app and Certain. Sprints 2 to 6 deliver conference and session management (live at week 12, Certain retired), with the six-week Certain to Salesforce data transition running in weeks 7 to 12. Sprints 7 to 10 move classes onto the same platform and improve them (live at week 20). Sprint scope is refined after the current-state walkthrough.</a:t>
+              <a:t>Two-week sprints, each closing with a demo and a milestone Memorial Hermann signs off. Sprint 1 assesses today’s Experience Cloud site, app and Certain. Sprints 2 to 10 deliver conference and session management (live at week 20, Certain retired), with the six-week Certain to Salesforce data transition in weeks 15 to 20. Sprints 11 and 12 move classes onto the same platform and improve them, with go-live and handover in week 25. Sprint scope is refined after the current-state walkthrough.</a:t>
             </a:r>
             <a:endParaRPr lang="en-US" dirty="0"/>
           </a:p>
@@ -1648,7 +1648,7 @@
           <a:p>
             <a:r>
               <a:rPr lang="en-US" dirty="0"/>
-              <a:t>A small, dedicated pod: one Scrum Master or Project Manager leading delivery, one QA engineer embedded in every sprint, and a build team of two Salesforce developers and one Marketing Cloud developer. Memorial Hermann provides a product owner and an Epic and app contact.</a:t>
+              <a:t>A small, dedicated pod: one Project Manager leading delivery and running the sprints, one QA engineer embedded in every sprint, and two developers covering Salesforce and Marketing Cloud. Memorial Hermann provides a product owner and an Epic and app contact.</a:t>
             </a:r>
             <a:endParaRPr lang="en-US" dirty="0"/>
           </a:p>
@@ -2440,7 +2440,7 @@
           <a:p>
             <a:r>
               <a:rPr lang="en-US" dirty="0"/>
-              <a:t>Pricing is for an offshore delivery model. Standard program value is $580,000. As a strategic partner, Memorial Hermann receives a 50% partnership credit applied upfront, for an investment of $290,000. Billing follows sprint milestones. Licenses and third-party fees are outside this price.</a:t>
+              <a:t>Pricing is for an offshore delivery model. Standard program value is $580,000: a four-person pod for 25 weeks (Phase 1 weeks 1 to 20, $464,000; Phase 2 weeks 21 to 25, $116,000). As a strategic partner, Memorial Hermann receives a 50% partnership credit applied upfront, for an investment of $290,000. Billing follows sprint milestones. Licenses and third-party fees are outside this price.</a:t>
             </a:r>
             <a:endParaRPr lang="en-US" dirty="0"/>
           </a:p>
@@ -13208,7 +13208,7 @@
                   <a:schemeClr val="bg1"/>
                 </a:solidFill>
               </a:rPr>
-              <a:t>Ten sprints: conferences live at week 12, classes improved by week 20</a:t>
+              <a:t>Twelve sprints: conferences live at week 20, classes improved by week 25</a:t>
             </a:r>
             <a:endParaRPr lang="en-US" sz="1800" dirty="0"/>
           </a:p>
@@ -13559,7 +13559,7 @@
                   <a:schemeClr val="bg1"/>
                 </a:solidFill>
               </a:rPr>
-              <a:t>Weeks 3-12  ·  Phase 1 live</a:t>
+              <a:t>Weeks 3-20  ·  Phase 1 live</a:t>
             </a:r>
             <a:endParaRPr lang="en-US" sz="1300" dirty="0"/>
           </a:p>
@@ -13679,7 +13679,7 @@
                   <a:schemeClr val="bg1"/>
                 </a:solidFill>
               </a:rPr>
-              <a:t>Weeks 13-20  ·  Phase 2 live</a:t>
+              <a:t>Weeks 21-25  ·  Phase 2 live</a:t>
             </a:r>
             <a:endParaRPr lang="en-US" sz="1300" dirty="0"/>
           </a:p>
@@ -13799,7 +13799,7 @@
                   <a:schemeClr val="bg1"/>
                 </a:solidFill>
               </a:rPr>
-              <a:t>Week 21+  ·  Grow</a:t>
+              <a:t>Week 26+  ·  Grow</a:t>
             </a:r>
             <a:endParaRPr lang="en-US" sz="1300" dirty="0"/>
           </a:p>
@@ -13874,8 +13874,8 @@
         </p:nvSpPr>
         <p:spPr>
           <a:xfrm>
-            <a:off x="4654296" y="3529584"/>
-            <a:ext cx="1591056" cy="164592"/>
+            <a:off x="5410200" y="3529584"/>
+            <a:ext cx="835152" cy="164592"/>
           </a:xfrm>
           <a:prstGeom prst="roundRect">
             <a:avLst>
@@ -13901,7 +13901,7 @@
         </p:nvSpPr>
         <p:spPr>
           <a:xfrm>
-            <a:off x="4654296" y="3840480"/>
+            <a:off x="4526280" y="3840480"/>
             <a:ext cx="1691640" cy="292608"/>
           </a:xfrm>
           <a:prstGeom prst="rect">
@@ -13937,7 +13937,7 @@
         </p:nvSpPr>
         <p:spPr>
           <a:xfrm>
-            <a:off x="4654296" y="4206240"/>
+            <a:off x="4526280" y="4206240"/>
             <a:ext cx="1600200" cy="822960"/>
           </a:xfrm>
           <a:prstGeom prst="rect">
@@ -13959,7 +13959,7 @@
                   <a:schemeClr val="bg1"/>
                 </a:solidFill>
               </a:rPr>
-              <a:t>Weeks 7-12: export, map, two trial loads, cutover between conferences</a:t>
+              <a:t>Weeks 15-20: export, map, two trial loads, cutover between conferences</a:t>
             </a:r>
             <a:endParaRPr lang="en-US" sz="1100" dirty="0"/>
           </a:p>
@@ -14786,7 +14786,7 @@
                   <a:srgbClr val="4D4D4D"/>
                 </a:solidFill>
               </a:rPr>
-              <a:t>Certain data moved in a six-week transition (weeks 7-12)</a:t>
+              <a:t>Certain data moved in a six-week transition (weeks 15-20)</a:t>
             </a:r>
             <a:endParaRPr lang="en-US" sz="1300" dirty="0"/>
           </a:p>
@@ -15251,7 +15251,7 @@
                   <a:srgbClr val="4D4D4D"/>
                 </a:solidFill>
               </a:rPr>
-              <a:t>Six weeks (weeks 7 to 12) alongside Phase 1, with cutover planned between conferences. Certain stays live until sign-off.</a:t>
+              <a:t>Six weeks (weeks 15 to 20) at the end of Phase 1, with cutover planned between conferences. Certain stays live until sign-off.</a:t>
             </a:r>
             <a:endParaRPr lang="en-US" sz="1400" dirty="0"/>
           </a:p>
@@ -15314,7 +15314,7 @@
                   <a:srgbClr val="45289F"/>
                 </a:solidFill>
               </a:rPr>
-              <a:t>1  ·  WEEKS 7-8</a:t>
+              <a:t>1  ·  WEEKS 15-16</a:t>
             </a:r>
             <a:endParaRPr lang="en-US" sz="1000" dirty="0"/>
           </a:p>
@@ -15449,7 +15449,7 @@
                   <a:srgbClr val="45289F"/>
                 </a:solidFill>
               </a:rPr>
-              <a:t>2  ·  WEEKS 7-8</a:t>
+              <a:t>2  ·  WEEKS 15-16</a:t>
             </a:r>
             <a:endParaRPr lang="en-US" sz="1000" dirty="0"/>
           </a:p>
@@ -15584,7 +15584,7 @@
                   <a:srgbClr val="45289F"/>
                 </a:solidFill>
               </a:rPr>
-              <a:t>3  ·  WEEKS 9-10</a:t>
+              <a:t>3  ·  WEEKS 17-18</a:t>
             </a:r>
             <a:endParaRPr lang="en-US" sz="1000" dirty="0"/>
           </a:p>
@@ -15719,7 +15719,7 @@
                   <a:srgbClr val="FF0068"/>
                 </a:solidFill>
               </a:rPr>
-              <a:t>4  ·  WEEKS 11-12</a:t>
+              <a:t>4  ·  WEEKS 19-20</a:t>
             </a:r>
             <a:endParaRPr lang="en-US" sz="1000" dirty="0"/>
           </a:p>
@@ -15854,7 +15854,7 @@
                   <a:srgbClr val="45289F"/>
                 </a:solidFill>
               </a:rPr>
-              <a:t>5  ·  WEEK 12+</a:t>
+              <a:t>5  ·  WEEK 20+</a:t>
             </a:r>
             <a:endParaRPr lang="en-US" sz="1000" dirty="0"/>
           </a:p>
@@ -16766,7 +16766,7 @@
                   <a:srgbClr val="4D4D4D"/>
                 </a:solidFill>
               </a:rPr>
-              <a:t>Delivered by the same five-person pod</a:t>
+              <a:t>Delivered by the same four-person pod</a:t>
             </a:r>
             <a:endParaRPr lang="en-US" sz="1150" dirty="0"/>
           </a:p>
@@ -16874,7 +16874,7 @@
                   <a:schemeClr val="tx1"/>
                 </a:solidFill>
               </a:rPr>
-              <a:t>Delivery plan: 10 two-week sprints</a:t>
+              <a:t>Delivery plan: 12 two-week sprints and a go-live week</a:t>
             </a:r>
             <a:endParaRPr lang="en-US" sz="3200" dirty="0"/>
           </a:p>
@@ -17238,11 +17238,11 @@
         <p:spPr>
           <a:xfrm>
             <a:off x="502920" y="2103120"/>
-            <a:ext cx="2134758" cy="1691640"/>
+            <a:ext cx="1519602" cy="1691640"/>
           </a:xfrm>
           <a:prstGeom prst="roundRect">
             <a:avLst>
-              <a:gd name="adj" fmla="val 5405"/>
+              <a:gd name="adj" fmla="val 6017"/>
             </a:avLst>
           </a:prstGeom>
           <a:solidFill>
@@ -17264,8 +17264,8 @@
         </p:nvSpPr>
         <p:spPr>
           <a:xfrm>
-            <a:off x="640080" y="2221992"/>
-            <a:ext cx="1860438" cy="219456"/>
+            <a:off x="603504" y="2221992"/>
+            <a:ext cx="1318434" cy="219456"/>
           </a:xfrm>
           <a:prstGeom prst="rect">
             <a:avLst/>
@@ -17281,14 +17281,14 @@
               <a:buNone/>
             </a:pPr>
             <a:r>
-              <a:rPr lang="en-US" sz="1100" b="1" spc="200" kern="0" dirty="0">
+              <a:rPr lang="en-US" sz="1000" b="1" spc="200" kern="0" dirty="0">
                 <a:solidFill>
                   <a:srgbClr val="007C8C"/>
                 </a:solidFill>
               </a:rPr>
               <a:t>SPRINT 1</a:t>
             </a:r>
-            <a:endParaRPr lang="en-US" sz="1100" dirty="0"/>
+            <a:endParaRPr lang="en-US" sz="1000" dirty="0"/>
           </a:p>
         </p:txBody>
       </p:sp>
@@ -17300,8 +17300,8 @@
         </p:nvSpPr>
         <p:spPr>
           <a:xfrm>
-            <a:off x="640080" y="2450592"/>
-            <a:ext cx="1860438" cy="201168"/>
+            <a:off x="603504" y="2450592"/>
+            <a:ext cx="1318434" cy="201168"/>
           </a:xfrm>
           <a:prstGeom prst="rect">
             <a:avLst/>
@@ -17317,50 +17317,50 @@
               <a:buNone/>
             </a:pPr>
             <a:r>
+              <a:rPr lang="en-US" sz="950" dirty="0">
+                <a:solidFill>
+                  <a:srgbClr val="4D4D4D"/>
+                </a:solidFill>
+              </a:rPr>
+              <a:t>Weeks 1-2</a:t>
+            </a:r>
+            <a:endParaRPr lang="en-US" sz="950" dirty="0"/>
+          </a:p>
+        </p:txBody>
+      </p:sp>
+      <p:sp>
+        <p:nvSpPr>
+          <p:cNvPr id="17" name="Text 15"/>
+          <p:cNvSpPr txBox="1"/>
+          <p:nvPr/>
+        </p:nvSpPr>
+        <p:spPr>
+          <a:xfrm>
+            <a:off x="603504" y="2688336"/>
+            <a:ext cx="1318434" cy="585216"/>
+          </a:xfrm>
+          <a:prstGeom prst="rect">
+            <a:avLst/>
+          </a:prstGeom>
+          <a:noFill/>
+          <a:ln/>
+        </p:spPr>
+        <p:txBody>
+          <a:bodyPr wrap="square" lIns="0" tIns="0" rIns="0" bIns="0" rtlCol="0" anchor="t"/>
+          <a:lstStyle/>
+          <a:p>
+            <a:pPr indent="0" marL="0">
+              <a:buNone/>
+            </a:pPr>
+            <a:r>
               <a:rPr lang="en-US" sz="1000" dirty="0">
                 <a:solidFill>
-                  <a:srgbClr val="4D4D4D"/>
-                </a:solidFill>
-              </a:rPr>
-              <a:t>Weeks 1-2</a:t>
+                  <a:srgbClr val="000000"/>
+                </a:solidFill>
+              </a:rPr>
+              <a:t>Review today’s site, app and a Certain data sample; design</a:t>
             </a:r>
             <a:endParaRPr lang="en-US" sz="1000" dirty="0"/>
-          </a:p>
-        </p:txBody>
-      </p:sp>
-      <p:sp>
-        <p:nvSpPr>
-          <p:cNvPr id="17" name="Text 15"/>
-          <p:cNvSpPr txBox="1"/>
-          <p:nvPr/>
-        </p:nvSpPr>
-        <p:spPr>
-          <a:xfrm>
-            <a:off x="640080" y="2706624"/>
-            <a:ext cx="1860438" cy="603504"/>
-          </a:xfrm>
-          <a:prstGeom prst="rect">
-            <a:avLst/>
-          </a:prstGeom>
-          <a:noFill/>
-          <a:ln/>
-        </p:spPr>
-        <p:txBody>
-          <a:bodyPr wrap="square" lIns="0" tIns="0" rIns="0" bIns="0" rtlCol="0" anchor="t"/>
-          <a:lstStyle/>
-          <a:p>
-            <a:pPr indent="0" marL="0">
-              <a:buNone/>
-            </a:pPr>
-            <a:r>
-              <a:rPr lang="en-US" sz="1100" dirty="0">
-                <a:solidFill>
-                  <a:srgbClr val="000000"/>
-                </a:solidFill>
-              </a:rPr>
-              <a:t>Review today’s site, app and a Certain data sample; design</a:t>
-            </a:r>
-            <a:endParaRPr lang="en-US" sz="1100" dirty="0"/>
           </a:p>
         </p:txBody>
       </p:sp>
@@ -17372,8 +17372,8 @@
         </p:nvSpPr>
         <p:spPr>
           <a:xfrm>
-            <a:off x="640080" y="3291840"/>
-            <a:ext cx="1860438" cy="0"/>
+            <a:off x="603504" y="3291840"/>
+            <a:ext cx="1318434" cy="0"/>
           </a:xfrm>
           <a:prstGeom prst="line">
             <a:avLst/>
@@ -17395,8 +17395,8 @@
         </p:nvSpPr>
         <p:spPr>
           <a:xfrm>
-            <a:off x="640080" y="3429000"/>
-            <a:ext cx="155448" cy="155448"/>
+            <a:off x="603504" y="3429000"/>
+            <a:ext cx="137160" cy="137160"/>
           </a:xfrm>
           <a:prstGeom prst="diamond">
             <a:avLst/>
@@ -17420,8 +17420,8 @@
         </p:nvSpPr>
         <p:spPr>
           <a:xfrm>
-            <a:off x="886968" y="3364992"/>
-            <a:ext cx="1631838" cy="384048"/>
+            <a:off x="822960" y="3346704"/>
+            <a:ext cx="1098978" cy="402336"/>
           </a:xfrm>
           <a:prstGeom prst="rect">
             <a:avLst/>
@@ -17437,14 +17437,14 @@
               <a:buNone/>
             </a:pPr>
             <a:r>
-              <a:rPr lang="en-US" sz="1050" b="1" dirty="0">
+              <a:rPr lang="en-US" sz="950" b="1" dirty="0">
                 <a:solidFill>
                   <a:srgbClr val="000000"/>
                 </a:solidFill>
               </a:rPr>
               <a:t>Design sign-off</a:t>
             </a:r>
-            <a:endParaRPr lang="en-US" sz="1050" dirty="0"/>
+            <a:endParaRPr lang="en-US" sz="950" dirty="0"/>
           </a:p>
         </p:txBody>
       </p:sp>
@@ -17456,12 +17456,12 @@
         </p:nvSpPr>
         <p:spPr>
           <a:xfrm>
-            <a:off x="2765694" y="2103120"/>
-            <a:ext cx="2134758" cy="1691640"/>
+            <a:off x="2113962" y="2103120"/>
+            <a:ext cx="1519602" cy="1691640"/>
           </a:xfrm>
           <a:prstGeom prst="roundRect">
             <a:avLst>
-              <a:gd name="adj" fmla="val 5405"/>
+              <a:gd name="adj" fmla="val 6017"/>
             </a:avLst>
           </a:prstGeom>
           <a:solidFill>
@@ -17483,8 +17483,8 @@
         </p:nvSpPr>
         <p:spPr>
           <a:xfrm>
-            <a:off x="2902854" y="2221992"/>
-            <a:ext cx="1860438" cy="219456"/>
+            <a:off x="2214546" y="2221992"/>
+            <a:ext cx="1318434" cy="219456"/>
           </a:xfrm>
           <a:prstGeom prst="rect">
             <a:avLst/>
@@ -17500,14 +17500,14 @@
               <a:buNone/>
             </a:pPr>
             <a:r>
-              <a:rPr lang="en-US" sz="1100" b="1" spc="200" kern="0" dirty="0">
+              <a:rPr lang="en-US" sz="1000" b="1" spc="200" kern="0" dirty="0">
                 <a:solidFill>
                   <a:srgbClr val="C8005A"/>
                 </a:solidFill>
               </a:rPr>
               <a:t>SPRINT 2</a:t>
             </a:r>
-            <a:endParaRPr lang="en-US" sz="1100" dirty="0"/>
+            <a:endParaRPr lang="en-US" sz="1000" dirty="0"/>
           </a:p>
         </p:txBody>
       </p:sp>
@@ -17519,8 +17519,8 @@
         </p:nvSpPr>
         <p:spPr>
           <a:xfrm>
-            <a:off x="2902854" y="2450592"/>
-            <a:ext cx="1860438" cy="201168"/>
+            <a:off x="2214546" y="2450592"/>
+            <a:ext cx="1318434" cy="201168"/>
           </a:xfrm>
           <a:prstGeom prst="rect">
             <a:avLst/>
@@ -17536,50 +17536,50 @@
               <a:buNone/>
             </a:pPr>
             <a:r>
+              <a:rPr lang="en-US" sz="950" dirty="0">
+                <a:solidFill>
+                  <a:srgbClr val="4D4D4D"/>
+                </a:solidFill>
+              </a:rPr>
+              <a:t>Weeks 3-4</a:t>
+            </a:r>
+            <a:endParaRPr lang="en-US" sz="950" dirty="0"/>
+          </a:p>
+        </p:txBody>
+      </p:sp>
+      <p:sp>
+        <p:nvSpPr>
+          <p:cNvPr id="24" name="Text 22"/>
+          <p:cNvSpPr txBox="1"/>
+          <p:nvPr/>
+        </p:nvSpPr>
+        <p:spPr>
+          <a:xfrm>
+            <a:off x="2214546" y="2688336"/>
+            <a:ext cx="1318434" cy="585216"/>
+          </a:xfrm>
+          <a:prstGeom prst="rect">
+            <a:avLst/>
+          </a:prstGeom>
+          <a:noFill/>
+          <a:ln/>
+        </p:spPr>
+        <p:txBody>
+          <a:bodyPr wrap="square" lIns="0" tIns="0" rIns="0" bIns="0" rtlCol="0" anchor="t"/>
+          <a:lstStyle/>
+          <a:p>
+            <a:pPr indent="0" marL="0">
+              <a:buNone/>
+            </a:pPr>
+            <a:r>
               <a:rPr lang="en-US" sz="1000" dirty="0">
                 <a:solidFill>
-                  <a:srgbClr val="4D4D4D"/>
-                </a:solidFill>
-              </a:rPr>
-              <a:t>Weeks 3-4</a:t>
+                  <a:srgbClr val="000000"/>
+                </a:solidFill>
+              </a:rPr>
+              <a:t>Shared event model; sessions, tracks, rooms</a:t>
             </a:r>
             <a:endParaRPr lang="en-US" sz="1000" dirty="0"/>
-          </a:p>
-        </p:txBody>
-      </p:sp>
-      <p:sp>
-        <p:nvSpPr>
-          <p:cNvPr id="24" name="Text 22"/>
-          <p:cNvSpPr txBox="1"/>
-          <p:nvPr/>
-        </p:nvSpPr>
-        <p:spPr>
-          <a:xfrm>
-            <a:off x="2902854" y="2706624"/>
-            <a:ext cx="1860438" cy="603504"/>
-          </a:xfrm>
-          <a:prstGeom prst="rect">
-            <a:avLst/>
-          </a:prstGeom>
-          <a:noFill/>
-          <a:ln/>
-        </p:spPr>
-        <p:txBody>
-          <a:bodyPr wrap="square" lIns="0" tIns="0" rIns="0" bIns="0" rtlCol="0" anchor="t"/>
-          <a:lstStyle/>
-          <a:p>
-            <a:pPr indent="0" marL="0">
-              <a:buNone/>
-            </a:pPr>
-            <a:r>
-              <a:rPr lang="en-US" sz="1100" dirty="0">
-                <a:solidFill>
-                  <a:srgbClr val="000000"/>
-                </a:solidFill>
-              </a:rPr>
-              <a:t>Shared event model; sessions, tracks, rooms, speakers</a:t>
-            </a:r>
-            <a:endParaRPr lang="en-US" sz="1100" dirty="0"/>
           </a:p>
         </p:txBody>
       </p:sp>
@@ -17591,8 +17591,8 @@
         </p:nvSpPr>
         <p:spPr>
           <a:xfrm>
-            <a:off x="2902854" y="3291840"/>
-            <a:ext cx="1860438" cy="0"/>
+            <a:off x="2214546" y="3291840"/>
+            <a:ext cx="1318434" cy="0"/>
           </a:xfrm>
           <a:prstGeom prst="line">
             <a:avLst/>
@@ -17614,8 +17614,8 @@
         </p:nvSpPr>
         <p:spPr>
           <a:xfrm>
-            <a:off x="2902854" y="3429000"/>
-            <a:ext cx="155448" cy="155448"/>
+            <a:off x="2214546" y="3429000"/>
+            <a:ext cx="137160" cy="137160"/>
           </a:xfrm>
           <a:prstGeom prst="diamond">
             <a:avLst/>
@@ -17639,8 +17639,8 @@
         </p:nvSpPr>
         <p:spPr>
           <a:xfrm>
-            <a:off x="3149742" y="3364992"/>
-            <a:ext cx="1631838" cy="384048"/>
+            <a:off x="2434002" y="3346704"/>
+            <a:ext cx="1098978" cy="402336"/>
           </a:xfrm>
           <a:prstGeom prst="rect">
             <a:avLst/>
@@ -17656,14 +17656,14 @@
               <a:buNone/>
             </a:pPr>
             <a:r>
-              <a:rPr lang="en-US" sz="1050" b="1" dirty="0">
+              <a:rPr lang="en-US" sz="950" b="1" dirty="0">
                 <a:solidFill>
                   <a:srgbClr val="000000"/>
                 </a:solidFill>
               </a:rPr>
               <a:t>Conference model demo</a:t>
             </a:r>
-            <a:endParaRPr lang="en-US" sz="1050" dirty="0"/>
+            <a:endParaRPr lang="en-US" sz="950" dirty="0"/>
           </a:p>
         </p:txBody>
       </p:sp>
@@ -17675,12 +17675,12 @@
         </p:nvSpPr>
         <p:spPr>
           <a:xfrm>
-            <a:off x="5028468" y="2103120"/>
-            <a:ext cx="2134758" cy="1691640"/>
+            <a:off x="3725004" y="2103120"/>
+            <a:ext cx="1519602" cy="1691640"/>
           </a:xfrm>
           <a:prstGeom prst="roundRect">
             <a:avLst>
-              <a:gd name="adj" fmla="val 5405"/>
+              <a:gd name="adj" fmla="val 6017"/>
             </a:avLst>
           </a:prstGeom>
           <a:solidFill>
@@ -17702,8 +17702,8 @@
         </p:nvSpPr>
         <p:spPr>
           <a:xfrm>
-            <a:off x="5165628" y="2221992"/>
-            <a:ext cx="1860438" cy="219456"/>
+            <a:off x="3825588" y="2221992"/>
+            <a:ext cx="1318434" cy="219456"/>
           </a:xfrm>
           <a:prstGeom prst="rect">
             <a:avLst/>
@@ -17719,14 +17719,14 @@
               <a:buNone/>
             </a:pPr>
             <a:r>
-              <a:rPr lang="en-US" sz="1100" b="1" spc="200" kern="0" dirty="0">
+              <a:rPr lang="en-US" sz="1000" b="1" spc="200" kern="0" dirty="0">
                 <a:solidFill>
                   <a:srgbClr val="C8005A"/>
                 </a:solidFill>
               </a:rPr>
               <a:t>SPRINT 3</a:t>
             </a:r>
-            <a:endParaRPr lang="en-US" sz="1100" dirty="0"/>
+            <a:endParaRPr lang="en-US" sz="1000" dirty="0"/>
           </a:p>
         </p:txBody>
       </p:sp>
@@ -17738,8 +17738,8 @@
         </p:nvSpPr>
         <p:spPr>
           <a:xfrm>
-            <a:off x="5165628" y="2450592"/>
-            <a:ext cx="1860438" cy="201168"/>
+            <a:off x="3825588" y="2450592"/>
+            <a:ext cx="1318434" cy="201168"/>
           </a:xfrm>
           <a:prstGeom prst="rect">
             <a:avLst/>
@@ -17755,50 +17755,50 @@
               <a:buNone/>
             </a:pPr>
             <a:r>
+              <a:rPr lang="en-US" sz="950" dirty="0">
+                <a:solidFill>
+                  <a:srgbClr val="4D4D4D"/>
+                </a:solidFill>
+              </a:rPr>
+              <a:t>Weeks 5-6</a:t>
+            </a:r>
+            <a:endParaRPr lang="en-US" sz="950" dirty="0"/>
+          </a:p>
+        </p:txBody>
+      </p:sp>
+      <p:sp>
+        <p:nvSpPr>
+          <p:cNvPr id="31" name="Text 29"/>
+          <p:cNvSpPr txBox="1"/>
+          <p:nvPr/>
+        </p:nvSpPr>
+        <p:spPr>
+          <a:xfrm>
+            <a:off x="3825588" y="2688336"/>
+            <a:ext cx="1318434" cy="585216"/>
+          </a:xfrm>
+          <a:prstGeom prst="rect">
+            <a:avLst/>
+          </a:prstGeom>
+          <a:noFill/>
+          <a:ln/>
+        </p:spPr>
+        <p:txBody>
+          <a:bodyPr wrap="square" lIns="0" tIns="0" rIns="0" bIns="0" rtlCol="0" anchor="t"/>
+          <a:lstStyle/>
+          <a:p>
+            <a:pPr indent="0" marL="0">
+              <a:buNone/>
+            </a:pPr>
+            <a:r>
               <a:rPr lang="en-US" sz="1000" dirty="0">
                 <a:solidFill>
-                  <a:srgbClr val="4D4D4D"/>
-                </a:solidFill>
-              </a:rPr>
-              <a:t>Weeks 5-6</a:t>
+                  <a:srgbClr val="000000"/>
+                </a:solidFill>
+              </a:rPr>
+              <a:t>Speakers, ticket types and pricing</a:t>
             </a:r>
             <a:endParaRPr lang="en-US" sz="1000" dirty="0"/>
-          </a:p>
-        </p:txBody>
-      </p:sp>
-      <p:sp>
-        <p:nvSpPr>
-          <p:cNvPr id="31" name="Text 29"/>
-          <p:cNvSpPr txBox="1"/>
-          <p:nvPr/>
-        </p:nvSpPr>
-        <p:spPr>
-          <a:xfrm>
-            <a:off x="5165628" y="2706624"/>
-            <a:ext cx="1860438" cy="603504"/>
-          </a:xfrm>
-          <a:prstGeom prst="rect">
-            <a:avLst/>
-          </a:prstGeom>
-          <a:noFill/>
-          <a:ln/>
-        </p:spPr>
-        <p:txBody>
-          <a:bodyPr wrap="square" lIns="0" tIns="0" rIns="0" bIns="0" rtlCol="0" anchor="t"/>
-          <a:lstStyle/>
-          <a:p>
-            <a:pPr indent="0" marL="0">
-              <a:buNone/>
-            </a:pPr>
-            <a:r>
-              <a:rPr lang="en-US" sz="1100" dirty="0">
-                <a:solidFill>
-                  <a:srgbClr val="000000"/>
-                </a:solidFill>
-              </a:rPr>
-              <a:t>My Agenda portal on Experience Cloud; ticket types</a:t>
-            </a:r>
-            <a:endParaRPr lang="en-US" sz="1100" dirty="0"/>
           </a:p>
         </p:txBody>
       </p:sp>
@@ -17810,8 +17810,8 @@
         </p:nvSpPr>
         <p:spPr>
           <a:xfrm>
-            <a:off x="5165628" y="3291840"/>
-            <a:ext cx="1860438" cy="0"/>
+            <a:off x="3825588" y="3291840"/>
+            <a:ext cx="1318434" cy="0"/>
           </a:xfrm>
           <a:prstGeom prst="line">
             <a:avLst/>
@@ -17833,8 +17833,8 @@
         </p:nvSpPr>
         <p:spPr>
           <a:xfrm>
-            <a:off x="5165628" y="3429000"/>
-            <a:ext cx="155448" cy="155448"/>
+            <a:off x="3825588" y="3429000"/>
+            <a:ext cx="137160" cy="137160"/>
           </a:xfrm>
           <a:prstGeom prst="diamond">
             <a:avLst/>
@@ -17858,8 +17858,8 @@
         </p:nvSpPr>
         <p:spPr>
           <a:xfrm>
-            <a:off x="5412516" y="3364992"/>
-            <a:ext cx="1631838" cy="384048"/>
+            <a:off x="4045044" y="3346704"/>
+            <a:ext cx="1098978" cy="402336"/>
           </a:xfrm>
           <a:prstGeom prst="rect">
             <a:avLst/>
@@ -17875,14 +17875,14 @@
               <a:buNone/>
             </a:pPr>
             <a:r>
-              <a:rPr lang="en-US" sz="1050" b="1" dirty="0">
+              <a:rPr lang="en-US" sz="950" b="1" dirty="0">
                 <a:solidFill>
                   <a:srgbClr val="000000"/>
                 </a:solidFill>
               </a:rPr>
-              <a:t>Attendee portal demo</a:t>
-            </a:r>
-            <a:endParaRPr lang="en-US" sz="1050" dirty="0"/>
+              <a:t>Speakers and tickets demo</a:t>
+            </a:r>
+            <a:endParaRPr lang="en-US" sz="950" dirty="0"/>
           </a:p>
         </p:txBody>
       </p:sp>
@@ -17894,12 +17894,12 @@
         </p:nvSpPr>
         <p:spPr>
           <a:xfrm>
-            <a:off x="7291243" y="2103120"/>
-            <a:ext cx="2134758" cy="1691640"/>
+            <a:off x="5336047" y="2103120"/>
+            <a:ext cx="1519602" cy="1691640"/>
           </a:xfrm>
           <a:prstGeom prst="roundRect">
             <a:avLst>
-              <a:gd name="adj" fmla="val 5405"/>
+              <a:gd name="adj" fmla="val 6017"/>
             </a:avLst>
           </a:prstGeom>
           <a:solidFill>
@@ -17921,8 +17921,8 @@
         </p:nvSpPr>
         <p:spPr>
           <a:xfrm>
-            <a:off x="7428403" y="2221992"/>
-            <a:ext cx="1860438" cy="219456"/>
+            <a:off x="5436631" y="2221992"/>
+            <a:ext cx="1318434" cy="219456"/>
           </a:xfrm>
           <a:prstGeom prst="rect">
             <a:avLst/>
@@ -17938,14 +17938,14 @@
               <a:buNone/>
             </a:pPr>
             <a:r>
-              <a:rPr lang="en-US" sz="1100" b="1" spc="200" kern="0" dirty="0">
+              <a:rPr lang="en-US" sz="1000" b="1" spc="200" kern="0" dirty="0">
                 <a:solidFill>
                   <a:srgbClr val="C8005A"/>
                 </a:solidFill>
               </a:rPr>
               <a:t>SPRINT 4</a:t>
             </a:r>
-            <a:endParaRPr lang="en-US" sz="1100" dirty="0"/>
+            <a:endParaRPr lang="en-US" sz="1000" dirty="0"/>
           </a:p>
         </p:txBody>
       </p:sp>
@@ -17957,8 +17957,8 @@
         </p:nvSpPr>
         <p:spPr>
           <a:xfrm>
-            <a:off x="7428403" y="2450592"/>
-            <a:ext cx="1860438" cy="201168"/>
+            <a:off x="5436631" y="2450592"/>
+            <a:ext cx="1318434" cy="201168"/>
           </a:xfrm>
           <a:prstGeom prst="rect">
             <a:avLst/>
@@ -17974,50 +17974,50 @@
               <a:buNone/>
             </a:pPr>
             <a:r>
+              <a:rPr lang="en-US" sz="950" dirty="0">
+                <a:solidFill>
+                  <a:srgbClr val="4D4D4D"/>
+                </a:solidFill>
+              </a:rPr>
+              <a:t>Weeks 7-8</a:t>
+            </a:r>
+            <a:endParaRPr lang="en-US" sz="950" dirty="0"/>
+          </a:p>
+        </p:txBody>
+      </p:sp>
+      <p:sp>
+        <p:nvSpPr>
+          <p:cNvPr id="38" name="Text 36"/>
+          <p:cNvSpPr txBox="1"/>
+          <p:nvPr/>
+        </p:nvSpPr>
+        <p:spPr>
+          <a:xfrm>
+            <a:off x="5436631" y="2688336"/>
+            <a:ext cx="1318434" cy="585216"/>
+          </a:xfrm>
+          <a:prstGeom prst="rect">
+            <a:avLst/>
+          </a:prstGeom>
+          <a:noFill/>
+          <a:ln/>
+        </p:spPr>
+        <p:txBody>
+          <a:bodyPr wrap="square" lIns="0" tIns="0" rIns="0" bIns="0" rtlCol="0" anchor="t"/>
+          <a:lstStyle/>
+          <a:p>
+            <a:pPr indent="0" marL="0">
+              <a:buNone/>
+            </a:pPr>
+            <a:r>
               <a:rPr lang="en-US" sz="1000" dirty="0">
                 <a:solidFill>
-                  <a:srgbClr val="4D4D4D"/>
-                </a:solidFill>
-              </a:rPr>
-              <a:t>Weeks 7-8</a:t>
+                  <a:srgbClr val="000000"/>
+                </a:solidFill>
+              </a:rPr>
+              <a:t>My Agenda portal on Experience Cloud</a:t>
             </a:r>
             <a:endParaRPr lang="en-US" sz="1000" dirty="0"/>
-          </a:p>
-        </p:txBody>
-      </p:sp>
-      <p:sp>
-        <p:nvSpPr>
-          <p:cNvPr id="38" name="Text 36"/>
-          <p:cNvSpPr txBox="1"/>
-          <p:nvPr/>
-        </p:nvSpPr>
-        <p:spPr>
-          <a:xfrm>
-            <a:off x="7428403" y="2706624"/>
-            <a:ext cx="1860438" cy="603504"/>
-          </a:xfrm>
-          <a:prstGeom prst="rect">
-            <a:avLst/>
-          </a:prstGeom>
-          <a:noFill/>
-          <a:ln/>
-        </p:spPr>
-        <p:txBody>
-          <a:bodyPr wrap="square" lIns="0" tIns="0" rIns="0" bIns="0" rtlCol="0" anchor="t"/>
-          <a:lstStyle/>
-          <a:p>
-            <a:pPr indent="0" marL="0">
-              <a:buNone/>
-            </a:pPr>
-            <a:r>
-              <a:rPr lang="en-US" sz="1100" dirty="0">
-                <a:solidFill>
-                  <a:srgbClr val="000000"/>
-                </a:solidFill>
-              </a:rPr>
-              <a:t>Chase checkout for conferences; badges; CME [to confirm]</a:t>
-            </a:r>
-            <a:endParaRPr lang="en-US" sz="1100" dirty="0"/>
           </a:p>
         </p:txBody>
       </p:sp>
@@ -18029,8 +18029,8 @@
         </p:nvSpPr>
         <p:spPr>
           <a:xfrm>
-            <a:off x="7428403" y="3291840"/>
-            <a:ext cx="1860438" cy="0"/>
+            <a:off x="5436631" y="3291840"/>
+            <a:ext cx="1318434" cy="0"/>
           </a:xfrm>
           <a:prstGeom prst="line">
             <a:avLst/>
@@ -18052,8 +18052,8 @@
         </p:nvSpPr>
         <p:spPr>
           <a:xfrm>
-            <a:off x="7428403" y="3429000"/>
-            <a:ext cx="155448" cy="155448"/>
+            <a:off x="5436631" y="3429000"/>
+            <a:ext cx="137160" cy="137160"/>
           </a:xfrm>
           <a:prstGeom prst="diamond">
             <a:avLst/>
@@ -18077,8 +18077,8 @@
         </p:nvSpPr>
         <p:spPr>
           <a:xfrm>
-            <a:off x="7675291" y="3364992"/>
-            <a:ext cx="1631838" cy="384048"/>
+            <a:off x="5656087" y="3346704"/>
+            <a:ext cx="1098978" cy="402336"/>
           </a:xfrm>
           <a:prstGeom prst="rect">
             <a:avLst/>
@@ -18094,14 +18094,14 @@
               <a:buNone/>
             </a:pPr>
             <a:r>
-              <a:rPr lang="en-US" sz="1050" b="1" dirty="0">
+              <a:rPr lang="en-US" sz="950" b="1" dirty="0">
                 <a:solidFill>
                   <a:srgbClr val="000000"/>
                 </a:solidFill>
               </a:rPr>
-              <a:t>Pay and badge end to end</a:t>
-            </a:r>
-            <a:endParaRPr lang="en-US" sz="1050" dirty="0"/>
+              <a:t>Attendee portal demo</a:t>
+            </a:r>
+            <a:endParaRPr lang="en-US" sz="950" dirty="0"/>
           </a:p>
         </p:txBody>
       </p:sp>
@@ -18113,12 +18113,12 @@
         </p:nvSpPr>
         <p:spPr>
           <a:xfrm>
-            <a:off x="9554017" y="2103120"/>
-            <a:ext cx="2134758" cy="1691640"/>
+            <a:off x="6947089" y="2103120"/>
+            <a:ext cx="1519602" cy="1691640"/>
           </a:xfrm>
           <a:prstGeom prst="roundRect">
             <a:avLst>
-              <a:gd name="adj" fmla="val 5405"/>
+              <a:gd name="adj" fmla="val 6017"/>
             </a:avLst>
           </a:prstGeom>
           <a:solidFill>
@@ -18140,8 +18140,8 @@
         </p:nvSpPr>
         <p:spPr>
           <a:xfrm>
-            <a:off x="9691177" y="2221992"/>
-            <a:ext cx="1860438" cy="219456"/>
+            <a:off x="7047673" y="2221992"/>
+            <a:ext cx="1318434" cy="219456"/>
           </a:xfrm>
           <a:prstGeom prst="rect">
             <a:avLst/>
@@ -18157,14 +18157,14 @@
               <a:buNone/>
             </a:pPr>
             <a:r>
-              <a:rPr lang="en-US" sz="1100" b="1" spc="200" kern="0" dirty="0">
+              <a:rPr lang="en-US" sz="1000" b="1" spc="200" kern="0" dirty="0">
                 <a:solidFill>
                   <a:srgbClr val="C8005A"/>
                 </a:solidFill>
               </a:rPr>
               <a:t>SPRINT 5</a:t>
             </a:r>
-            <a:endParaRPr lang="en-US" sz="1100" dirty="0"/>
+            <a:endParaRPr lang="en-US" sz="1000" dirty="0"/>
           </a:p>
         </p:txBody>
       </p:sp>
@@ -18176,8 +18176,8 @@
         </p:nvSpPr>
         <p:spPr>
           <a:xfrm>
-            <a:off x="9691177" y="2450592"/>
-            <a:ext cx="1860438" cy="201168"/>
+            <a:off x="7047673" y="2450592"/>
+            <a:ext cx="1318434" cy="201168"/>
           </a:xfrm>
           <a:prstGeom prst="rect">
             <a:avLst/>
@@ -18193,50 +18193,50 @@
               <a:buNone/>
             </a:pPr>
             <a:r>
+              <a:rPr lang="en-US" sz="950" dirty="0">
+                <a:solidFill>
+                  <a:srgbClr val="4D4D4D"/>
+                </a:solidFill>
+              </a:rPr>
+              <a:t>Weeks 9-10</a:t>
+            </a:r>
+            <a:endParaRPr lang="en-US" sz="950" dirty="0"/>
+          </a:p>
+        </p:txBody>
+      </p:sp>
+      <p:sp>
+        <p:nvSpPr>
+          <p:cNvPr id="45" name="Text 43"/>
+          <p:cNvSpPr txBox="1"/>
+          <p:nvPr/>
+        </p:nvSpPr>
+        <p:spPr>
+          <a:xfrm>
+            <a:off x="7047673" y="2688336"/>
+            <a:ext cx="1318434" cy="585216"/>
+          </a:xfrm>
+          <a:prstGeom prst="rect">
+            <a:avLst/>
+          </a:prstGeom>
+          <a:noFill/>
+          <a:ln/>
+        </p:spPr>
+        <p:txBody>
+          <a:bodyPr wrap="square" lIns="0" tIns="0" rIns="0" bIns="0" rtlCol="0" anchor="t"/>
+          <a:lstStyle/>
+          <a:p>
+            <a:pPr indent="0" marL="0">
+              <a:buNone/>
+            </a:pPr>
+            <a:r>
               <a:rPr lang="en-US" sz="1000" dirty="0">
                 <a:solidFill>
-                  <a:srgbClr val="4D4D4D"/>
-                </a:solidFill>
-              </a:rPr>
-              <a:t>Weeks 9-10</a:t>
+                  <a:srgbClr val="000000"/>
+                </a:solidFill>
+              </a:rPr>
+              <a:t>Session picks, seat limits, holds, waitlists</a:t>
             </a:r>
             <a:endParaRPr lang="en-US" sz="1000" dirty="0"/>
-          </a:p>
-        </p:txBody>
-      </p:sp>
-      <p:sp>
-        <p:nvSpPr>
-          <p:cNvPr id="45" name="Text 43"/>
-          <p:cNvSpPr txBox="1"/>
-          <p:nvPr/>
-        </p:nvSpPr>
-        <p:spPr>
-          <a:xfrm>
-            <a:off x="9691177" y="2706624"/>
-            <a:ext cx="1860438" cy="603504"/>
-          </a:xfrm>
-          <a:prstGeom prst="rect">
-            <a:avLst/>
-          </a:prstGeom>
-          <a:noFill/>
-          <a:ln/>
-        </p:spPr>
-        <p:txBody>
-          <a:bodyPr wrap="square" lIns="0" tIns="0" rIns="0" bIns="0" rtlCol="0" anchor="t"/>
-          <a:lstStyle/>
-          <a:p>
-            <a:pPr indent="0" marL="0">
-              <a:buNone/>
-            </a:pPr>
-            <a:r>
-              <a:rPr lang="en-US" sz="1100" dirty="0">
-                <a:solidFill>
-                  <a:srgbClr val="000000"/>
-                </a:solidFill>
-              </a:rPr>
-              <a:t>Load test, user testing, conference reporting</a:t>
-            </a:r>
-            <a:endParaRPr lang="en-US" sz="1100" dirty="0"/>
           </a:p>
         </p:txBody>
       </p:sp>
@@ -18248,8 +18248,8 @@
         </p:nvSpPr>
         <p:spPr>
           <a:xfrm>
-            <a:off x="9691177" y="3291840"/>
-            <a:ext cx="1860438" cy="0"/>
+            <a:off x="7047673" y="3291840"/>
+            <a:ext cx="1318434" cy="0"/>
           </a:xfrm>
           <a:prstGeom prst="line">
             <a:avLst/>
@@ -18271,8 +18271,8 @@
         </p:nvSpPr>
         <p:spPr>
           <a:xfrm>
-            <a:off x="9691177" y="3429000"/>
-            <a:ext cx="155448" cy="155448"/>
+            <a:off x="7047673" y="3429000"/>
+            <a:ext cx="137160" cy="137160"/>
           </a:xfrm>
           <a:prstGeom prst="diamond">
             <a:avLst/>
@@ -18296,8 +18296,8 @@
         </p:nvSpPr>
         <p:spPr>
           <a:xfrm>
-            <a:off x="9938065" y="3364992"/>
-            <a:ext cx="1631838" cy="384048"/>
+            <a:off x="7267129" y="3346704"/>
+            <a:ext cx="1098978" cy="402336"/>
           </a:xfrm>
           <a:prstGeom prst="rect">
             <a:avLst/>
@@ -18313,14 +18313,14 @@
               <a:buNone/>
             </a:pPr>
             <a:r>
-              <a:rPr lang="en-US" sz="1050" b="1" dirty="0">
+              <a:rPr lang="en-US" sz="950" b="1" dirty="0">
                 <a:solidFill>
                   <a:srgbClr val="000000"/>
                 </a:solidFill>
               </a:rPr>
-              <a:t>Testing sign-off</a:t>
-            </a:r>
-            <a:endParaRPr lang="en-US" sz="1050" dirty="0"/>
+              <a:t>Session booking demo</a:t>
+            </a:r>
+            <a:endParaRPr lang="en-US" sz="950" dirty="0"/>
           </a:p>
         </p:txBody>
       </p:sp>
@@ -18332,12 +18332,888 @@
         </p:nvSpPr>
         <p:spPr>
           <a:xfrm>
-            <a:off x="502920" y="4251960"/>
-            <a:ext cx="2134758" cy="1691640"/>
+            <a:off x="8558131" y="2103120"/>
+            <a:ext cx="1519602" cy="1691640"/>
           </a:xfrm>
           <a:prstGeom prst="roundRect">
             <a:avLst>
-              <a:gd name="adj" fmla="val 5405"/>
+              <a:gd name="adj" fmla="val 6017"/>
+            </a:avLst>
+          </a:prstGeom>
+          <a:solidFill>
+            <a:srgbClr val="F2F2F2"/>
+          </a:solidFill>
+          <a:ln w="22225">
+            <a:solidFill>
+              <a:srgbClr val="FF0068"/>
+            </a:solidFill>
+            <a:prstDash val="solid"/>
+          </a:ln>
+        </p:spPr>
+      </p:sp>
+      <p:sp>
+        <p:nvSpPr>
+          <p:cNvPr id="50" name="Text 48"/>
+          <p:cNvSpPr txBox="1"/>
+          <p:nvPr/>
+        </p:nvSpPr>
+        <p:spPr>
+          <a:xfrm>
+            <a:off x="8658715" y="2221992"/>
+            <a:ext cx="1318434" cy="219456"/>
+          </a:xfrm>
+          <a:prstGeom prst="rect">
+            <a:avLst/>
+          </a:prstGeom>
+          <a:noFill/>
+          <a:ln/>
+        </p:spPr>
+        <p:txBody>
+          <a:bodyPr wrap="square" lIns="0" tIns="0" rIns="0" bIns="0" rtlCol="0" anchor="t"/>
+          <a:lstStyle/>
+          <a:p>
+            <a:pPr indent="0" marL="0">
+              <a:buNone/>
+            </a:pPr>
+            <a:r>
+              <a:rPr lang="en-US" sz="1000" b="1" spc="200" kern="0" dirty="0">
+                <a:solidFill>
+                  <a:srgbClr val="C8005A"/>
+                </a:solidFill>
+              </a:rPr>
+              <a:t>SPRINT 6</a:t>
+            </a:r>
+            <a:endParaRPr lang="en-US" sz="1000" dirty="0"/>
+          </a:p>
+        </p:txBody>
+      </p:sp>
+      <p:sp>
+        <p:nvSpPr>
+          <p:cNvPr id="51" name="Text 49"/>
+          <p:cNvSpPr txBox="1"/>
+          <p:nvPr/>
+        </p:nvSpPr>
+        <p:spPr>
+          <a:xfrm>
+            <a:off x="8658715" y="2450592"/>
+            <a:ext cx="1318434" cy="201168"/>
+          </a:xfrm>
+          <a:prstGeom prst="rect">
+            <a:avLst/>
+          </a:prstGeom>
+          <a:noFill/>
+          <a:ln/>
+        </p:spPr>
+        <p:txBody>
+          <a:bodyPr wrap="square" lIns="0" tIns="0" rIns="0" bIns="0" rtlCol="0" anchor="t"/>
+          <a:lstStyle/>
+          <a:p>
+            <a:pPr indent="0" marL="0">
+              <a:buNone/>
+            </a:pPr>
+            <a:r>
+              <a:rPr lang="en-US" sz="950" dirty="0">
+                <a:solidFill>
+                  <a:srgbClr val="4D4D4D"/>
+                </a:solidFill>
+              </a:rPr>
+              <a:t>Weeks 11-12</a:t>
+            </a:r>
+            <a:endParaRPr lang="en-US" sz="950" dirty="0"/>
+          </a:p>
+        </p:txBody>
+      </p:sp>
+      <p:sp>
+        <p:nvSpPr>
+          <p:cNvPr id="52" name="Text 50"/>
+          <p:cNvSpPr txBox="1"/>
+          <p:nvPr/>
+        </p:nvSpPr>
+        <p:spPr>
+          <a:xfrm>
+            <a:off x="8658715" y="2688336"/>
+            <a:ext cx="1318434" cy="585216"/>
+          </a:xfrm>
+          <a:prstGeom prst="rect">
+            <a:avLst/>
+          </a:prstGeom>
+          <a:noFill/>
+          <a:ln/>
+        </p:spPr>
+        <p:txBody>
+          <a:bodyPr wrap="square" lIns="0" tIns="0" rIns="0" bIns="0" rtlCol="0" anchor="t"/>
+          <a:lstStyle/>
+          <a:p>
+            <a:pPr indent="0" marL="0">
+              <a:buNone/>
+            </a:pPr>
+            <a:r>
+              <a:rPr lang="en-US" sz="1000" dirty="0">
+                <a:solidFill>
+                  <a:srgbClr val="000000"/>
+                </a:solidFill>
+              </a:rPr>
+              <a:t>Chase checkout for conferences; refunds</a:t>
+            </a:r>
+            <a:endParaRPr lang="en-US" sz="1000" dirty="0"/>
+          </a:p>
+        </p:txBody>
+      </p:sp>
+      <p:sp>
+        <p:nvSpPr>
+          <p:cNvPr id="53" name="Shape 51"/>
+          <p:cNvSpPr/>
+          <p:nvPr/>
+        </p:nvSpPr>
+        <p:spPr>
+          <a:xfrm>
+            <a:off x="8658715" y="3291840"/>
+            <a:ext cx="1318434" cy="0"/>
+          </a:xfrm>
+          <a:prstGeom prst="line">
+            <a:avLst/>
+          </a:prstGeom>
+          <a:noFill/>
+          <a:ln w="9525">
+            <a:solidFill>
+              <a:srgbClr val="D0D0D6"/>
+            </a:solidFill>
+            <a:prstDash val="solid"/>
+          </a:ln>
+        </p:spPr>
+      </p:sp>
+      <p:sp>
+        <p:nvSpPr>
+          <p:cNvPr id="54" name="Shape 52"/>
+          <p:cNvSpPr/>
+          <p:nvPr/>
+        </p:nvSpPr>
+        <p:spPr>
+          <a:xfrm>
+            <a:off x="8658715" y="3429000"/>
+            <a:ext cx="137160" cy="137160"/>
+          </a:xfrm>
+          <a:prstGeom prst="diamond">
+            <a:avLst/>
+          </a:prstGeom>
+          <a:solidFill>
+            <a:srgbClr val="000000"/>
+          </a:solidFill>
+          <a:ln w="12700">
+            <a:solidFill>
+              <a:srgbClr val="000000"/>
+            </a:solidFill>
+            <a:prstDash val="solid"/>
+          </a:ln>
+        </p:spPr>
+      </p:sp>
+      <p:sp>
+        <p:nvSpPr>
+          <p:cNvPr id="55" name="Text 53"/>
+          <p:cNvSpPr txBox="1"/>
+          <p:nvPr/>
+        </p:nvSpPr>
+        <p:spPr>
+          <a:xfrm>
+            <a:off x="8878171" y="3346704"/>
+            <a:ext cx="1098978" cy="402336"/>
+          </a:xfrm>
+          <a:prstGeom prst="rect">
+            <a:avLst/>
+          </a:prstGeom>
+          <a:noFill/>
+          <a:ln/>
+        </p:spPr>
+        <p:txBody>
+          <a:bodyPr wrap="square" lIns="0" tIns="0" rIns="0" bIns="0" rtlCol="0" anchor="t"/>
+          <a:lstStyle/>
+          <a:p>
+            <a:pPr indent="0" marL="0">
+              <a:buNone/>
+            </a:pPr>
+            <a:r>
+              <a:rPr lang="en-US" sz="950" b="1" dirty="0">
+                <a:solidFill>
+                  <a:srgbClr val="000000"/>
+                </a:solidFill>
+              </a:rPr>
+              <a:t>Pay end to end</a:t>
+            </a:r>
+            <a:endParaRPr lang="en-US" sz="950" dirty="0"/>
+          </a:p>
+        </p:txBody>
+      </p:sp>
+      <p:sp>
+        <p:nvSpPr>
+          <p:cNvPr id="56" name="sprint-7"/>
+          <p:cNvSpPr/>
+          <p:nvPr/>
+        </p:nvSpPr>
+        <p:spPr>
+          <a:xfrm>
+            <a:off x="10169173" y="2103120"/>
+            <a:ext cx="1519602" cy="1691640"/>
+          </a:xfrm>
+          <a:prstGeom prst="roundRect">
+            <a:avLst>
+              <a:gd name="adj" fmla="val 6017"/>
+            </a:avLst>
+          </a:prstGeom>
+          <a:solidFill>
+            <a:srgbClr val="F2F2F2"/>
+          </a:solidFill>
+          <a:ln w="22225">
+            <a:solidFill>
+              <a:srgbClr val="FF0068"/>
+            </a:solidFill>
+            <a:prstDash val="solid"/>
+          </a:ln>
+        </p:spPr>
+      </p:sp>
+      <p:sp>
+        <p:nvSpPr>
+          <p:cNvPr id="57" name="Text 55"/>
+          <p:cNvSpPr txBox="1"/>
+          <p:nvPr/>
+        </p:nvSpPr>
+        <p:spPr>
+          <a:xfrm>
+            <a:off x="10269757" y="2221992"/>
+            <a:ext cx="1318434" cy="219456"/>
+          </a:xfrm>
+          <a:prstGeom prst="rect">
+            <a:avLst/>
+          </a:prstGeom>
+          <a:noFill/>
+          <a:ln/>
+        </p:spPr>
+        <p:txBody>
+          <a:bodyPr wrap="square" lIns="0" tIns="0" rIns="0" bIns="0" rtlCol="0" anchor="t"/>
+          <a:lstStyle/>
+          <a:p>
+            <a:pPr indent="0" marL="0">
+              <a:buNone/>
+            </a:pPr>
+            <a:r>
+              <a:rPr lang="en-US" sz="1000" b="1" spc="200" kern="0" dirty="0">
+                <a:solidFill>
+                  <a:srgbClr val="C8005A"/>
+                </a:solidFill>
+              </a:rPr>
+              <a:t>SPRINT 7</a:t>
+            </a:r>
+            <a:endParaRPr lang="en-US" sz="1000" dirty="0"/>
+          </a:p>
+        </p:txBody>
+      </p:sp>
+      <p:sp>
+        <p:nvSpPr>
+          <p:cNvPr id="58" name="Text 56"/>
+          <p:cNvSpPr txBox="1"/>
+          <p:nvPr/>
+        </p:nvSpPr>
+        <p:spPr>
+          <a:xfrm>
+            <a:off x="10269757" y="2450592"/>
+            <a:ext cx="1318434" cy="201168"/>
+          </a:xfrm>
+          <a:prstGeom prst="rect">
+            <a:avLst/>
+          </a:prstGeom>
+          <a:noFill/>
+          <a:ln/>
+        </p:spPr>
+        <p:txBody>
+          <a:bodyPr wrap="square" lIns="0" tIns="0" rIns="0" bIns="0" rtlCol="0" anchor="t"/>
+          <a:lstStyle/>
+          <a:p>
+            <a:pPr indent="0" marL="0">
+              <a:buNone/>
+            </a:pPr>
+            <a:r>
+              <a:rPr lang="en-US" sz="950" dirty="0">
+                <a:solidFill>
+                  <a:srgbClr val="4D4D4D"/>
+                </a:solidFill>
+              </a:rPr>
+              <a:t>Weeks 13-14</a:t>
+            </a:r>
+            <a:endParaRPr lang="en-US" sz="950" dirty="0"/>
+          </a:p>
+        </p:txBody>
+      </p:sp>
+      <p:sp>
+        <p:nvSpPr>
+          <p:cNvPr id="59" name="Text 57"/>
+          <p:cNvSpPr txBox="1"/>
+          <p:nvPr/>
+        </p:nvSpPr>
+        <p:spPr>
+          <a:xfrm>
+            <a:off x="10269757" y="2688336"/>
+            <a:ext cx="1318434" cy="585216"/>
+          </a:xfrm>
+          <a:prstGeom prst="rect">
+            <a:avLst/>
+          </a:prstGeom>
+          <a:noFill/>
+          <a:ln/>
+        </p:spPr>
+        <p:txBody>
+          <a:bodyPr wrap="square" lIns="0" tIns="0" rIns="0" bIns="0" rtlCol="0" anchor="t"/>
+          <a:lstStyle/>
+          <a:p>
+            <a:pPr indent="0" marL="0">
+              <a:buNone/>
+            </a:pPr>
+            <a:r>
+              <a:rPr lang="en-US" sz="1000" dirty="0">
+                <a:solidFill>
+                  <a:srgbClr val="000000"/>
+                </a:solidFill>
+              </a:rPr>
+              <a:t>Badges, check-in, CME [to confirm]; journeys</a:t>
+            </a:r>
+            <a:endParaRPr lang="en-US" sz="1000" dirty="0"/>
+          </a:p>
+        </p:txBody>
+      </p:sp>
+      <p:sp>
+        <p:nvSpPr>
+          <p:cNvPr id="60" name="Shape 58"/>
+          <p:cNvSpPr/>
+          <p:nvPr/>
+        </p:nvSpPr>
+        <p:spPr>
+          <a:xfrm>
+            <a:off x="10269757" y="3291840"/>
+            <a:ext cx="1318434" cy="0"/>
+          </a:xfrm>
+          <a:prstGeom prst="line">
+            <a:avLst/>
+          </a:prstGeom>
+          <a:noFill/>
+          <a:ln w="9525">
+            <a:solidFill>
+              <a:srgbClr val="D0D0D6"/>
+            </a:solidFill>
+            <a:prstDash val="solid"/>
+          </a:ln>
+        </p:spPr>
+      </p:sp>
+      <p:sp>
+        <p:nvSpPr>
+          <p:cNvPr id="61" name="Shape 59"/>
+          <p:cNvSpPr/>
+          <p:nvPr/>
+        </p:nvSpPr>
+        <p:spPr>
+          <a:xfrm>
+            <a:off x="10269757" y="3429000"/>
+            <a:ext cx="137160" cy="137160"/>
+          </a:xfrm>
+          <a:prstGeom prst="diamond">
+            <a:avLst/>
+          </a:prstGeom>
+          <a:solidFill>
+            <a:srgbClr val="000000"/>
+          </a:solidFill>
+          <a:ln w="12700">
+            <a:solidFill>
+              <a:srgbClr val="000000"/>
+            </a:solidFill>
+            <a:prstDash val="solid"/>
+          </a:ln>
+        </p:spPr>
+      </p:sp>
+      <p:sp>
+        <p:nvSpPr>
+          <p:cNvPr id="62" name="Text 60"/>
+          <p:cNvSpPr txBox="1"/>
+          <p:nvPr/>
+        </p:nvSpPr>
+        <p:spPr>
+          <a:xfrm>
+            <a:off x="10489213" y="3346704"/>
+            <a:ext cx="1098978" cy="402336"/>
+          </a:xfrm>
+          <a:prstGeom prst="rect">
+            <a:avLst/>
+          </a:prstGeom>
+          <a:noFill/>
+          <a:ln/>
+        </p:spPr>
+        <p:txBody>
+          <a:bodyPr wrap="square" lIns="0" tIns="0" rIns="0" bIns="0" rtlCol="0" anchor="t"/>
+          <a:lstStyle/>
+          <a:p>
+            <a:pPr indent="0" marL="0">
+              <a:buNone/>
+            </a:pPr>
+            <a:r>
+              <a:rPr lang="en-US" sz="950" b="1" dirty="0">
+                <a:solidFill>
+                  <a:srgbClr val="000000"/>
+                </a:solidFill>
+              </a:rPr>
+              <a:t>Check-in demo</a:t>
+            </a:r>
+            <a:endParaRPr lang="en-US" sz="950" dirty="0"/>
+          </a:p>
+        </p:txBody>
+      </p:sp>
+      <p:sp>
+        <p:nvSpPr>
+          <p:cNvPr id="63" name="sprint-8"/>
+          <p:cNvSpPr/>
+          <p:nvPr/>
+        </p:nvSpPr>
+        <p:spPr>
+          <a:xfrm>
+            <a:off x="502920" y="4251960"/>
+            <a:ext cx="1519602" cy="1691640"/>
+          </a:xfrm>
+          <a:prstGeom prst="roundRect">
+            <a:avLst>
+              <a:gd name="adj" fmla="val 6017"/>
+            </a:avLst>
+          </a:prstGeom>
+          <a:solidFill>
+            <a:srgbClr val="F2F2F2"/>
+          </a:solidFill>
+          <a:ln w="22225">
+            <a:solidFill>
+              <a:srgbClr val="FF0068"/>
+            </a:solidFill>
+            <a:prstDash val="solid"/>
+          </a:ln>
+        </p:spPr>
+      </p:sp>
+      <p:sp>
+        <p:nvSpPr>
+          <p:cNvPr id="64" name="Text 62"/>
+          <p:cNvSpPr txBox="1"/>
+          <p:nvPr/>
+        </p:nvSpPr>
+        <p:spPr>
+          <a:xfrm>
+            <a:off x="603504" y="4370832"/>
+            <a:ext cx="1318434" cy="219456"/>
+          </a:xfrm>
+          <a:prstGeom prst="rect">
+            <a:avLst/>
+          </a:prstGeom>
+          <a:noFill/>
+          <a:ln/>
+        </p:spPr>
+        <p:txBody>
+          <a:bodyPr wrap="square" lIns="0" tIns="0" rIns="0" bIns="0" rtlCol="0" anchor="t"/>
+          <a:lstStyle/>
+          <a:p>
+            <a:pPr indent="0" marL="0">
+              <a:buNone/>
+            </a:pPr>
+            <a:r>
+              <a:rPr lang="en-US" sz="1000" b="1" spc="200" kern="0" dirty="0">
+                <a:solidFill>
+                  <a:srgbClr val="C8005A"/>
+                </a:solidFill>
+              </a:rPr>
+              <a:t>SPRINT 8</a:t>
+            </a:r>
+            <a:endParaRPr lang="en-US" sz="1000" dirty="0"/>
+          </a:p>
+        </p:txBody>
+      </p:sp>
+      <p:sp>
+        <p:nvSpPr>
+          <p:cNvPr id="65" name="Text 63"/>
+          <p:cNvSpPr txBox="1"/>
+          <p:nvPr/>
+        </p:nvSpPr>
+        <p:spPr>
+          <a:xfrm>
+            <a:off x="603504" y="4599432"/>
+            <a:ext cx="1318434" cy="201168"/>
+          </a:xfrm>
+          <a:prstGeom prst="rect">
+            <a:avLst/>
+          </a:prstGeom>
+          <a:noFill/>
+          <a:ln/>
+        </p:spPr>
+        <p:txBody>
+          <a:bodyPr wrap="square" lIns="0" tIns="0" rIns="0" bIns="0" rtlCol="0" anchor="t"/>
+          <a:lstStyle/>
+          <a:p>
+            <a:pPr indent="0" marL="0">
+              <a:buNone/>
+            </a:pPr>
+            <a:r>
+              <a:rPr lang="en-US" sz="950" dirty="0">
+                <a:solidFill>
+                  <a:srgbClr val="4D4D4D"/>
+                </a:solidFill>
+              </a:rPr>
+              <a:t>Weeks 15-16</a:t>
+            </a:r>
+            <a:endParaRPr lang="en-US" sz="950" dirty="0"/>
+          </a:p>
+        </p:txBody>
+      </p:sp>
+      <p:sp>
+        <p:nvSpPr>
+          <p:cNvPr id="66" name="Text 64"/>
+          <p:cNvSpPr txBox="1"/>
+          <p:nvPr/>
+        </p:nvSpPr>
+        <p:spPr>
+          <a:xfrm>
+            <a:off x="603504" y="4837176"/>
+            <a:ext cx="1318434" cy="585216"/>
+          </a:xfrm>
+          <a:prstGeom prst="rect">
+            <a:avLst/>
+          </a:prstGeom>
+          <a:noFill/>
+          <a:ln/>
+        </p:spPr>
+        <p:txBody>
+          <a:bodyPr wrap="square" lIns="0" tIns="0" rIns="0" bIns="0" rtlCol="0" anchor="t"/>
+          <a:lstStyle/>
+          <a:p>
+            <a:pPr indent="0" marL="0">
+              <a:buNone/>
+            </a:pPr>
+            <a:r>
+              <a:rPr lang="en-US" sz="1000" dirty="0">
+                <a:solidFill>
+                  <a:srgbClr val="000000"/>
+                </a:solidFill>
+              </a:rPr>
+              <a:t>Conference reporting; load test</a:t>
+            </a:r>
+            <a:endParaRPr lang="en-US" sz="1000" dirty="0"/>
+          </a:p>
+        </p:txBody>
+      </p:sp>
+      <p:sp>
+        <p:nvSpPr>
+          <p:cNvPr id="67" name="Shape 65"/>
+          <p:cNvSpPr/>
+          <p:nvPr/>
+        </p:nvSpPr>
+        <p:spPr>
+          <a:xfrm>
+            <a:off x="603504" y="5440680"/>
+            <a:ext cx="1318434" cy="0"/>
+          </a:xfrm>
+          <a:prstGeom prst="line">
+            <a:avLst/>
+          </a:prstGeom>
+          <a:noFill/>
+          <a:ln w="9525">
+            <a:solidFill>
+              <a:srgbClr val="D0D0D6"/>
+            </a:solidFill>
+            <a:prstDash val="solid"/>
+          </a:ln>
+        </p:spPr>
+      </p:sp>
+      <p:sp>
+        <p:nvSpPr>
+          <p:cNvPr id="68" name="Shape 66"/>
+          <p:cNvSpPr/>
+          <p:nvPr/>
+        </p:nvSpPr>
+        <p:spPr>
+          <a:xfrm>
+            <a:off x="603504" y="5577840"/>
+            <a:ext cx="137160" cy="137160"/>
+          </a:xfrm>
+          <a:prstGeom prst="diamond">
+            <a:avLst/>
+          </a:prstGeom>
+          <a:solidFill>
+            <a:srgbClr val="000000"/>
+          </a:solidFill>
+          <a:ln w="12700">
+            <a:solidFill>
+              <a:srgbClr val="000000"/>
+            </a:solidFill>
+            <a:prstDash val="solid"/>
+          </a:ln>
+        </p:spPr>
+      </p:sp>
+      <p:sp>
+        <p:nvSpPr>
+          <p:cNvPr id="69" name="Text 67"/>
+          <p:cNvSpPr txBox="1"/>
+          <p:nvPr/>
+        </p:nvSpPr>
+        <p:spPr>
+          <a:xfrm>
+            <a:off x="822960" y="5495544"/>
+            <a:ext cx="1098978" cy="402336"/>
+          </a:xfrm>
+          <a:prstGeom prst="rect">
+            <a:avLst/>
+          </a:prstGeom>
+          <a:noFill/>
+          <a:ln/>
+        </p:spPr>
+        <p:txBody>
+          <a:bodyPr wrap="square" lIns="0" tIns="0" rIns="0" bIns="0" rtlCol="0" anchor="t"/>
+          <a:lstStyle/>
+          <a:p>
+            <a:pPr indent="0" marL="0">
+              <a:buNone/>
+            </a:pPr>
+            <a:r>
+              <a:rPr lang="en-US" sz="950" b="1" dirty="0">
+                <a:solidFill>
+                  <a:srgbClr val="000000"/>
+                </a:solidFill>
+              </a:rPr>
+              <a:t>Load test passed</a:t>
+            </a:r>
+            <a:endParaRPr lang="en-US" sz="950" dirty="0"/>
+          </a:p>
+        </p:txBody>
+      </p:sp>
+      <p:sp>
+        <p:nvSpPr>
+          <p:cNvPr id="70" name="sprint-9"/>
+          <p:cNvSpPr/>
+          <p:nvPr/>
+        </p:nvSpPr>
+        <p:spPr>
+          <a:xfrm>
+            <a:off x="2113962" y="4251960"/>
+            <a:ext cx="1519602" cy="1691640"/>
+          </a:xfrm>
+          <a:prstGeom prst="roundRect">
+            <a:avLst>
+              <a:gd name="adj" fmla="val 6017"/>
+            </a:avLst>
+          </a:prstGeom>
+          <a:solidFill>
+            <a:srgbClr val="F2F2F2"/>
+          </a:solidFill>
+          <a:ln w="22225">
+            <a:solidFill>
+              <a:srgbClr val="FF0068"/>
+            </a:solidFill>
+            <a:prstDash val="solid"/>
+          </a:ln>
+        </p:spPr>
+      </p:sp>
+      <p:sp>
+        <p:nvSpPr>
+          <p:cNvPr id="71" name="Text 69"/>
+          <p:cNvSpPr txBox="1"/>
+          <p:nvPr/>
+        </p:nvSpPr>
+        <p:spPr>
+          <a:xfrm>
+            <a:off x="2214546" y="4370832"/>
+            <a:ext cx="1318434" cy="219456"/>
+          </a:xfrm>
+          <a:prstGeom prst="rect">
+            <a:avLst/>
+          </a:prstGeom>
+          <a:noFill/>
+          <a:ln/>
+        </p:spPr>
+        <p:txBody>
+          <a:bodyPr wrap="square" lIns="0" tIns="0" rIns="0" bIns="0" rtlCol="0" anchor="t"/>
+          <a:lstStyle/>
+          <a:p>
+            <a:pPr indent="0" marL="0">
+              <a:buNone/>
+            </a:pPr>
+            <a:r>
+              <a:rPr lang="en-US" sz="1000" b="1" spc="200" kern="0" dirty="0">
+                <a:solidFill>
+                  <a:srgbClr val="C8005A"/>
+                </a:solidFill>
+              </a:rPr>
+              <a:t>SPRINT 9</a:t>
+            </a:r>
+            <a:endParaRPr lang="en-US" sz="1000" dirty="0"/>
+          </a:p>
+        </p:txBody>
+      </p:sp>
+      <p:sp>
+        <p:nvSpPr>
+          <p:cNvPr id="72" name="Text 70"/>
+          <p:cNvSpPr txBox="1"/>
+          <p:nvPr/>
+        </p:nvSpPr>
+        <p:spPr>
+          <a:xfrm>
+            <a:off x="2214546" y="4599432"/>
+            <a:ext cx="1318434" cy="201168"/>
+          </a:xfrm>
+          <a:prstGeom prst="rect">
+            <a:avLst/>
+          </a:prstGeom>
+          <a:noFill/>
+          <a:ln/>
+        </p:spPr>
+        <p:txBody>
+          <a:bodyPr wrap="square" lIns="0" tIns="0" rIns="0" bIns="0" rtlCol="0" anchor="t"/>
+          <a:lstStyle/>
+          <a:p>
+            <a:pPr indent="0" marL="0">
+              <a:buNone/>
+            </a:pPr>
+            <a:r>
+              <a:rPr lang="en-US" sz="950" dirty="0">
+                <a:solidFill>
+                  <a:srgbClr val="4D4D4D"/>
+                </a:solidFill>
+              </a:rPr>
+              <a:t>Weeks 17-18</a:t>
+            </a:r>
+            <a:endParaRPr lang="en-US" sz="950" dirty="0"/>
+          </a:p>
+        </p:txBody>
+      </p:sp>
+      <p:sp>
+        <p:nvSpPr>
+          <p:cNvPr id="73" name="Text 71"/>
+          <p:cNvSpPr txBox="1"/>
+          <p:nvPr/>
+        </p:nvSpPr>
+        <p:spPr>
+          <a:xfrm>
+            <a:off x="2214546" y="4837176"/>
+            <a:ext cx="1318434" cy="585216"/>
+          </a:xfrm>
+          <a:prstGeom prst="rect">
+            <a:avLst/>
+          </a:prstGeom>
+          <a:noFill/>
+          <a:ln/>
+        </p:spPr>
+        <p:txBody>
+          <a:bodyPr wrap="square" lIns="0" tIns="0" rIns="0" bIns="0" rtlCol="0" anchor="t"/>
+          <a:lstStyle/>
+          <a:p>
+            <a:pPr indent="0" marL="0">
+              <a:buNone/>
+            </a:pPr>
+            <a:r>
+              <a:rPr lang="en-US" sz="1000" dirty="0">
+                <a:solidFill>
+                  <a:srgbClr val="000000"/>
+                </a:solidFill>
+              </a:rPr>
+              <a:t>User testing and fixes</a:t>
+            </a:r>
+            <a:endParaRPr lang="en-US" sz="1000" dirty="0"/>
+          </a:p>
+        </p:txBody>
+      </p:sp>
+      <p:sp>
+        <p:nvSpPr>
+          <p:cNvPr id="74" name="Shape 72"/>
+          <p:cNvSpPr/>
+          <p:nvPr/>
+        </p:nvSpPr>
+        <p:spPr>
+          <a:xfrm>
+            <a:off x="2214546" y="5440680"/>
+            <a:ext cx="1318434" cy="0"/>
+          </a:xfrm>
+          <a:prstGeom prst="line">
+            <a:avLst/>
+          </a:prstGeom>
+          <a:noFill/>
+          <a:ln w="9525">
+            <a:solidFill>
+              <a:srgbClr val="D0D0D6"/>
+            </a:solidFill>
+            <a:prstDash val="solid"/>
+          </a:ln>
+        </p:spPr>
+      </p:sp>
+      <p:sp>
+        <p:nvSpPr>
+          <p:cNvPr id="75" name="Shape 73"/>
+          <p:cNvSpPr/>
+          <p:nvPr/>
+        </p:nvSpPr>
+        <p:spPr>
+          <a:xfrm>
+            <a:off x="2214546" y="5577840"/>
+            <a:ext cx="137160" cy="137160"/>
+          </a:xfrm>
+          <a:prstGeom prst="diamond">
+            <a:avLst/>
+          </a:prstGeom>
+          <a:solidFill>
+            <a:srgbClr val="000000"/>
+          </a:solidFill>
+          <a:ln w="12700">
+            <a:solidFill>
+              <a:srgbClr val="000000"/>
+            </a:solidFill>
+            <a:prstDash val="solid"/>
+          </a:ln>
+        </p:spPr>
+      </p:sp>
+      <p:sp>
+        <p:nvSpPr>
+          <p:cNvPr id="76" name="Text 74"/>
+          <p:cNvSpPr txBox="1"/>
+          <p:nvPr/>
+        </p:nvSpPr>
+        <p:spPr>
+          <a:xfrm>
+            <a:off x="2434002" y="5495544"/>
+            <a:ext cx="1098978" cy="402336"/>
+          </a:xfrm>
+          <a:prstGeom prst="rect">
+            <a:avLst/>
+          </a:prstGeom>
+          <a:noFill/>
+          <a:ln/>
+        </p:spPr>
+        <p:txBody>
+          <a:bodyPr wrap="square" lIns="0" tIns="0" rIns="0" bIns="0" rtlCol="0" anchor="t"/>
+          <a:lstStyle/>
+          <a:p>
+            <a:pPr indent="0" marL="0">
+              <a:buNone/>
+            </a:pPr>
+            <a:r>
+              <a:rPr lang="en-US" sz="950" b="1" dirty="0">
+                <a:solidFill>
+                  <a:srgbClr val="000000"/>
+                </a:solidFill>
+              </a:rPr>
+              <a:t>Testing sign-off</a:t>
+            </a:r>
+            <a:endParaRPr lang="en-US" sz="950" dirty="0"/>
+          </a:p>
+        </p:txBody>
+      </p:sp>
+      <p:sp>
+        <p:nvSpPr>
+          <p:cNvPr id="77" name="sprint-10"/>
+          <p:cNvSpPr/>
+          <p:nvPr/>
+        </p:nvSpPr>
+        <p:spPr>
+          <a:xfrm>
+            <a:off x="3725004" y="4251960"/>
+            <a:ext cx="1519602" cy="1691640"/>
+          </a:xfrm>
+          <a:prstGeom prst="roundRect">
+            <a:avLst>
+              <a:gd name="adj" fmla="val 6017"/>
             </a:avLst>
           </a:prstGeom>
           <a:solidFill>
@@ -18353,14 +19229,14 @@
       </p:sp>
       <p:sp>
         <p:nvSpPr>
-          <p:cNvPr id="50" name="Text 48"/>
-          <p:cNvSpPr txBox="1"/>
-          <p:nvPr/>
-        </p:nvSpPr>
-        <p:spPr>
-          <a:xfrm>
-            <a:off x="640080" y="4370832"/>
-            <a:ext cx="1860438" cy="219456"/>
+          <p:cNvPr id="78" name="Text 76"/>
+          <p:cNvSpPr txBox="1"/>
+          <p:nvPr/>
+        </p:nvSpPr>
+        <p:spPr>
+          <a:xfrm>
+            <a:off x="3825588" y="4370832"/>
+            <a:ext cx="1318434" cy="219456"/>
           </a:xfrm>
           <a:prstGeom prst="rect">
             <a:avLst/>
@@ -18376,27 +19252,27 @@
               <a:buNone/>
             </a:pPr>
             <a:r>
-              <a:rPr lang="en-US" sz="1100" b="1" spc="200" kern="0" dirty="0">
+              <a:rPr lang="en-US" sz="1000" b="1" spc="200" kern="0" dirty="0">
                 <a:solidFill>
                   <a:srgbClr val="FF0068"/>
                 </a:solidFill>
               </a:rPr>
-              <a:t>SPRINT 6</a:t>
-            </a:r>
-            <a:endParaRPr lang="en-US" sz="1100" dirty="0"/>
-          </a:p>
-        </p:txBody>
-      </p:sp>
-      <p:sp>
-        <p:nvSpPr>
-          <p:cNvPr id="51" name="Text 49"/>
-          <p:cNvSpPr txBox="1"/>
-          <p:nvPr/>
-        </p:nvSpPr>
-        <p:spPr>
-          <a:xfrm>
-            <a:off x="640080" y="4599432"/>
-            <a:ext cx="1860438" cy="201168"/>
+              <a:t>SPRINT 10</a:t>
+            </a:r>
+            <a:endParaRPr lang="en-US" sz="1000" dirty="0"/>
+          </a:p>
+        </p:txBody>
+      </p:sp>
+      <p:sp>
+        <p:nvSpPr>
+          <p:cNvPr id="79" name="Text 77"/>
+          <p:cNvSpPr txBox="1"/>
+          <p:nvPr/>
+        </p:nvSpPr>
+        <p:spPr>
+          <a:xfrm>
+            <a:off x="3825588" y="4599432"/>
+            <a:ext cx="1318434" cy="201168"/>
           </a:xfrm>
           <a:prstGeom prst="rect">
             <a:avLst/>
@@ -18412,12 +19288,48 @@
               <a:buNone/>
             </a:pPr>
             <a:r>
+              <a:rPr lang="en-US" sz="950" dirty="0">
+                <a:solidFill>
+                  <a:srgbClr val="D9D9D9"/>
+                </a:solidFill>
+              </a:rPr>
+              <a:t>Weeks 19-20</a:t>
+            </a:r>
+            <a:endParaRPr lang="en-US" sz="950" dirty="0"/>
+          </a:p>
+        </p:txBody>
+      </p:sp>
+      <p:sp>
+        <p:nvSpPr>
+          <p:cNvPr id="80" name="Text 78"/>
+          <p:cNvSpPr txBox="1"/>
+          <p:nvPr/>
+        </p:nvSpPr>
+        <p:spPr>
+          <a:xfrm>
+            <a:off x="3825588" y="4837176"/>
+            <a:ext cx="1318434" cy="585216"/>
+          </a:xfrm>
+          <a:prstGeom prst="rect">
+            <a:avLst/>
+          </a:prstGeom>
+          <a:noFill/>
+          <a:ln/>
+        </p:spPr>
+        <p:txBody>
+          <a:bodyPr wrap="square" lIns="0" tIns="0" rIns="0" bIns="0" rtlCol="0" anchor="t"/>
+          <a:lstStyle/>
+          <a:p>
+            <a:pPr indent="0" marL="0">
+              <a:buNone/>
+            </a:pPr>
+            <a:r>
               <a:rPr lang="en-US" sz="1000" dirty="0">
                 <a:solidFill>
-                  <a:srgbClr val="D9D9D9"/>
-                </a:solidFill>
-              </a:rPr>
-              <a:t>Weeks 11-12</a:t>
+                  <a:srgbClr val="FFFFFF"/>
+                </a:solidFill>
+              </a:rPr>
+              <a:t>Final data load, go-live, hypercare</a:t>
             </a:r>
             <a:endParaRPr lang="en-US" sz="1000" dirty="0"/>
           </a:p>
@@ -18425,50 +19337,14 @@
       </p:sp>
       <p:sp>
         <p:nvSpPr>
-          <p:cNvPr id="52" name="Text 50"/>
-          <p:cNvSpPr txBox="1"/>
-          <p:nvPr/>
-        </p:nvSpPr>
-        <p:spPr>
-          <a:xfrm>
-            <a:off x="640080" y="4855464"/>
-            <a:ext cx="1860438" cy="603504"/>
-          </a:xfrm>
-          <a:prstGeom prst="rect">
-            <a:avLst/>
-          </a:prstGeom>
-          <a:noFill/>
-          <a:ln/>
-        </p:spPr>
-        <p:txBody>
-          <a:bodyPr wrap="square" lIns="0" tIns="0" rIns="0" bIns="0" rtlCol="0" anchor="t"/>
-          <a:lstStyle/>
-          <a:p>
-            <a:pPr indent="0" marL="0">
-              <a:buNone/>
-            </a:pPr>
-            <a:r>
-              <a:rPr lang="en-US" sz="1100" dirty="0">
-                <a:solidFill>
-                  <a:srgbClr val="FFFFFF"/>
-                </a:solidFill>
-              </a:rPr>
-              <a:t>Final data load, conference go-live, hypercare</a:t>
-            </a:r>
-            <a:endParaRPr lang="en-US" sz="1100" dirty="0"/>
-          </a:p>
-        </p:txBody>
-      </p:sp>
-      <p:sp>
-        <p:nvSpPr>
-          <p:cNvPr id="53" name="Shape 51"/>
+          <p:cNvPr id="81" name="Shape 79"/>
           <p:cNvSpPr/>
           <p:nvPr/>
         </p:nvSpPr>
         <p:spPr>
           <a:xfrm>
-            <a:off x="640080" y="5440680"/>
-            <a:ext cx="1860438" cy="0"/>
+            <a:off x="3825588" y="5440680"/>
+            <a:ext cx="1318434" cy="0"/>
           </a:xfrm>
           <a:prstGeom prst="line">
             <a:avLst/>
@@ -18484,14 +19360,14 @@
       </p:sp>
       <p:sp>
         <p:nvSpPr>
-          <p:cNvPr id="54" name="Shape 52"/>
+          <p:cNvPr id="82" name="Shape 80"/>
           <p:cNvSpPr/>
           <p:nvPr/>
         </p:nvSpPr>
         <p:spPr>
           <a:xfrm>
-            <a:off x="640080" y="5577840"/>
-            <a:ext cx="155448" cy="155448"/>
+            <a:off x="3825588" y="5577840"/>
+            <a:ext cx="137160" cy="137160"/>
           </a:xfrm>
           <a:prstGeom prst="diamond">
             <a:avLst/>
@@ -18509,14 +19385,14 @@
       </p:sp>
       <p:sp>
         <p:nvSpPr>
-          <p:cNvPr id="55" name="Text 53"/>
-          <p:cNvSpPr txBox="1"/>
-          <p:nvPr/>
-        </p:nvSpPr>
-        <p:spPr>
-          <a:xfrm>
-            <a:off x="886968" y="5513832"/>
-            <a:ext cx="1631838" cy="384048"/>
+          <p:cNvPr id="83" name="Text 81"/>
+          <p:cNvSpPr txBox="1"/>
+          <p:nvPr/>
+        </p:nvSpPr>
+        <p:spPr>
+          <a:xfrm>
+            <a:off x="4045044" y="5495544"/>
+            <a:ext cx="1098978" cy="402336"/>
           </a:xfrm>
           <a:prstGeom prst="rect">
             <a:avLst/>
@@ -18532,31 +19408,31 @@
               <a:buNone/>
             </a:pPr>
             <a:r>
-              <a:rPr lang="en-US" sz="1050" b="1" dirty="0">
+              <a:rPr lang="en-US" sz="950" b="1" dirty="0">
                 <a:solidFill>
                   <a:srgbClr val="FFFFFF"/>
                 </a:solidFill>
               </a:rPr>
               <a:t>Phase 1 live, Certain retired</a:t>
             </a:r>
-            <a:endParaRPr lang="en-US" sz="1050" dirty="0"/>
-          </a:p>
-        </p:txBody>
-      </p:sp>
-      <p:sp>
-        <p:nvSpPr>
-          <p:cNvPr id="56" name="sprint-7"/>
+            <a:endParaRPr lang="en-US" sz="950" dirty="0"/>
+          </a:p>
+        </p:txBody>
+      </p:sp>
+      <p:sp>
+        <p:nvSpPr>
+          <p:cNvPr id="84" name="sprint-11"/>
           <p:cNvSpPr/>
           <p:nvPr/>
         </p:nvSpPr>
         <p:spPr>
           <a:xfrm>
-            <a:off x="2765694" y="4251960"/>
-            <a:ext cx="2134758" cy="1691640"/>
+            <a:off x="5336047" y="4251960"/>
+            <a:ext cx="1519602" cy="1691640"/>
           </a:xfrm>
           <a:prstGeom prst="roundRect">
             <a:avLst>
-              <a:gd name="adj" fmla="val 5405"/>
+              <a:gd name="adj" fmla="val 6017"/>
             </a:avLst>
           </a:prstGeom>
           <a:solidFill>
@@ -18572,14 +19448,14 @@
       </p:sp>
       <p:sp>
         <p:nvSpPr>
-          <p:cNvPr id="57" name="Text 55"/>
-          <p:cNvSpPr txBox="1"/>
-          <p:nvPr/>
-        </p:nvSpPr>
-        <p:spPr>
-          <a:xfrm>
-            <a:off x="2902854" y="4370832"/>
-            <a:ext cx="1860438" cy="219456"/>
+          <p:cNvPr id="85" name="Text 83"/>
+          <p:cNvSpPr txBox="1"/>
+          <p:nvPr/>
+        </p:nvSpPr>
+        <p:spPr>
+          <a:xfrm>
+            <a:off x="5436631" y="4370832"/>
+            <a:ext cx="1318434" cy="219456"/>
           </a:xfrm>
           <a:prstGeom prst="rect">
             <a:avLst/>
@@ -18595,27 +19471,27 @@
               <a:buNone/>
             </a:pPr>
             <a:r>
-              <a:rPr lang="en-US" sz="1100" b="1" spc="200" kern="0" dirty="0">
+              <a:rPr lang="en-US" sz="1000" b="1" spc="200" kern="0" dirty="0">
                 <a:solidFill>
                   <a:srgbClr val="7A6100"/>
                 </a:solidFill>
               </a:rPr>
-              <a:t>SPRINT 7</a:t>
-            </a:r>
-            <a:endParaRPr lang="en-US" sz="1100" dirty="0"/>
-          </a:p>
-        </p:txBody>
-      </p:sp>
-      <p:sp>
-        <p:nvSpPr>
-          <p:cNvPr id="58" name="Text 56"/>
-          <p:cNvSpPr txBox="1"/>
-          <p:nvPr/>
-        </p:nvSpPr>
-        <p:spPr>
-          <a:xfrm>
-            <a:off x="2902854" y="4599432"/>
-            <a:ext cx="1860438" cy="201168"/>
+              <a:t>SPRINT 11</a:t>
+            </a:r>
+            <a:endParaRPr lang="en-US" sz="1000" dirty="0"/>
+          </a:p>
+        </p:txBody>
+      </p:sp>
+      <p:sp>
+        <p:nvSpPr>
+          <p:cNvPr id="86" name="Text 84"/>
+          <p:cNvSpPr txBox="1"/>
+          <p:nvPr/>
+        </p:nvSpPr>
+        <p:spPr>
+          <a:xfrm>
+            <a:off x="5436631" y="4599432"/>
+            <a:ext cx="1318434" cy="201168"/>
           </a:xfrm>
           <a:prstGeom prst="rect">
             <a:avLst/>
@@ -18631,12 +19507,48 @@
               <a:buNone/>
             </a:pPr>
             <a:r>
+              <a:rPr lang="en-US" sz="950" dirty="0">
+                <a:solidFill>
+                  <a:srgbClr val="4D4D4D"/>
+                </a:solidFill>
+              </a:rPr>
+              <a:t>Weeks 21-22</a:t>
+            </a:r>
+            <a:endParaRPr lang="en-US" sz="950" dirty="0"/>
+          </a:p>
+        </p:txBody>
+      </p:sp>
+      <p:sp>
+        <p:nvSpPr>
+          <p:cNvPr id="87" name="Text 85"/>
+          <p:cNvSpPr txBox="1"/>
+          <p:nvPr/>
+        </p:nvSpPr>
+        <p:spPr>
+          <a:xfrm>
+            <a:off x="5436631" y="4837176"/>
+            <a:ext cx="1318434" cy="585216"/>
+          </a:xfrm>
+          <a:prstGeom prst="rect">
+            <a:avLst/>
+          </a:prstGeom>
+          <a:noFill/>
+          <a:ln/>
+        </p:spPr>
+        <p:txBody>
+          <a:bodyPr wrap="square" lIns="0" tIns="0" rIns="0" bIns="0" rtlCol="0" anchor="t"/>
+          <a:lstStyle/>
+          <a:p>
+            <a:pPr indent="0" marL="0">
+              <a:buNone/>
+            </a:pPr>
+            <a:r>
               <a:rPr lang="en-US" sz="1000" dirty="0">
                 <a:solidFill>
-                  <a:srgbClr val="4D4D4D"/>
-                </a:solidFill>
-              </a:rPr>
-              <a:t>Weeks 13-14</a:t>
+                  <a:srgbClr val="000000"/>
+                </a:solidFill>
+              </a:rPr>
+              <a:t>Classes onto the shared model; instant confirmation, waitlists</a:t>
             </a:r>
             <a:endParaRPr lang="en-US" sz="1000" dirty="0"/>
           </a:p>
@@ -18644,50 +19556,14 @@
       </p:sp>
       <p:sp>
         <p:nvSpPr>
-          <p:cNvPr id="59" name="Text 57"/>
-          <p:cNvSpPr txBox="1"/>
-          <p:nvPr/>
-        </p:nvSpPr>
-        <p:spPr>
-          <a:xfrm>
-            <a:off x="2902854" y="4855464"/>
-            <a:ext cx="1860438" cy="603504"/>
-          </a:xfrm>
-          <a:prstGeom prst="rect">
-            <a:avLst/>
-          </a:prstGeom>
-          <a:noFill/>
-          <a:ln/>
-        </p:spPr>
-        <p:txBody>
-          <a:bodyPr wrap="square" lIns="0" tIns="0" rIns="0" bIns="0" rtlCol="0" anchor="t"/>
-          <a:lstStyle/>
-          <a:p>
-            <a:pPr indent="0" marL="0">
-              <a:buNone/>
-            </a:pPr>
-            <a:r>
-              <a:rPr lang="en-US" sz="1100" dirty="0">
-                <a:solidFill>
-                  <a:srgbClr val="000000"/>
-                </a:solidFill>
-              </a:rPr>
-              <a:t>Classes onto the shared model by extending today’s objects</a:t>
-            </a:r>
-            <a:endParaRPr lang="en-US" sz="1100" dirty="0"/>
-          </a:p>
-        </p:txBody>
-      </p:sp>
-      <p:sp>
-        <p:nvSpPr>
-          <p:cNvPr id="60" name="Shape 58"/>
+          <p:cNvPr id="88" name="Shape 86"/>
           <p:cNvSpPr/>
           <p:nvPr/>
         </p:nvSpPr>
         <p:spPr>
           <a:xfrm>
-            <a:off x="2902854" y="5440680"/>
-            <a:ext cx="1860438" cy="0"/>
+            <a:off x="5436631" y="5440680"/>
+            <a:ext cx="1318434" cy="0"/>
           </a:xfrm>
           <a:prstGeom prst="line">
             <a:avLst/>
@@ -18703,14 +19579,14 @@
       </p:sp>
       <p:sp>
         <p:nvSpPr>
-          <p:cNvPr id="61" name="Shape 59"/>
+          <p:cNvPr id="89" name="Shape 87"/>
           <p:cNvSpPr/>
           <p:nvPr/>
         </p:nvSpPr>
         <p:spPr>
           <a:xfrm>
-            <a:off x="2902854" y="5577840"/>
-            <a:ext cx="155448" cy="155448"/>
+            <a:off x="5436631" y="5577840"/>
+            <a:ext cx="137160" cy="137160"/>
           </a:xfrm>
           <a:prstGeom prst="diamond">
             <a:avLst/>
@@ -18728,14 +19604,14 @@
       </p:sp>
       <p:sp>
         <p:nvSpPr>
-          <p:cNvPr id="62" name="Text 60"/>
-          <p:cNvSpPr txBox="1"/>
-          <p:nvPr/>
-        </p:nvSpPr>
-        <p:spPr>
-          <a:xfrm>
-            <a:off x="3149742" y="5513832"/>
-            <a:ext cx="1631838" cy="384048"/>
+          <p:cNvPr id="90" name="Text 88"/>
+          <p:cNvSpPr txBox="1"/>
+          <p:nvPr/>
+        </p:nvSpPr>
+        <p:spPr>
+          <a:xfrm>
+            <a:off x="5656087" y="5495544"/>
+            <a:ext cx="1098978" cy="402336"/>
           </a:xfrm>
           <a:prstGeom prst="rect">
             <a:avLst/>
@@ -18751,31 +19627,31 @@
               <a:buNone/>
             </a:pPr>
             <a:r>
-              <a:rPr lang="en-US" sz="1050" b="1" dirty="0">
+              <a:rPr lang="en-US" sz="950" b="1" dirty="0">
                 <a:solidFill>
                   <a:srgbClr val="000000"/>
                 </a:solidFill>
               </a:rPr>
               <a:t>Classes on shared model</a:t>
             </a:r>
-            <a:endParaRPr lang="en-US" sz="1050" dirty="0"/>
-          </a:p>
-        </p:txBody>
-      </p:sp>
-      <p:sp>
-        <p:nvSpPr>
-          <p:cNvPr id="63" name="sprint-8"/>
+            <a:endParaRPr lang="en-US" sz="950" dirty="0"/>
+          </a:p>
+        </p:txBody>
+      </p:sp>
+      <p:sp>
+        <p:nvSpPr>
+          <p:cNvPr id="91" name="sprint-12"/>
           <p:cNvSpPr/>
           <p:nvPr/>
         </p:nvSpPr>
         <p:spPr>
           <a:xfrm>
-            <a:off x="5028468" y="4251960"/>
-            <a:ext cx="2134758" cy="1691640"/>
+            <a:off x="6947089" y="4251960"/>
+            <a:ext cx="1519602" cy="1691640"/>
           </a:xfrm>
           <a:prstGeom prst="roundRect">
             <a:avLst>
-              <a:gd name="adj" fmla="val 5405"/>
+              <a:gd name="adj" fmla="val 6017"/>
             </a:avLst>
           </a:prstGeom>
           <a:solidFill>
@@ -18791,14 +19667,14 @@
       </p:sp>
       <p:sp>
         <p:nvSpPr>
-          <p:cNvPr id="64" name="Text 62"/>
-          <p:cNvSpPr txBox="1"/>
-          <p:nvPr/>
-        </p:nvSpPr>
-        <p:spPr>
-          <a:xfrm>
-            <a:off x="5165628" y="4370832"/>
-            <a:ext cx="1860438" cy="219456"/>
+          <p:cNvPr id="92" name="Text 90"/>
+          <p:cNvSpPr txBox="1"/>
+          <p:nvPr/>
+        </p:nvSpPr>
+        <p:spPr>
+          <a:xfrm>
+            <a:off x="7047673" y="4370832"/>
+            <a:ext cx="1318434" cy="219456"/>
           </a:xfrm>
           <a:prstGeom prst="rect">
             <a:avLst/>
@@ -18814,27 +19690,27 @@
               <a:buNone/>
             </a:pPr>
             <a:r>
-              <a:rPr lang="en-US" sz="1100" b="1" spc="200" kern="0" dirty="0">
+              <a:rPr lang="en-US" sz="1000" b="1" spc="200" kern="0" dirty="0">
                 <a:solidFill>
                   <a:srgbClr val="7A6100"/>
                 </a:solidFill>
               </a:rPr>
-              <a:t>SPRINT 8</a:t>
-            </a:r>
-            <a:endParaRPr lang="en-US" sz="1100" dirty="0"/>
-          </a:p>
-        </p:txBody>
-      </p:sp>
-      <p:sp>
-        <p:nvSpPr>
-          <p:cNvPr id="65" name="Text 63"/>
-          <p:cNvSpPr txBox="1"/>
-          <p:nvPr/>
-        </p:nvSpPr>
-        <p:spPr>
-          <a:xfrm>
-            <a:off x="5165628" y="4599432"/>
-            <a:ext cx="1860438" cy="201168"/>
+              <a:t>SPRINT 12</a:t>
+            </a:r>
+            <a:endParaRPr lang="en-US" sz="1000" dirty="0"/>
+          </a:p>
+        </p:txBody>
+      </p:sp>
+      <p:sp>
+        <p:nvSpPr>
+          <p:cNvPr id="93" name="Text 91"/>
+          <p:cNvSpPr txBox="1"/>
+          <p:nvPr/>
+        </p:nvSpPr>
+        <p:spPr>
+          <a:xfrm>
+            <a:off x="7047673" y="4599432"/>
+            <a:ext cx="1318434" cy="201168"/>
           </a:xfrm>
           <a:prstGeom prst="rect">
             <a:avLst/>
@@ -18850,12 +19726,48 @@
               <a:buNone/>
             </a:pPr>
             <a:r>
+              <a:rPr lang="en-US" sz="950" dirty="0">
+                <a:solidFill>
+                  <a:srgbClr val="4D4D4D"/>
+                </a:solidFill>
+              </a:rPr>
+              <a:t>Weeks 23-24</a:t>
+            </a:r>
+            <a:endParaRPr lang="en-US" sz="950" dirty="0"/>
+          </a:p>
+        </p:txBody>
+      </p:sp>
+      <p:sp>
+        <p:nvSpPr>
+          <p:cNvPr id="94" name="Text 92"/>
+          <p:cNvSpPr txBox="1"/>
+          <p:nvPr/>
+        </p:nvSpPr>
+        <p:spPr>
+          <a:xfrm>
+            <a:off x="7047673" y="4837176"/>
+            <a:ext cx="1318434" cy="585216"/>
+          </a:xfrm>
+          <a:prstGeom prst="rect">
+            <a:avLst/>
+          </a:prstGeom>
+          <a:noFill/>
+          <a:ln/>
+        </p:spPr>
+        <p:txBody>
+          <a:bodyPr wrap="square" lIns="0" tIns="0" rIns="0" bIns="0" rtlCol="0" anchor="t"/>
+          <a:lstStyle/>
+          <a:p>
+            <a:pPr indent="0" marL="0">
+              <a:buNone/>
+            </a:pPr>
+            <a:r>
               <a:rPr lang="en-US" sz="1000" dirty="0">
                 <a:solidFill>
-                  <a:srgbClr val="4D4D4D"/>
-                </a:solidFill>
-              </a:rPr>
-              <a:t>Weeks 15-16</a:t>
+                  <a:srgbClr val="000000"/>
+                </a:solidFill>
+              </a:rPr>
+              <a:t>QR check-in, reporting, app connected; user testing</a:t>
             </a:r>
             <a:endParaRPr lang="en-US" sz="1000" dirty="0"/>
           </a:p>
@@ -18863,50 +19775,14 @@
       </p:sp>
       <p:sp>
         <p:nvSpPr>
-          <p:cNvPr id="66" name="Text 64"/>
-          <p:cNvSpPr txBox="1"/>
-          <p:nvPr/>
-        </p:nvSpPr>
-        <p:spPr>
-          <a:xfrm>
-            <a:off x="5165628" y="4855464"/>
-            <a:ext cx="1860438" cy="603504"/>
-          </a:xfrm>
-          <a:prstGeom prst="rect">
-            <a:avLst/>
-          </a:prstGeom>
-          <a:noFill/>
-          <a:ln/>
-        </p:spPr>
-        <p:txBody>
-          <a:bodyPr wrap="square" lIns="0" tIns="0" rIns="0" bIns="0" rtlCol="0" anchor="t"/>
-          <a:lstStyle/>
-          <a:p>
-            <a:pPr indent="0" marL="0">
-              <a:buNone/>
-            </a:pPr>
-            <a:r>
-              <a:rPr lang="en-US" sz="1100" dirty="0">
-                <a:solidFill>
-                  <a:srgbClr val="000000"/>
-                </a:solidFill>
-              </a:rPr>
-              <a:t>Instant confirmation, safe payment retries, waitlists</a:t>
-            </a:r>
-            <a:endParaRPr lang="en-US" sz="1100" dirty="0"/>
-          </a:p>
-        </p:txBody>
-      </p:sp>
-      <p:sp>
-        <p:nvSpPr>
-          <p:cNvPr id="67" name="Shape 65"/>
+          <p:cNvPr id="95" name="Shape 93"/>
           <p:cNvSpPr/>
           <p:nvPr/>
         </p:nvSpPr>
         <p:spPr>
           <a:xfrm>
-            <a:off x="5165628" y="5440680"/>
-            <a:ext cx="1860438" cy="0"/>
+            <a:off x="7047673" y="5440680"/>
+            <a:ext cx="1318434" cy="0"/>
           </a:xfrm>
           <a:prstGeom prst="line">
             <a:avLst/>
@@ -18922,14 +19798,14 @@
       </p:sp>
       <p:sp>
         <p:nvSpPr>
-          <p:cNvPr id="68" name="Shape 66"/>
+          <p:cNvPr id="96" name="Shape 94"/>
           <p:cNvSpPr/>
           <p:nvPr/>
         </p:nvSpPr>
         <p:spPr>
           <a:xfrm>
-            <a:off x="5165628" y="5577840"/>
-            <a:ext cx="155448" cy="155448"/>
+            <a:off x="7047673" y="5577840"/>
+            <a:ext cx="137160" cy="137160"/>
           </a:xfrm>
           <a:prstGeom prst="diamond">
             <a:avLst/>
@@ -18947,14 +19823,14 @@
       </p:sp>
       <p:sp>
         <p:nvSpPr>
-          <p:cNvPr id="69" name="Text 67"/>
-          <p:cNvSpPr txBox="1"/>
-          <p:nvPr/>
-        </p:nvSpPr>
-        <p:spPr>
-          <a:xfrm>
-            <a:off x="5412516" y="5513832"/>
-            <a:ext cx="1631838" cy="384048"/>
+          <p:cNvPr id="97" name="Text 95"/>
+          <p:cNvSpPr txBox="1"/>
+          <p:nvPr/>
+        </p:nvSpPr>
+        <p:spPr>
+          <a:xfrm>
+            <a:off x="7267129" y="5495544"/>
+            <a:ext cx="1098978" cy="402336"/>
           </a:xfrm>
           <a:prstGeom prst="rect">
             <a:avLst/>
@@ -18970,250 +19846,31 @@
               <a:buNone/>
             </a:pPr>
             <a:r>
-              <a:rPr lang="en-US" sz="1050" b="1" dirty="0">
+              <a:rPr lang="en-US" sz="950" b="1" dirty="0">
                 <a:solidFill>
                   <a:srgbClr val="000000"/>
                 </a:solidFill>
               </a:rPr>
-              <a:t>Registration improvements demo</a:t>
-            </a:r>
-            <a:endParaRPr lang="en-US" sz="1050" dirty="0"/>
-          </a:p>
-        </p:txBody>
-      </p:sp>
-      <p:sp>
-        <p:nvSpPr>
-          <p:cNvPr id="70" name="sprint-9"/>
+              <a:t>Testing sign-off</a:t>
+            </a:r>
+            <a:endParaRPr lang="en-US" sz="950" dirty="0"/>
+          </a:p>
+        </p:txBody>
+      </p:sp>
+      <p:sp>
+        <p:nvSpPr>
+          <p:cNvPr id="98" name="sprint-13"/>
           <p:cNvSpPr/>
           <p:nvPr/>
         </p:nvSpPr>
         <p:spPr>
           <a:xfrm>
-            <a:off x="7291243" y="4251960"/>
-            <a:ext cx="2134758" cy="1691640"/>
+            <a:off x="8558131" y="4251960"/>
+            <a:ext cx="1519602" cy="1691640"/>
           </a:xfrm>
           <a:prstGeom prst="roundRect">
             <a:avLst>
-              <a:gd name="adj" fmla="val 5405"/>
-            </a:avLst>
-          </a:prstGeom>
-          <a:solidFill>
-            <a:srgbClr val="F2F2F2"/>
-          </a:solidFill>
-          <a:ln w="22225">
-            <a:solidFill>
-              <a:srgbClr val="D9B200"/>
-            </a:solidFill>
-            <a:prstDash val="solid"/>
-          </a:ln>
-        </p:spPr>
-      </p:sp>
-      <p:sp>
-        <p:nvSpPr>
-          <p:cNvPr id="71" name="Text 69"/>
-          <p:cNvSpPr txBox="1"/>
-          <p:nvPr/>
-        </p:nvSpPr>
-        <p:spPr>
-          <a:xfrm>
-            <a:off x="7428403" y="4370832"/>
-            <a:ext cx="1860438" cy="219456"/>
-          </a:xfrm>
-          <a:prstGeom prst="rect">
-            <a:avLst/>
-          </a:prstGeom>
-          <a:noFill/>
-          <a:ln/>
-        </p:spPr>
-        <p:txBody>
-          <a:bodyPr wrap="square" lIns="0" tIns="0" rIns="0" bIns="0" rtlCol="0" anchor="t"/>
-          <a:lstStyle/>
-          <a:p>
-            <a:pPr indent="0" marL="0">
-              <a:buNone/>
-            </a:pPr>
-            <a:r>
-              <a:rPr lang="en-US" sz="1100" b="1" spc="200" kern="0" dirty="0">
-                <a:solidFill>
-                  <a:srgbClr val="7A6100"/>
-                </a:solidFill>
-              </a:rPr>
-              <a:t>SPRINT 9</a:t>
-            </a:r>
-            <a:endParaRPr lang="en-US" sz="1100" dirty="0"/>
-          </a:p>
-        </p:txBody>
-      </p:sp>
-      <p:sp>
-        <p:nvSpPr>
-          <p:cNvPr id="72" name="Text 70"/>
-          <p:cNvSpPr txBox="1"/>
-          <p:nvPr/>
-        </p:nvSpPr>
-        <p:spPr>
-          <a:xfrm>
-            <a:off x="7428403" y="4599432"/>
-            <a:ext cx="1860438" cy="201168"/>
-          </a:xfrm>
-          <a:prstGeom prst="rect">
-            <a:avLst/>
-          </a:prstGeom>
-          <a:noFill/>
-          <a:ln/>
-        </p:spPr>
-        <p:txBody>
-          <a:bodyPr wrap="square" lIns="0" tIns="0" rIns="0" bIns="0" rtlCol="0" anchor="t"/>
-          <a:lstStyle/>
-          <a:p>
-            <a:pPr indent="0" marL="0">
-              <a:buNone/>
-            </a:pPr>
-            <a:r>
-              <a:rPr lang="en-US" sz="1000" dirty="0">
-                <a:solidFill>
-                  <a:srgbClr val="4D4D4D"/>
-                </a:solidFill>
-              </a:rPr>
-              <a:t>Weeks 17-18</a:t>
-            </a:r>
-            <a:endParaRPr lang="en-US" sz="1000" dirty="0"/>
-          </a:p>
-        </p:txBody>
-      </p:sp>
-      <p:sp>
-        <p:nvSpPr>
-          <p:cNvPr id="73" name="Text 71"/>
-          <p:cNvSpPr txBox="1"/>
-          <p:nvPr/>
-        </p:nvSpPr>
-        <p:spPr>
-          <a:xfrm>
-            <a:off x="7428403" y="4855464"/>
-            <a:ext cx="1860438" cy="603504"/>
-          </a:xfrm>
-          <a:prstGeom prst="rect">
-            <a:avLst/>
-          </a:prstGeom>
-          <a:noFill/>
-          <a:ln/>
-        </p:spPr>
-        <p:txBody>
-          <a:bodyPr wrap="square" lIns="0" tIns="0" rIns="0" bIns="0" rtlCol="0" anchor="t"/>
-          <a:lstStyle/>
-          <a:p>
-            <a:pPr indent="0" marL="0">
-              <a:buNone/>
-            </a:pPr>
-            <a:r>
-              <a:rPr lang="en-US" sz="1100" dirty="0">
-                <a:solidFill>
-                  <a:srgbClr val="000000"/>
-                </a:solidFill>
-              </a:rPr>
-              <a:t>QR check-in, reporting, app connected, PEI journeys</a:t>
-            </a:r>
-            <a:endParaRPr lang="en-US" sz="1100" dirty="0"/>
-          </a:p>
-        </p:txBody>
-      </p:sp>
-      <p:sp>
-        <p:nvSpPr>
-          <p:cNvPr id="74" name="Shape 72"/>
-          <p:cNvSpPr/>
-          <p:nvPr/>
-        </p:nvSpPr>
-        <p:spPr>
-          <a:xfrm>
-            <a:off x="7428403" y="5440680"/>
-            <a:ext cx="1860438" cy="0"/>
-          </a:xfrm>
-          <a:prstGeom prst="line">
-            <a:avLst/>
-          </a:prstGeom>
-          <a:noFill/>
-          <a:ln w="9525">
-            <a:solidFill>
-              <a:srgbClr val="D0D0D6"/>
-            </a:solidFill>
-            <a:prstDash val="solid"/>
-          </a:ln>
-        </p:spPr>
-      </p:sp>
-      <p:sp>
-        <p:nvSpPr>
-          <p:cNvPr id="75" name="Shape 73"/>
-          <p:cNvSpPr/>
-          <p:nvPr/>
-        </p:nvSpPr>
-        <p:spPr>
-          <a:xfrm>
-            <a:off x="7428403" y="5577840"/>
-            <a:ext cx="155448" cy="155448"/>
-          </a:xfrm>
-          <a:prstGeom prst="diamond">
-            <a:avLst/>
-          </a:prstGeom>
-          <a:solidFill>
-            <a:srgbClr val="000000"/>
-          </a:solidFill>
-          <a:ln w="12700">
-            <a:solidFill>
-              <a:srgbClr val="000000"/>
-            </a:solidFill>
-            <a:prstDash val="solid"/>
-          </a:ln>
-        </p:spPr>
-      </p:sp>
-      <p:sp>
-        <p:nvSpPr>
-          <p:cNvPr id="76" name="Text 74"/>
-          <p:cNvSpPr txBox="1"/>
-          <p:nvPr/>
-        </p:nvSpPr>
-        <p:spPr>
-          <a:xfrm>
-            <a:off x="7675291" y="5513832"/>
-            <a:ext cx="1631838" cy="384048"/>
-          </a:xfrm>
-          <a:prstGeom prst="rect">
-            <a:avLst/>
-          </a:prstGeom>
-          <a:noFill/>
-          <a:ln/>
-        </p:spPr>
-        <p:txBody>
-          <a:bodyPr wrap="square" lIns="0" tIns="0" rIns="0" bIns="0" rtlCol="0" anchor="t"/>
-          <a:lstStyle/>
-          <a:p>
-            <a:pPr indent="0" marL="0">
-              <a:buNone/>
-            </a:pPr>
-            <a:r>
-              <a:rPr lang="en-US" sz="1050" b="1" dirty="0">
-                <a:solidFill>
-                  <a:srgbClr val="000000"/>
-                </a:solidFill>
-              </a:rPr>
-              <a:t>User testing starts</a:t>
-            </a:r>
-            <a:endParaRPr lang="en-US" sz="1050" dirty="0"/>
-          </a:p>
-        </p:txBody>
-      </p:sp>
-      <p:sp>
-        <p:nvSpPr>
-          <p:cNvPr id="77" name="sprint-10"/>
-          <p:cNvSpPr/>
-          <p:nvPr/>
-        </p:nvSpPr>
-        <p:spPr>
-          <a:xfrm>
-            <a:off x="9554017" y="4251960"/>
-            <a:ext cx="2134758" cy="1691640"/>
-          </a:xfrm>
-          <a:prstGeom prst="roundRect">
-            <a:avLst>
-              <a:gd name="adj" fmla="val 5405"/>
+              <a:gd name="adj" fmla="val 6017"/>
             </a:avLst>
           </a:prstGeom>
           <a:solidFill>
@@ -19229,14 +19886,14 @@
       </p:sp>
       <p:sp>
         <p:nvSpPr>
-          <p:cNvPr id="78" name="Text 76"/>
-          <p:cNvSpPr txBox="1"/>
-          <p:nvPr/>
-        </p:nvSpPr>
-        <p:spPr>
-          <a:xfrm>
-            <a:off x="9691177" y="4370832"/>
-            <a:ext cx="1860438" cy="219456"/>
+          <p:cNvPr id="99" name="Text 97"/>
+          <p:cNvSpPr txBox="1"/>
+          <p:nvPr/>
+        </p:nvSpPr>
+        <p:spPr>
+          <a:xfrm>
+            <a:off x="8658715" y="4370832"/>
+            <a:ext cx="1318434" cy="219456"/>
           </a:xfrm>
           <a:prstGeom prst="rect">
             <a:avLst/>
@@ -19252,27 +19909,27 @@
               <a:buNone/>
             </a:pPr>
             <a:r>
-              <a:rPr lang="en-US" sz="1100" b="1" spc="200" kern="0" dirty="0">
+              <a:rPr lang="en-US" sz="1000" b="1" spc="200" kern="0" dirty="0">
                 <a:solidFill>
                   <a:srgbClr val="D9B200"/>
                 </a:solidFill>
               </a:rPr>
-              <a:t>SPRINT 10</a:t>
-            </a:r>
-            <a:endParaRPr lang="en-US" sz="1100" dirty="0"/>
-          </a:p>
-        </p:txBody>
-      </p:sp>
-      <p:sp>
-        <p:nvSpPr>
-          <p:cNvPr id="79" name="Text 77"/>
-          <p:cNvSpPr txBox="1"/>
-          <p:nvPr/>
-        </p:nvSpPr>
-        <p:spPr>
-          <a:xfrm>
-            <a:off x="9691177" y="4599432"/>
-            <a:ext cx="1860438" cy="201168"/>
+              <a:t>GO-LIVE</a:t>
+            </a:r>
+            <a:endParaRPr lang="en-US" sz="1000" dirty="0"/>
+          </a:p>
+        </p:txBody>
+      </p:sp>
+      <p:sp>
+        <p:nvSpPr>
+          <p:cNvPr id="100" name="Text 98"/>
+          <p:cNvSpPr txBox="1"/>
+          <p:nvPr/>
+        </p:nvSpPr>
+        <p:spPr>
+          <a:xfrm>
+            <a:off x="8658715" y="4599432"/>
+            <a:ext cx="1318434" cy="201168"/>
           </a:xfrm>
           <a:prstGeom prst="rect">
             <a:avLst/>
@@ -19288,12 +19945,48 @@
               <a:buNone/>
             </a:pPr>
             <a:r>
+              <a:rPr lang="en-US" sz="950" dirty="0">
+                <a:solidFill>
+                  <a:srgbClr val="D9D9D9"/>
+                </a:solidFill>
+              </a:rPr>
+              <a:t>Week 25</a:t>
+            </a:r>
+            <a:endParaRPr lang="en-US" sz="950" dirty="0"/>
+          </a:p>
+        </p:txBody>
+      </p:sp>
+      <p:sp>
+        <p:nvSpPr>
+          <p:cNvPr id="101" name="Text 99"/>
+          <p:cNvSpPr txBox="1"/>
+          <p:nvPr/>
+        </p:nvSpPr>
+        <p:spPr>
+          <a:xfrm>
+            <a:off x="8658715" y="4837176"/>
+            <a:ext cx="1318434" cy="585216"/>
+          </a:xfrm>
+          <a:prstGeom prst="rect">
+            <a:avLst/>
+          </a:prstGeom>
+          <a:noFill/>
+          <a:ln/>
+        </p:spPr>
+        <p:txBody>
+          <a:bodyPr wrap="square" lIns="0" tIns="0" rIns="0" bIns="0" rtlCol="0" anchor="t"/>
+          <a:lstStyle/>
+          <a:p>
+            <a:pPr indent="0" marL="0">
+              <a:buNone/>
+            </a:pPr>
+            <a:r>
               <a:rPr lang="en-US" sz="1000" dirty="0">
                 <a:solidFill>
-                  <a:srgbClr val="D9D9D9"/>
-                </a:solidFill>
-              </a:rPr>
-              <a:t>Weeks 19-20</a:t>
+                  <a:srgbClr val="FFFFFF"/>
+                </a:solidFill>
+              </a:rPr>
+              <a:t>Classes go-live, hypercare, knowledge transfer</a:t>
             </a:r>
             <a:endParaRPr lang="en-US" sz="1000" dirty="0"/>
           </a:p>
@@ -19301,50 +19994,14 @@
       </p:sp>
       <p:sp>
         <p:nvSpPr>
-          <p:cNvPr id="80" name="Text 78"/>
-          <p:cNvSpPr txBox="1"/>
-          <p:nvPr/>
-        </p:nvSpPr>
-        <p:spPr>
-          <a:xfrm>
-            <a:off x="9691177" y="4855464"/>
-            <a:ext cx="1860438" cy="603504"/>
-          </a:xfrm>
-          <a:prstGeom prst="rect">
-            <a:avLst/>
-          </a:prstGeom>
-          <a:noFill/>
-          <a:ln/>
-        </p:spPr>
-        <p:txBody>
-          <a:bodyPr wrap="square" lIns="0" tIns="0" rIns="0" bIns="0" rtlCol="0" anchor="t"/>
-          <a:lstStyle/>
-          <a:p>
-            <a:pPr indent="0" marL="0">
-              <a:buNone/>
-            </a:pPr>
-            <a:r>
-              <a:rPr lang="en-US" sz="1100" dirty="0">
-                <a:solidFill>
-                  <a:srgbClr val="FFFFFF"/>
-                </a:solidFill>
-              </a:rPr>
-              <a:t>User testing, go-live, knowledge transfer</a:t>
-            </a:r>
-            <a:endParaRPr lang="en-US" sz="1100" dirty="0"/>
-          </a:p>
-        </p:txBody>
-      </p:sp>
-      <p:sp>
-        <p:nvSpPr>
-          <p:cNvPr id="81" name="Shape 79"/>
+          <p:cNvPr id="102" name="Shape 100"/>
           <p:cNvSpPr/>
           <p:nvPr/>
         </p:nvSpPr>
         <p:spPr>
           <a:xfrm>
-            <a:off x="9691177" y="5440680"/>
-            <a:ext cx="1860438" cy="0"/>
+            <a:off x="8658715" y="5440680"/>
+            <a:ext cx="1318434" cy="0"/>
           </a:xfrm>
           <a:prstGeom prst="line">
             <a:avLst/>
@@ -19360,14 +20017,14 @@
       </p:sp>
       <p:sp>
         <p:nvSpPr>
-          <p:cNvPr id="82" name="Shape 80"/>
+          <p:cNvPr id="103" name="Shape 101"/>
           <p:cNvSpPr/>
           <p:nvPr/>
         </p:nvSpPr>
         <p:spPr>
           <a:xfrm>
-            <a:off x="9691177" y="5577840"/>
-            <a:ext cx="155448" cy="155448"/>
+            <a:off x="8658715" y="5577840"/>
+            <a:ext cx="137160" cy="137160"/>
           </a:xfrm>
           <a:prstGeom prst="diamond">
             <a:avLst/>
@@ -19385,14 +20042,14 @@
       </p:sp>
       <p:sp>
         <p:nvSpPr>
-          <p:cNvPr id="83" name="Text 81"/>
-          <p:cNvSpPr txBox="1"/>
-          <p:nvPr/>
-        </p:nvSpPr>
-        <p:spPr>
-          <a:xfrm>
-            <a:off x="9938065" y="5513832"/>
-            <a:ext cx="1631838" cy="384048"/>
+          <p:cNvPr id="104" name="Text 102"/>
+          <p:cNvSpPr txBox="1"/>
+          <p:nvPr/>
+        </p:nvSpPr>
+        <p:spPr>
+          <a:xfrm>
+            <a:off x="8878171" y="5495544"/>
+            <a:ext cx="1098978" cy="402336"/>
           </a:xfrm>
           <a:prstGeom prst="rect">
             <a:avLst/>
@@ -19408,27 +20065,27 @@
               <a:buNone/>
             </a:pPr>
             <a:r>
-              <a:rPr lang="en-US" sz="1050" b="1" dirty="0">
+              <a:rPr lang="en-US" sz="950" b="1" dirty="0">
                 <a:solidFill>
                   <a:srgbClr val="FFFFFF"/>
                 </a:solidFill>
               </a:rPr>
               <a:t>Phase 2 live</a:t>
             </a:r>
-            <a:endParaRPr lang="en-US" sz="1050" dirty="0"/>
-          </a:p>
-        </p:txBody>
-      </p:sp>
-      <p:sp>
-        <p:nvSpPr>
-          <p:cNvPr id="84" name="transition-band-4"/>
+            <a:endParaRPr lang="en-US" sz="950" dirty="0"/>
+          </a:p>
+        </p:txBody>
+      </p:sp>
+      <p:sp>
+        <p:nvSpPr>
+          <p:cNvPr id="105" name="transition-band-8"/>
           <p:cNvSpPr/>
           <p:nvPr/>
         </p:nvSpPr>
         <p:spPr>
           <a:xfrm>
-            <a:off x="7291243" y="3867912"/>
-            <a:ext cx="4397532" cy="274320"/>
+            <a:off x="502920" y="6016752"/>
+            <a:ext cx="4741687" cy="274320"/>
           </a:xfrm>
           <a:prstGeom prst="roundRect">
             <a:avLst>
@@ -19448,14 +20105,14 @@
       </p:sp>
       <p:sp>
         <p:nvSpPr>
-          <p:cNvPr id="85" name="Text 83"/>
-          <p:cNvSpPr txBox="1"/>
-          <p:nvPr/>
-        </p:nvSpPr>
-        <p:spPr>
-          <a:xfrm>
-            <a:off x="7400971" y="3867912"/>
-            <a:ext cx="4178076" cy="274320"/>
+          <p:cNvPr id="106" name="Text 104"/>
+          <p:cNvSpPr txBox="1"/>
+          <p:nvPr/>
+        </p:nvSpPr>
+        <p:spPr>
+          <a:xfrm>
+            <a:off x="612648" y="6016752"/>
+            <a:ext cx="4522231" cy="274320"/>
           </a:xfrm>
           <a:prstGeom prst="rect">
             <a:avLst/>
@@ -19476,70 +20133,7 @@
                   <a:srgbClr val="FFFFFF"/>
                 </a:solidFill>
               </a:rPr>
-              <a:t>CERTAIN TRANSITION  ·  Weeks 7-10: export, map, trial loads</a:t>
-            </a:r>
-            <a:endParaRPr lang="en-US" sz="1000" dirty="0"/>
-          </a:p>
-        </p:txBody>
-      </p:sp>
-      <p:sp>
-        <p:nvSpPr>
-          <p:cNvPr id="86" name="transition-band-6"/>
-          <p:cNvSpPr/>
-          <p:nvPr/>
-        </p:nvSpPr>
-        <p:spPr>
-          <a:xfrm>
-            <a:off x="502920" y="6016752"/>
-            <a:ext cx="2134758" cy="274320"/>
-          </a:xfrm>
-          <a:prstGeom prst="roundRect">
-            <a:avLst>
-              <a:gd name="adj" fmla="val 20000"/>
-            </a:avLst>
-          </a:prstGeom>
-          <a:solidFill>
-            <a:srgbClr val="45289F"/>
-          </a:solidFill>
-          <a:ln w="12700">
-            <a:solidFill>
-              <a:srgbClr val="45289F"/>
-            </a:solidFill>
-            <a:prstDash val="solid"/>
-          </a:ln>
-        </p:spPr>
-      </p:sp>
-      <p:sp>
-        <p:nvSpPr>
-          <p:cNvPr id="87" name="Text 85"/>
-          <p:cNvSpPr txBox="1"/>
-          <p:nvPr/>
-        </p:nvSpPr>
-        <p:spPr>
-          <a:xfrm>
-            <a:off x="612648" y="6016752"/>
-            <a:ext cx="1915302" cy="274320"/>
-          </a:xfrm>
-          <a:prstGeom prst="rect">
-            <a:avLst/>
-          </a:prstGeom>
-          <a:noFill/>
-          <a:ln/>
-        </p:spPr>
-        <p:txBody>
-          <a:bodyPr wrap="square" lIns="0" tIns="0" rIns="0" bIns="0" rtlCol="0" anchor="ctr"/>
-          <a:lstStyle/>
-          <a:p>
-            <a:pPr indent="0" marL="0">
-              <a:buNone/>
-            </a:pPr>
-            <a:r>
-              <a:rPr lang="en-US" sz="1000" b="1" dirty="0">
-                <a:solidFill>
-                  <a:srgbClr val="FFFFFF"/>
-                </a:solidFill>
-              </a:rPr>
-              <a:t>Weeks 11-12: cutover</a:t>
+              <a:t>CERTAIN TRANSITION  ·  Weeks 15-20: export, map, trial loads, cutover</a:t>
             </a:r>
             <a:endParaRPr lang="en-US" sz="1000" dirty="0"/>
           </a:p>
@@ -20337,7 +20931,7 @@
                   <a:schemeClr val="tx1"/>
                 </a:solidFill>
               </a:rPr>
-              <a:t>A dedicated five-person delivery pod</a:t>
+              <a:t>A dedicated four-person delivery pod</a:t>
             </a:r>
             <a:endParaRPr lang="en-US" sz="3200" dirty="0"/>
           </a:p>
@@ -20575,7 +21169,7 @@
                 <a:ea typeface="Trenda IG Text Light" pitchFamily="34" charset="-122"/>
                 <a:cs typeface="Trenda IG Text Light" pitchFamily="34" charset="-120"/>
               </a:rPr>
-              <a:t>3</a:t>
+              <a:t>2</a:t>
             </a:r>
             <a:endParaRPr lang="en-US" sz="3200" dirty="0"/>
           </a:p>
@@ -20695,7 +21289,7 @@
                   <a:srgbClr val="000000"/>
                 </a:solidFill>
               </a:rPr>
-              <a:t>Scrum Master or Project Manager</a:t>
+              <a:t>Project Manager</a:t>
             </a:r>
             <a:endParaRPr lang="en-US" sz="1300" dirty="0"/>
           </a:p>
@@ -21007,7 +21601,7 @@
                   <a:srgbClr val="000000"/>
                 </a:solidFill>
               </a:rPr>
-              <a:t>2 Salesforce Developers + 1 Marketing Cloud Developer</a:t>
+              <a:t>2 Developers: Salesforce and Marketing Cloud</a:t>
             </a:r>
             <a:endParaRPr lang="en-US" sz="1300" dirty="0"/>
           </a:p>
@@ -21043,7 +21637,7 @@
                   <a:srgbClr val="4D4D4D"/>
                 </a:solidFill>
               </a:rPr>
-              <a:t>Event app, registration, payments, integrations, journeys and PEIs</a:t>
+              <a:t>Event app, registration, payments, journeys, data migration</a:t>
             </a:r>
             <a:endParaRPr lang="en-US" sz="1050" dirty="0"/>
           </a:p>
@@ -21698,7 +22292,7 @@
                   <a:srgbClr val="000000"/>
                 </a:solidFill>
               </a:rPr>
-              <a:t>5 people  ·  10 sprints  ·  20 weeks</a:t>
+              <a:t>4 people  ·  12 sprints  ·  25 weeks</a:t>
             </a:r>
             <a:endParaRPr lang="en-US" sz="1300" dirty="0"/>
           </a:p>
@@ -25010,7 +25604,7 @@
                   <a:schemeClr val="accent6"/>
                 </a:solidFill>
               </a:rPr>
-              <a:t>Weeks 3-12</a:t>
+              <a:t>Weeks 3-20</a:t>
             </a:r>
             <a:endParaRPr lang="en-US" sz="1300" dirty="0"/>
           </a:p>
@@ -25216,7 +25810,7 @@
                   <a:schemeClr val="accent3"/>
                 </a:solidFill>
               </a:rPr>
-              <a:t>Weeks 13-20</a:t>
+              <a:t>Weeks 21-25</a:t>
             </a:r>
             <a:endParaRPr lang="en-US" sz="1300" dirty="0"/>
           </a:p>
@@ -25628,7 +26222,7 @@
                   <a:schemeClr val="accent4"/>
                 </a:solidFill>
               </a:rPr>
-              <a:t>Week 21+</a:t>
+              <a:t>Week 26+</a:t>
             </a:r>
             <a:endParaRPr lang="en-US" sz="1300" dirty="0"/>
           </a:p>
@@ -27624,7 +28218,7 @@
                   <a:srgbClr val="4D4D4D"/>
                 </a:solidFill>
               </a:rPr>
-              <a:t>Offshore delivery model: fixed scope, five-person pod, 10 sprints</a:t>
+              <a:t>Offshore delivery model: fixed scope, four-person pod, 25 weeks</a:t>
             </a:r>
             <a:endParaRPr lang="en-US" sz="1400" dirty="0"/>
           </a:p>
@@ -28055,7 +28649,7 @@
                   <a:srgbClr val="000000"/>
                 </a:solidFill>
               </a:rPr>
-              <a:t>Sprints</a:t>
+              <a:t>Weeks</a:t>
             </a:r>
             <a:endParaRPr lang="en-US" sz="1200" dirty="0"/>
           </a:p>
@@ -28222,7 +28816,7 @@
                   <a:srgbClr val="000000"/>
                 </a:solidFill>
               </a:rPr>
-              <a:t>1-6</a:t>
+              <a:t>1-20</a:t>
             </a:r>
             <a:endParaRPr lang="en-US" sz="1200" dirty="0"/>
           </a:p>
@@ -28258,7 +28852,7 @@
                   <a:srgbClr val="8C8C8C"/>
                 </a:solidFill>
               </a:rPr>
-              <a:t>$350,000</a:t>
+              <a:t>$464,000</a:t>
             </a:r>
             <a:endParaRPr lang="en-US" sz="1200" dirty="0"/>
           </a:p>
@@ -28294,7 +28888,7 @@
                   <a:srgbClr val="000000"/>
                 </a:solidFill>
               </a:rPr>
-              <a:t>$175,000</a:t>
+              <a:t>$232,000</a:t>
             </a:r>
             <a:endParaRPr lang="en-US" sz="1200" dirty="0"/>
           </a:p>
@@ -28389,7 +28983,7 @@
                   <a:srgbClr val="000000"/>
                 </a:solidFill>
               </a:rPr>
-              <a:t>7-10</a:t>
+              <a:t>21-25</a:t>
             </a:r>
             <a:endParaRPr lang="en-US" sz="1200" dirty="0"/>
           </a:p>
@@ -28425,7 +29019,7 @@
                   <a:srgbClr val="8C8C8C"/>
                 </a:solidFill>
               </a:rPr>
-              <a:t>$230,000</a:t>
+              <a:t>$116,000</a:t>
             </a:r>
             <a:endParaRPr lang="en-US" sz="1200" dirty="0"/>
           </a:p>
@@ -28461,7 +29055,7 @@
                   <a:srgbClr val="000000"/>
                 </a:solidFill>
               </a:rPr>
-              <a:t>$115,000</a:t>
+              <a:t>$58,000</a:t>
             </a:r>
             <a:endParaRPr lang="en-US" sz="1200" dirty="0"/>
           </a:p>
@@ -28556,7 +29150,7 @@
                   <a:srgbClr val="000000"/>
                 </a:solidFill>
               </a:rPr>
-              <a:t>10 sprints</a:t>
+              <a:t>25</a:t>
             </a:r>
             <a:endParaRPr lang="en-US" sz="1200" dirty="0"/>
           </a:p>
@@ -28727,7 +29321,7 @@
                   <a:srgbClr val="4D4D4D"/>
                 </a:solidFill>
               </a:rPr>
-              <a:t>Dedicated five-person offshore pod for 20 weeks</a:t>
+              <a:t>Dedicated four-person offshore pod for 25 weeks</a:t>
             </a:r>
             <a:endParaRPr lang="en-US" sz="1100" dirty="0"/>
           </a:p>

</xml_diff>

<commit_message>
Slide 7: transactional email from Salesforce; Surya's wording for payment steps
Co-Authored-By: Claude Opus 5.5 <noreply@anthropic.com>
Claude-Session: https://claude.ai/code/session_0161UfSgfoLg2WkzVi8freAH
</commit_message>
<xml_diff>
--- a/deck/Memorial-Hermann-Event-Platform.pptx
+++ b/deck/Memorial-Hermann-Event-Platform.pptx
@@ -137,7 +137,7 @@
   <p:extLst>
     <p:ext uri="{521415D9-36F7-43E2-AB2F-B90AF26B5E84}">
       <p14:sectionLst xmlns:p14="http://schemas.microsoft.com/office/powerpoint/2010/main">
-        <p14:section name="Introduction" id="{2dcde034-44b1-21bb-306d-c9503d229d35}">
+        <p14:section name="Introduction" id="{9b996d0d-aa25-6830-51cc-099d233f0f1a}">
           <p14:sldIdLst>
             <p14:sldId id="256"/>
             <p14:sldId id="257"/>
@@ -145,7 +145,7 @@
             <p14:sldId id="259"/>
           </p14:sldIdLst>
         </p14:section>
-        <p14:section name="The solution" id="{d50c6d02-b9a3-2d26-d88d-f0cae36dc129}">
+        <p14:section name="The solution" id="{7c5ae7f4-a01a-d04e-e3ab-526c57c9a7b7}">
           <p14:sldIdLst>
             <p14:sldId id="260"/>
             <p14:sldId id="261"/>
@@ -159,7 +159,7 @@
             <p14:sldId id="269"/>
           </p14:sldIdLst>
         </p14:section>
-        <p14:section name="Delivery plan" id="{021d73d1-7677-0cee-5ff9-4a7cbab26dd3}">
+        <p14:section name="Delivery plan" id="{e8f7cbf6-a4e5-e9f3-acec-0aa98a431f14}">
           <p14:sldIdLst>
             <p14:sldId id="270"/>
             <p14:sldId id="271"/>
@@ -169,7 +169,7 @@
             <p14:sldId id="275"/>
           </p14:sldIdLst>
         </p14:section>
-        <p14:section name="Beyond the event" id="{bd8fae05-568e-9a2a-154f-c099bb1c23c4}">
+        <p14:section name="Beyond the event" id="{ba38b831-d140-9fb8-df4c-d0bb8c2eb349}">
           <p14:sldIdLst>
             <p14:sldId id="276"/>
             <p14:sldId id="277"/>
@@ -179,7 +179,7 @@
             <p14:sldId id="281"/>
           </p14:sldIdLst>
         </p14:section>
-        <p14:section name="Roadmap and next steps" id="{851b9796-4ddd-9e18-4cea-389a1ddf7263}">
+        <p14:section name="Roadmap and next steps" id="{e6c51c5b-afdf-5318-d6ff-0b1533d6fea9}">
           <p14:sldIdLst>
             <p14:sldId id="282"/>
             <p14:sldId id="283"/>
@@ -3056,7 +3056,7 @@
           <a:p>
             <a:r>
               <a:rPr lang="en-US" dirty="0"/>
-              <a:t>This is the whole solution on one page, in the order a registrant experiences it. Register: website or the existing My Memorial Hermann app, with a seat held while they pay. Pay: the gateway hosts the card page; we receive only a token. Confirm: Salesforce records the registration and Marketing Cloud sends confirmation and reminders. Attend: QR check-in. Engage: patient engagement initiatives. Grow: staff see demand and add sessions. It replaces Certain and builds on today’s Experience Cloud site and app.</a:t>
+              <a:t>This is the whole solution on one page, in the order a registrant experiences it. Register: website or the existing My Memorial Hermann app, with a seat held while they pay. Pay: the gateway hosts the card page; we receive only a token. Confirm: Salesforce records the registration and sends the confirmation, QR code, calendar invite and reminders from Salesforce email, so confirmation is instant. Attend: QR check-in. Engage: patient engagement initiatives. Grow: staff see demand and add sessions. It replaces Certain and builds on today’s Experience Cloud site and app.</a:t>
             </a:r>
             <a:endParaRPr lang="en-US" dirty="0"/>
           </a:p>
@@ -33924,7 +33924,7 @@
                   <a:srgbClr val="000000"/>
                 </a:solidFill>
               </a:rPr>
-              <a:t>Chase payment page</a:t>
+              <a:t>Payment gateway (Chase)</a:t>
             </a:r>
             <a:endParaRPr lang="en-US" sz="1050" dirty="0"/>
           </a:p>
@@ -34096,7 +34096,7 @@
                   <a:srgbClr val="000000"/>
                 </a:solidFill>
               </a:rPr>
-              <a:t>Marketing Cloud</a:t>
+              <a:t>Salesforce email</a:t>
             </a:r>
             <a:endParaRPr lang="en-US" sz="1050" dirty="0"/>
           </a:p>
@@ -34883,8 +34883,8 @@
         </p:nvSpPr>
         <p:spPr>
           <a:xfrm>
-            <a:off x="4418838" y="3413019"/>
-            <a:ext cx="1987906" cy="219456"/>
+            <a:off x="3674516" y="3413019"/>
+            <a:ext cx="2732227" cy="219456"/>
           </a:xfrm>
           <a:prstGeom prst="rect">
             <a:avLst/>
@@ -34905,7 +34905,7 @@
                   <a:srgbClr val="4D4D4D"/>
                 </a:solidFill>
               </a:rPr>
-              <a:t>Signed webhook, token only</a:t>
+              <a:t>Signed webhook (payment confirmation)</a:t>
             </a:r>
             <a:endParaRPr lang="en-US" sz="1000" dirty="0"/>
           </a:p>
@@ -35005,7 +35005,7 @@
         <p:spPr>
           <a:xfrm>
             <a:off x="5232001" y="3700000"/>
-            <a:ext cx="2935224" cy="219456"/>
+            <a:ext cx="3205886" cy="219456"/>
           </a:xfrm>
           <a:prstGeom prst="rect">
             <a:avLst/>
@@ -35026,7 +35026,7 @@
                   <a:srgbClr val="000000"/>
                 </a:solidFill>
               </a:rPr>
-              <a:t>Create registration (queued, idempotent)</a:t>
+              <a:t>Create registration (queued, duplicate-safe)</a:t>
             </a:r>
             <a:endParaRPr lang="en-US" sz="1000" dirty="0"/>
           </a:p>

</xml_diff>

<commit_message>
Commercials slide: $60K only, team table, offshore tag; three-person team
Co-Authored-By: Claude Opus 5.5 <noreply@anthropic.com>
Claude-Session: https://claude.ai/code/session_0161UfSgfoLg2WkzVi8freAH
</commit_message>
<xml_diff>
--- a/deck/Memorial-Hermann-Event-Platform.pptx
+++ b/deck/Memorial-Hermann-Event-Platform.pptx
@@ -136,7 +136,7 @@
   <p:extLst>
     <p:ext uri="{521415D9-36F7-43E2-AB2F-B90AF26B5E84}">
       <p14:sectionLst xmlns:p14="http://schemas.microsoft.com/office/powerpoint/2010/main">
-        <p14:section name="Introduction" id="{85b29fc9-0e4c-6327-1899-811bbdea5ac8}">
+        <p14:section name="Introduction" id="{8aa2811a-dfca-7215-910b-9376256d7218}">
           <p14:sldIdLst>
             <p14:sldId id="256"/>
             <p14:sldId id="257"/>
@@ -144,7 +144,7 @@
             <p14:sldId id="259"/>
           </p14:sldIdLst>
         </p14:section>
-        <p14:section name="The solution" id="{14eeb2fe-d837-9945-b83b-c1ca26711e08}">
+        <p14:section name="The solution" id="{d58e77f7-3148-c394-fe5f-d35b84a11c44}">
           <p14:sldIdLst>
             <p14:sldId id="260"/>
             <p14:sldId id="261"/>
@@ -158,7 +158,7 @@
             <p14:sldId id="269"/>
           </p14:sldIdLst>
         </p14:section>
-        <p14:section name="Delivery plan" id="{2ef7607f-6d29-097e-69ad-cee6b6fece0f}">
+        <p14:section name="Delivery plan" id="{9c0accac-2edf-aab0-704d-09f185e1f4f1}">
           <p14:sldIdLst>
             <p14:sldId id="270"/>
             <p14:sldId id="271"/>
@@ -167,7 +167,7 @@
             <p14:sldId id="274"/>
           </p14:sldIdLst>
         </p14:section>
-        <p14:section name="Beyond the event" id="{8d5cf30e-46e1-c9d5-c9ae-dd8b07d23640}">
+        <p14:section name="Beyond the event" id="{541e3454-c7be-8aff-aad2-eee3cbc4b33d}">
           <p14:sldIdLst>
             <p14:sldId id="275"/>
             <p14:sldId id="276"/>
@@ -177,7 +177,7 @@
             <p14:sldId id="280"/>
           </p14:sldIdLst>
         </p14:section>
-        <p14:section name="Roadmap and next steps" id="{66b63d37-4e22-f29c-becc-5082a342158f}">
+        <p14:section name="Roadmap and next steps" id="{2d463393-d2d3-d701-f874-5367967b190c}">
           <p14:sldIdLst>
             <p14:sldId id="281"/>
             <p14:sldId id="282"/>
@@ -1294,7 +1294,7 @@
           <a:p>
             <a:r>
               <a:rPr lang="en-US" dirty="0"/>
-              <a:t>Everything here lands in eight weeks with the same four-person pod. Classes and events stay as they are; conferences are added alongside them.</a:t>
+              <a:t>Everything here lands in eight weeks with the same three-person team. Classes and events stay as they are; conferences are added alongside them.</a:t>
             </a:r>
             <a:endParaRPr lang="en-US" dirty="0"/>
           </a:p>
@@ -1470,7 +1470,7 @@
           <a:p>
             <a:r>
               <a:rPr lang="en-US" dirty="0"/>
-              <a:t>A small, dedicated pod: one Project Manager leading delivery and running the sprints, one QA engineer embedded in every sprint, and two developers covering Salesforce and Marketing Cloud. Memorial Hermann provides a product owner and an Epic and app contact.</a:t>
+              <a:t>A small, dedicated offshore team: one Project Manager leading delivery and running the sprints, one QA Engineer embedded in every sprint, and one Salesforce Developer. Memorial Hermann provides a product owner and an Epic and app contact.</a:t>
             </a:r>
             <a:endParaRPr lang="en-US" dirty="0"/>
           </a:p>
@@ -2350,7 +2350,7 @@
           <a:p>
             <a:r>
               <a:rPr lang="en-US" dirty="0"/>
-              <a:t>Pricing is for an offshore delivery model. Standard program value is $120,000 for a four-person pod over 8 weeks. As a strategic partner, Memorial Hermann receives a 50% partnership credit applied upfront, for an investment of $60,000. Billing follows sprint milestones. Licenses (Salesforce, Zoom or Teams) and third-party fees are outside this price.</a:t>
+              <a:t>Pricing is for an offshore delivery model: $60,000 fixed for 8 weeks with a three-person team (one Project Manager, one Salesforce Developer, one QA Engineer). Billing follows sprint milestones. Licenses (Salesforce, Zoom or Teams) and gateway fees are outside this price.</a:t>
             </a:r>
             <a:endParaRPr lang="en-US" dirty="0"/>
           </a:p>
@@ -15981,7 +15981,7 @@
                   <a:schemeClr val="tx1"/>
                 </a:solidFill>
               </a:rPr>
-              <a:t>A dedicated four-person delivery pod</a:t>
+              <a:t>A dedicated three-person delivery team</a:t>
             </a:r>
             <a:endParaRPr lang="en-US" sz="3200" dirty="0"/>
           </a:p>
@@ -16219,7 +16219,7 @@
                 <a:ea typeface="Trenda IG Text Light" pitchFamily="34" charset="-122"/>
                 <a:cs typeface="Trenda IG Text Light" pitchFamily="34" charset="-120"/>
               </a:rPr>
-              <a:t>2</a:t>
+              <a:t>1</a:t>
             </a:r>
             <a:endParaRPr lang="en-US" sz="3200" dirty="0"/>
           </a:p>
@@ -16651,7 +16651,7 @@
                   <a:srgbClr val="000000"/>
                 </a:solidFill>
               </a:rPr>
-              <a:t>2 Developers: Salesforce and Marketing Cloud</a:t>
+              <a:t>Salesforce Developer</a:t>
             </a:r>
             <a:endParaRPr lang="en-US" sz="1300" dirty="0"/>
           </a:p>
@@ -16665,7 +16665,7 @@
         </p:nvSpPr>
         <p:spPr>
           <a:xfrm>
-            <a:off x="5029200" y="5356860"/>
+            <a:off x="5029200" y="5173980"/>
             <a:ext cx="2926080" cy="411480"/>
           </a:xfrm>
           <a:prstGeom prst="rect">
@@ -17342,7 +17342,7 @@
                   <a:srgbClr val="000000"/>
                 </a:solidFill>
               </a:rPr>
-              <a:t>4 people  ·  4 sprints  ·  8 weeks</a:t>
+              <a:t>3 people  ·  4 sprints  ·  8 weeks</a:t>
             </a:r>
             <a:endParaRPr lang="en-US" sz="1300" dirty="0"/>
           </a:p>
@@ -23922,7 +23922,7 @@
                   <a:schemeClr val="tx1"/>
                 </a:solidFill>
               </a:rPr>
-              <a:t>Investment</a:t>
+              <a:t>Commercials</a:t>
             </a:r>
             <a:endParaRPr lang="en-US" sz="3200" dirty="0"/>
           </a:p>
@@ -23958,7 +23958,7 @@
                   <a:srgbClr val="4D4D4D"/>
                 </a:solidFill>
               </a:rPr>
-              <a:t>Offshore delivery model: fixed scope, four-person pod, 8 weeks</a:t>
+              <a:t>Offshore delivery model: fixed scope, three-person team, 8 weeks</a:t>
             </a:r>
             <a:endParaRPr lang="en-US" sz="1400" dirty="0"/>
           </a:p>
@@ -24078,10 +24078,10 @@
             <a:r>
               <a:rPr lang="en-US" sz="1000" b="1" spc="200" kern="0" dirty="0">
                 <a:solidFill>
-                  <a:srgbClr val="BFBFBF"/>
-                </a:solidFill>
-              </a:rPr>
-              <a:t>STANDARD PROGRAM VALUE</a:t>
+                  <a:srgbClr val="00D6F2"/>
+                </a:solidFill>
+              </a:rPr>
+              <a:t>PROGRAM INVESTMENT</a:t>
             </a:r>
             <a:endParaRPr lang="en-US" sz="1000" dirty="0"/>
           </a:p>
@@ -24095,8 +24095,8 @@
         </p:nvSpPr>
         <p:spPr>
           <a:xfrm>
-            <a:off x="822960" y="2350008"/>
-            <a:ext cx="3566160" cy="548640"/>
+            <a:off x="822960" y="2880360"/>
+            <a:ext cx="3566160" cy="1005840"/>
           </a:xfrm>
           <a:prstGeom prst="rect">
             <a:avLst/>
@@ -24112,17 +24112,17 @@
               <a:buNone/>
             </a:pPr>
             <a:r>
-              <a:rPr lang="en-US" sz="3000" strike="sngStrike" dirty="0">
-                <a:solidFill>
-                  <a:srgbClr val="8C8C8C"/>
+              <a:rPr lang="en-US" sz="6000" dirty="0">
+                <a:solidFill>
+                  <a:srgbClr val="FFFFFF"/>
                 </a:solidFill>
                 <a:latin typeface="Trenda IG Text Light" pitchFamily="34" charset="0"/>
                 <a:ea typeface="Trenda IG Text Light" pitchFamily="34" charset="-122"/>
                 <a:cs typeface="Trenda IG Text Light" pitchFamily="34" charset="-120"/>
               </a:rPr>
-              <a:t>$120,000</a:t>
-            </a:r>
-            <a:endParaRPr lang="en-US" sz="3000" dirty="0"/>
+              <a:t>$60,000</a:t>
+            </a:r>
+            <a:endParaRPr lang="en-US" sz="6000" dirty="0"/>
           </a:p>
         </p:txBody>
       </p:sp>
@@ -24134,7 +24134,7 @@
         </p:nvSpPr>
         <p:spPr>
           <a:xfrm>
-            <a:off x="822960" y="3108960"/>
+            <a:off x="822960" y="4206240"/>
             <a:ext cx="3566160" cy="0"/>
           </a:xfrm>
           <a:prstGeom prst="line">
@@ -24157,8 +24157,8 @@
         </p:nvSpPr>
         <p:spPr>
           <a:xfrm>
-            <a:off x="822960" y="3291840"/>
-            <a:ext cx="3566160" cy="219456"/>
+            <a:off x="822960" y="4389120"/>
+            <a:ext cx="1097280" cy="274320"/>
           </a:xfrm>
           <a:prstGeom prst="rect">
             <a:avLst/>
@@ -24174,14 +24174,14 @@
               <a:buNone/>
             </a:pPr>
             <a:r>
-              <a:rPr lang="en-US" sz="1000" b="1" spc="200" kern="0" dirty="0">
-                <a:solidFill>
-                  <a:srgbClr val="00D6F2"/>
-                </a:solidFill>
-              </a:rPr>
-              <a:t>STRATEGIC PARTNER INVESTMENT</a:t>
-            </a:r>
-            <a:endParaRPr lang="en-US" sz="1000" dirty="0"/>
+              <a:rPr lang="en-US" sz="1100" b="1" dirty="0">
+                <a:solidFill>
+                  <a:srgbClr val="BFBFBF"/>
+                </a:solidFill>
+              </a:rPr>
+              <a:t>Scope</a:t>
+            </a:r>
+            <a:endParaRPr lang="en-US" sz="1100" dirty="0"/>
           </a:p>
         </p:txBody>
       </p:sp>
@@ -24193,8 +24193,8 @@
         </p:nvSpPr>
         <p:spPr>
           <a:xfrm>
-            <a:off x="822960" y="3566160"/>
-            <a:ext cx="3566160" cy="914400"/>
+            <a:off x="1874520" y="4389120"/>
+            <a:ext cx="2514600" cy="274320"/>
           </a:xfrm>
           <a:prstGeom prst="rect">
             <a:avLst/>
@@ -24210,46 +24210,52 @@
               <a:buNone/>
             </a:pPr>
             <a:r>
-              <a:rPr lang="en-US" sz="5400" dirty="0">
+              <a:rPr lang="en-US" sz="1150" dirty="0">
                 <a:solidFill>
                   <a:srgbClr val="FFFFFF"/>
                 </a:solidFill>
-                <a:latin typeface="Trenda IG Text Light" pitchFamily="34" charset="0"/>
-                <a:ea typeface="Trenda IG Text Light" pitchFamily="34" charset="-122"/>
-                <a:cs typeface="Trenda IG Text Light" pitchFamily="34" charset="-120"/>
-              </a:rPr>
-              <a:t>$60,000</a:t>
-            </a:r>
-            <a:endParaRPr lang="en-US" sz="5400" dirty="0"/>
-          </a:p>
-        </p:txBody>
-      </p:sp>
-      <p:sp>
-        <p:nvSpPr>
-          <p:cNvPr id="12" name="Shape 10"/>
-          <p:cNvSpPr/>
-          <p:nvPr/>
-        </p:nvSpPr>
-        <p:spPr>
-          <a:xfrm>
-            <a:off x="822960" y="4617720"/>
-            <a:ext cx="3108960" cy="384048"/>
-          </a:xfrm>
-          <a:prstGeom prst="roundRect">
-            <a:avLst>
-              <a:gd name="adj" fmla="val 50000"/>
-            </a:avLst>
-          </a:prstGeom>
-          <a:solidFill>
-            <a:srgbClr val="FF0068"/>
-          </a:solidFill>
-          <a:ln w="12700">
-            <a:solidFill>
-              <a:srgbClr val="FF0068"/>
-            </a:solidFill>
-            <a:prstDash val="solid"/>
-          </a:ln>
-        </p:spPr>
+              </a:rPr>
+              <a:t>Conference and session setup; Certain retired</a:t>
+            </a:r>
+            <a:endParaRPr lang="en-US" sz="1150" dirty="0"/>
+          </a:p>
+        </p:txBody>
+      </p:sp>
+      <p:sp>
+        <p:nvSpPr>
+          <p:cNvPr id="12" name="Text 10"/>
+          <p:cNvSpPr txBox="1"/>
+          <p:nvPr/>
+        </p:nvSpPr>
+        <p:spPr>
+          <a:xfrm>
+            <a:off x="822960" y="4828032"/>
+            <a:ext cx="1097280" cy="274320"/>
+          </a:xfrm>
+          <a:prstGeom prst="rect">
+            <a:avLst/>
+          </a:prstGeom>
+          <a:noFill/>
+          <a:ln/>
+        </p:spPr>
+        <p:txBody>
+          <a:bodyPr wrap="square" lIns="0" tIns="0" rIns="0" bIns="0" rtlCol="0" anchor="t"/>
+          <a:lstStyle/>
+          <a:p>
+            <a:pPr indent="0" marL="0">
+              <a:buNone/>
+            </a:pPr>
+            <a:r>
+              <a:rPr lang="en-US" sz="1100" b="1" dirty="0">
+                <a:solidFill>
+                  <a:srgbClr val="BFBFBF"/>
+                </a:solidFill>
+              </a:rPr>
+              <a:t>Duration</a:t>
+            </a:r>
+            <a:endParaRPr lang="en-US" sz="1100" dirty="0"/>
+          </a:p>
+        </p:txBody>
       </p:sp>
       <p:sp>
         <p:nvSpPr>
@@ -24259,8 +24265,116 @@
         </p:nvSpPr>
         <p:spPr>
           <a:xfrm>
-            <a:off x="822960" y="4617720"/>
-            <a:ext cx="3108960" cy="384048"/>
+            <a:off x="1874520" y="4828032"/>
+            <a:ext cx="2514600" cy="274320"/>
+          </a:xfrm>
+          <a:prstGeom prst="rect">
+            <a:avLst/>
+          </a:prstGeom>
+          <a:noFill/>
+          <a:ln/>
+        </p:spPr>
+        <p:txBody>
+          <a:bodyPr wrap="square" lIns="0" tIns="0" rIns="0" bIns="0" rtlCol="0" anchor="t"/>
+          <a:lstStyle/>
+          <a:p>
+            <a:pPr indent="0" marL="0">
+              <a:buNone/>
+            </a:pPr>
+            <a:r>
+              <a:rPr lang="en-US" sz="1150" dirty="0">
+                <a:solidFill>
+                  <a:srgbClr val="FFFFFF"/>
+                </a:solidFill>
+              </a:rPr>
+              <a:t>8 weeks, 4 two-week sprints</a:t>
+            </a:r>
+            <a:endParaRPr lang="en-US" sz="1150" dirty="0"/>
+          </a:p>
+        </p:txBody>
+      </p:sp>
+      <p:sp>
+        <p:nvSpPr>
+          <p:cNvPr id="14" name="Text 12"/>
+          <p:cNvSpPr txBox="1"/>
+          <p:nvPr/>
+        </p:nvSpPr>
+        <p:spPr>
+          <a:xfrm>
+            <a:off x="822960" y="5266944"/>
+            <a:ext cx="1097280" cy="274320"/>
+          </a:xfrm>
+          <a:prstGeom prst="rect">
+            <a:avLst/>
+          </a:prstGeom>
+          <a:noFill/>
+          <a:ln/>
+        </p:spPr>
+        <p:txBody>
+          <a:bodyPr wrap="square" lIns="0" tIns="0" rIns="0" bIns="0" rtlCol="0" anchor="t"/>
+          <a:lstStyle/>
+          <a:p>
+            <a:pPr indent="0" marL="0">
+              <a:buNone/>
+            </a:pPr>
+            <a:r>
+              <a:rPr lang="en-US" sz="1100" b="1" dirty="0">
+                <a:solidFill>
+                  <a:srgbClr val="BFBFBF"/>
+                </a:solidFill>
+              </a:rPr>
+              <a:t>Billing</a:t>
+            </a:r>
+            <a:endParaRPr lang="en-US" sz="1100" dirty="0"/>
+          </a:p>
+        </p:txBody>
+      </p:sp>
+      <p:sp>
+        <p:nvSpPr>
+          <p:cNvPr id="15" name="Text 13"/>
+          <p:cNvSpPr txBox="1"/>
+          <p:nvPr/>
+        </p:nvSpPr>
+        <p:spPr>
+          <a:xfrm>
+            <a:off x="1874520" y="5266944"/>
+            <a:ext cx="2514600" cy="274320"/>
+          </a:xfrm>
+          <a:prstGeom prst="rect">
+            <a:avLst/>
+          </a:prstGeom>
+          <a:noFill/>
+          <a:ln/>
+        </p:spPr>
+        <p:txBody>
+          <a:bodyPr wrap="square" lIns="0" tIns="0" rIns="0" bIns="0" rtlCol="0" anchor="t"/>
+          <a:lstStyle/>
+          <a:p>
+            <a:pPr indent="0" marL="0">
+              <a:buNone/>
+            </a:pPr>
+            <a:r>
+              <a:rPr lang="en-US" sz="1150" dirty="0">
+                <a:solidFill>
+                  <a:srgbClr val="FFFFFF"/>
+                </a:solidFill>
+              </a:rPr>
+              <a:t>At sprint milestones</a:t>
+            </a:r>
+            <a:endParaRPr lang="en-US" sz="1150" dirty="0"/>
+          </a:p>
+        </p:txBody>
+      </p:sp>
+      <p:sp>
+        <p:nvSpPr>
+          <p:cNvPr id="16" name="Text 14"/>
+          <p:cNvSpPr txBox="1"/>
+          <p:nvPr/>
+        </p:nvSpPr>
+        <p:spPr>
+          <a:xfrm>
+            <a:off x="5129784" y="1783080"/>
+            <a:ext cx="4855464" cy="329184"/>
           </a:xfrm>
           <a:prstGeom prst="rect">
             <a:avLst/>
@@ -24272,67 +24386,31 @@
           <a:bodyPr wrap="square" lIns="0" tIns="0" rIns="0" bIns="0" rtlCol="0" anchor="ctr"/>
           <a:lstStyle/>
           <a:p>
-            <a:pPr algn="ctr" indent="0" marL="0">
-              <a:buNone/>
-            </a:pPr>
-            <a:r>
-              <a:rPr lang="en-US" sz="1200" b="1" dirty="0">
-                <a:solidFill>
-                  <a:srgbClr val="FFFFFF"/>
-                </a:solidFill>
-              </a:rPr>
-              <a:t>50% partnership credit, applied upfront</a:t>
-            </a:r>
-            <a:endParaRPr lang="en-US" sz="1200" dirty="0"/>
-          </a:p>
-        </p:txBody>
-      </p:sp>
-      <p:sp>
-        <p:nvSpPr>
-          <p:cNvPr id="14" name="Text 12"/>
-          <p:cNvSpPr txBox="1"/>
-          <p:nvPr/>
-        </p:nvSpPr>
-        <p:spPr>
-          <a:xfrm>
-            <a:off x="822960" y="5184648"/>
-            <a:ext cx="3566160" cy="274320"/>
-          </a:xfrm>
-          <a:prstGeom prst="rect">
-            <a:avLst/>
-          </a:prstGeom>
-          <a:noFill/>
-          <a:ln/>
-        </p:spPr>
-        <p:txBody>
-          <a:bodyPr wrap="square" lIns="0" tIns="0" rIns="0" bIns="0" rtlCol="0" anchor="t"/>
-          <a:lstStyle/>
-          <a:p>
-            <a:pPr indent="0" marL="0">
-              <a:buNone/>
-            </a:pPr>
-            <a:r>
-              <a:rPr lang="en-US" sz="1200" dirty="0">
-                <a:solidFill>
-                  <a:srgbClr val="D9D9D9"/>
-                </a:solidFill>
-              </a:rPr>
-              <a:t>You save $60,000 on the full program</a:t>
-            </a:r>
-            <a:endParaRPr lang="en-US" sz="1200" dirty="0"/>
-          </a:p>
-        </p:txBody>
-      </p:sp>
-      <p:sp>
-        <p:nvSpPr>
-          <p:cNvPr id="15" name="Text 13"/>
-          <p:cNvSpPr txBox="1"/>
-          <p:nvPr/>
-        </p:nvSpPr>
-        <p:spPr>
-          <a:xfrm>
-            <a:off x="5129784" y="1783080"/>
-            <a:ext cx="3182112" cy="329184"/>
+            <a:pPr algn="l" indent="0" marL="0">
+              <a:buNone/>
+            </a:pPr>
+            <a:r>
+              <a:rPr lang="en-US" sz="1250" b="1" dirty="0">
+                <a:solidFill>
+                  <a:srgbClr val="000000"/>
+                </a:solidFill>
+              </a:rPr>
+              <a:t>Team</a:t>
+            </a:r>
+            <a:endParaRPr lang="en-US" sz="1250" dirty="0"/>
+          </a:p>
+        </p:txBody>
+      </p:sp>
+      <p:sp>
+        <p:nvSpPr>
+          <p:cNvPr id="17" name="Text 15"/>
+          <p:cNvSpPr txBox="1"/>
+          <p:nvPr/>
+        </p:nvSpPr>
+        <p:spPr>
+          <a:xfrm>
+            <a:off x="10094976" y="1783080"/>
+            <a:ext cx="1536192" cy="329184"/>
           </a:xfrm>
           <a:prstGeom prst="rect">
             <a:avLst/>
@@ -24344,132 +24422,24 @@
           <a:bodyPr wrap="square" lIns="0" tIns="0" rIns="0" bIns="0" rtlCol="0" anchor="ctr"/>
           <a:lstStyle/>
           <a:p>
-            <a:pPr algn="l" indent="0" marL="0">
-              <a:buNone/>
-            </a:pPr>
-            <a:r>
-              <a:rPr lang="en-US" sz="1200" b="1" dirty="0">
+            <a:pPr algn="r" indent="0" marL="0">
+              <a:buNone/>
+            </a:pPr>
+            <a:r>
+              <a:rPr lang="en-US" sz="1250" b="1" dirty="0">
                 <a:solidFill>
                   <a:srgbClr val="000000"/>
                 </a:solidFill>
               </a:rPr>
-              <a:t>Phase</a:t>
-            </a:r>
-            <a:endParaRPr lang="en-US" sz="1200" dirty="0"/>
-          </a:p>
-        </p:txBody>
-      </p:sp>
-      <p:sp>
-        <p:nvSpPr>
-          <p:cNvPr id="16" name="Text 14"/>
-          <p:cNvSpPr txBox="1"/>
-          <p:nvPr/>
-        </p:nvSpPr>
-        <p:spPr>
-          <a:xfrm>
-            <a:off x="8421624" y="1783080"/>
-            <a:ext cx="896112" cy="329184"/>
-          </a:xfrm>
-          <a:prstGeom prst="rect">
-            <a:avLst/>
-          </a:prstGeom>
-          <a:noFill/>
-          <a:ln/>
-        </p:spPr>
-        <p:txBody>
-          <a:bodyPr wrap="square" lIns="0" tIns="0" rIns="0" bIns="0" rtlCol="0" anchor="ctr"/>
-          <a:lstStyle/>
-          <a:p>
-            <a:pPr algn="l" indent="0" marL="0">
-              <a:buNone/>
-            </a:pPr>
-            <a:r>
-              <a:rPr lang="en-US" sz="1200" b="1" dirty="0">
-                <a:solidFill>
-                  <a:srgbClr val="000000"/>
-                </a:solidFill>
-              </a:rPr>
-              <a:t>Weeks</a:t>
-            </a:r>
-            <a:endParaRPr lang="en-US" sz="1200" dirty="0"/>
-          </a:p>
-        </p:txBody>
-      </p:sp>
-      <p:sp>
-        <p:nvSpPr>
-          <p:cNvPr id="17" name="Text 15"/>
-          <p:cNvSpPr txBox="1"/>
-          <p:nvPr/>
-        </p:nvSpPr>
-        <p:spPr>
-          <a:xfrm>
-            <a:off x="9427464" y="1783080"/>
-            <a:ext cx="1078992" cy="329184"/>
-          </a:xfrm>
-          <a:prstGeom prst="rect">
-            <a:avLst/>
-          </a:prstGeom>
-          <a:noFill/>
-          <a:ln/>
-        </p:spPr>
-        <p:txBody>
-          <a:bodyPr wrap="square" lIns="0" tIns="0" rIns="0" bIns="0" rtlCol="0" anchor="ctr"/>
-          <a:lstStyle/>
-          <a:p>
-            <a:pPr algn="r" indent="0" marL="0">
-              <a:buNone/>
-            </a:pPr>
-            <a:r>
-              <a:rPr lang="en-US" sz="1200" b="1" dirty="0">
-                <a:solidFill>
-                  <a:srgbClr val="000000"/>
-                </a:solidFill>
-              </a:rPr>
-              <a:t>Standard</a:t>
-            </a:r>
-            <a:endParaRPr lang="en-US" sz="1200" dirty="0"/>
-          </a:p>
-        </p:txBody>
-      </p:sp>
-      <p:sp>
-        <p:nvSpPr>
-          <p:cNvPr id="18" name="Text 16"/>
-          <p:cNvSpPr txBox="1"/>
-          <p:nvPr/>
-        </p:nvSpPr>
-        <p:spPr>
-          <a:xfrm>
-            <a:off x="10616184" y="1783080"/>
-            <a:ext cx="1014984" cy="329184"/>
-          </a:xfrm>
-          <a:prstGeom prst="rect">
-            <a:avLst/>
-          </a:prstGeom>
-          <a:noFill/>
-          <a:ln/>
-        </p:spPr>
-        <p:txBody>
-          <a:bodyPr wrap="square" lIns="0" tIns="0" rIns="0" bIns="0" rtlCol="0" anchor="ctr"/>
-          <a:lstStyle/>
-          <a:p>
-            <a:pPr algn="r" indent="0" marL="0">
-              <a:buNone/>
-            </a:pPr>
-            <a:r>
-              <a:rPr lang="en-US" sz="1200" b="1" dirty="0">
-                <a:solidFill>
-                  <a:srgbClr val="000000"/>
-                </a:solidFill>
-              </a:rPr>
-              <a:t>Partner</a:t>
-            </a:r>
-            <a:endParaRPr lang="en-US" sz="1200" dirty="0"/>
-          </a:p>
-        </p:txBody>
-      </p:sp>
-      <p:sp>
-        <p:nvSpPr>
-          <p:cNvPr id="19" name="Shape 17"/>
+              <a:t>Resources</a:t>
+            </a:r>
+            <a:endParaRPr lang="en-US" sz="1250" dirty="0"/>
+          </a:p>
+        </p:txBody>
+      </p:sp>
+      <p:sp>
+        <p:nvSpPr>
+          <p:cNvPr id="18" name="Shape 16"/>
           <p:cNvSpPr/>
           <p:nvPr/>
         </p:nvSpPr>
@@ -24492,14 +24462,50 @@
       </p:sp>
       <p:sp>
         <p:nvSpPr>
+          <p:cNvPr id="19" name="Text 17"/>
+          <p:cNvSpPr txBox="1"/>
+          <p:nvPr/>
+        </p:nvSpPr>
+        <p:spPr>
+          <a:xfrm>
+            <a:off x="5129784" y="2112264"/>
+            <a:ext cx="4855464" cy="420624"/>
+          </a:xfrm>
+          <a:prstGeom prst="rect">
+            <a:avLst/>
+          </a:prstGeom>
+          <a:noFill/>
+          <a:ln/>
+        </p:spPr>
+        <p:txBody>
+          <a:bodyPr wrap="square" lIns="0" tIns="0" rIns="0" bIns="0" rtlCol="0" anchor="ctr"/>
+          <a:lstStyle/>
+          <a:p>
+            <a:pPr algn="l" indent="0" marL="0">
+              <a:buNone/>
+            </a:pPr>
+            <a:r>
+              <a:rPr lang="en-US" sz="1250" dirty="0">
+                <a:solidFill>
+                  <a:srgbClr val="000000"/>
+                </a:solidFill>
+              </a:rPr>
+              <a:t>Project Manager</a:t>
+            </a:r>
+            <a:endParaRPr lang="en-US" sz="1250" dirty="0"/>
+          </a:p>
+        </p:txBody>
+      </p:sp>
+      <p:sp>
+        <p:nvSpPr>
           <p:cNvPr id="20" name="Text 18"/>
           <p:cNvSpPr txBox="1"/>
           <p:nvPr/>
         </p:nvSpPr>
         <p:spPr>
           <a:xfrm>
-            <a:off x="5129784" y="2112264"/>
-            <a:ext cx="3182112" cy="457200"/>
+            <a:off x="10094976" y="2112264"/>
+            <a:ext cx="1536192" cy="420624"/>
           </a:xfrm>
           <a:prstGeom prst="rect">
             <a:avLst/>
@@ -24511,138 +24517,30 @@
           <a:bodyPr wrap="square" lIns="0" tIns="0" rIns="0" bIns="0" rtlCol="0" anchor="ctr"/>
           <a:lstStyle/>
           <a:p>
-            <a:pPr algn="l" indent="0" marL="0">
-              <a:buNone/>
-            </a:pPr>
-            <a:r>
-              <a:rPr lang="en-US" sz="1200" dirty="0">
+            <a:pPr algn="r" indent="0" marL="0">
+              <a:buNone/>
+            </a:pPr>
+            <a:r>
+              <a:rPr lang="en-US" sz="1250" dirty="0">
                 <a:solidFill>
                   <a:srgbClr val="000000"/>
                 </a:solidFill>
               </a:rPr>
-              <a:t>Assess and design</a:t>
-            </a:r>
-            <a:endParaRPr lang="en-US" sz="1200" dirty="0"/>
-          </a:p>
-        </p:txBody>
-      </p:sp>
-      <p:sp>
-        <p:nvSpPr>
-          <p:cNvPr id="21" name="Text 19"/>
-          <p:cNvSpPr txBox="1"/>
-          <p:nvPr/>
-        </p:nvSpPr>
-        <p:spPr>
-          <a:xfrm>
-            <a:off x="8421624" y="2112264"/>
-            <a:ext cx="896112" cy="457200"/>
-          </a:xfrm>
-          <a:prstGeom prst="rect">
-            <a:avLst/>
-          </a:prstGeom>
-          <a:noFill/>
-          <a:ln/>
-        </p:spPr>
-        <p:txBody>
-          <a:bodyPr wrap="square" lIns="0" tIns="0" rIns="0" bIns="0" rtlCol="0" anchor="ctr"/>
-          <a:lstStyle/>
-          <a:p>
-            <a:pPr algn="l" indent="0" marL="0">
-              <a:buNone/>
-            </a:pPr>
-            <a:r>
-              <a:rPr lang="en-US" sz="1200" dirty="0">
-                <a:solidFill>
-                  <a:srgbClr val="000000"/>
-                </a:solidFill>
-              </a:rPr>
-              <a:t>1-2</a:t>
-            </a:r>
-            <a:endParaRPr lang="en-US" sz="1200" dirty="0"/>
-          </a:p>
-        </p:txBody>
-      </p:sp>
-      <p:sp>
-        <p:nvSpPr>
-          <p:cNvPr id="22" name="Text 20"/>
-          <p:cNvSpPr txBox="1"/>
-          <p:nvPr/>
-        </p:nvSpPr>
-        <p:spPr>
-          <a:xfrm>
-            <a:off x="9427464" y="2112264"/>
-            <a:ext cx="1078992" cy="457200"/>
-          </a:xfrm>
-          <a:prstGeom prst="rect">
-            <a:avLst/>
-          </a:prstGeom>
-          <a:noFill/>
-          <a:ln/>
-        </p:spPr>
-        <p:txBody>
-          <a:bodyPr wrap="square" lIns="0" tIns="0" rIns="0" bIns="0" rtlCol="0" anchor="ctr"/>
-          <a:lstStyle/>
-          <a:p>
-            <a:pPr algn="r" indent="0" marL="0">
-              <a:buNone/>
-            </a:pPr>
-            <a:r>
-              <a:rPr lang="en-US" sz="1200" strike="sngStrike" dirty="0">
-                <a:solidFill>
-                  <a:srgbClr val="8C8C8C"/>
-                </a:solidFill>
-              </a:rPr>
-              <a:t>$30,000</a:t>
-            </a:r>
-            <a:endParaRPr lang="en-US" sz="1200" dirty="0"/>
-          </a:p>
-        </p:txBody>
-      </p:sp>
-      <p:sp>
-        <p:nvSpPr>
-          <p:cNvPr id="23" name="Text 21"/>
-          <p:cNvSpPr txBox="1"/>
-          <p:nvPr/>
-        </p:nvSpPr>
-        <p:spPr>
-          <a:xfrm>
-            <a:off x="10616184" y="2112264"/>
-            <a:ext cx="1014984" cy="457200"/>
-          </a:xfrm>
-          <a:prstGeom prst="rect">
-            <a:avLst/>
-          </a:prstGeom>
-          <a:noFill/>
-          <a:ln/>
-        </p:spPr>
-        <p:txBody>
-          <a:bodyPr wrap="square" lIns="0" tIns="0" rIns="0" bIns="0" rtlCol="0" anchor="ctr"/>
-          <a:lstStyle/>
-          <a:p>
-            <a:pPr algn="r" indent="0" marL="0">
-              <a:buNone/>
-            </a:pPr>
-            <a:r>
-              <a:rPr lang="en-US" sz="1200" b="1" dirty="0">
-                <a:solidFill>
-                  <a:srgbClr val="000000"/>
-                </a:solidFill>
-              </a:rPr>
-              <a:t>$15,000</a:t>
-            </a:r>
-            <a:endParaRPr lang="en-US" sz="1200" dirty="0"/>
-          </a:p>
-        </p:txBody>
-      </p:sp>
-      <p:sp>
-        <p:nvSpPr>
-          <p:cNvPr id="24" name="Shape 22"/>
+              <a:t>1</a:t>
+            </a:r>
+            <a:endParaRPr lang="en-US" sz="1250" dirty="0"/>
+          </a:p>
+        </p:txBody>
+      </p:sp>
+      <p:sp>
+        <p:nvSpPr>
+          <p:cNvPr id="21" name="Shape 19"/>
           <p:cNvSpPr/>
           <p:nvPr/>
         </p:nvSpPr>
         <p:spPr>
           <a:xfrm>
-            <a:off x="5074920" y="2569464"/>
+            <a:off x="5074920" y="2532888"/>
             <a:ext cx="6611112" cy="0"/>
           </a:xfrm>
           <a:prstGeom prst="line">
@@ -24659,14 +24557,109 @@
       </p:sp>
       <p:sp>
         <p:nvSpPr>
+          <p:cNvPr id="22" name="Text 20"/>
+          <p:cNvSpPr txBox="1"/>
+          <p:nvPr/>
+        </p:nvSpPr>
+        <p:spPr>
+          <a:xfrm>
+            <a:off x="5129784" y="2532888"/>
+            <a:ext cx="4855464" cy="420624"/>
+          </a:xfrm>
+          <a:prstGeom prst="rect">
+            <a:avLst/>
+          </a:prstGeom>
+          <a:noFill/>
+          <a:ln/>
+        </p:spPr>
+        <p:txBody>
+          <a:bodyPr wrap="square" lIns="0" tIns="0" rIns="0" bIns="0" rtlCol="0" anchor="ctr"/>
+          <a:lstStyle/>
+          <a:p>
+            <a:pPr algn="l" indent="0" marL="0">
+              <a:buNone/>
+            </a:pPr>
+            <a:r>
+              <a:rPr lang="en-US" sz="1250" dirty="0">
+                <a:solidFill>
+                  <a:srgbClr val="000000"/>
+                </a:solidFill>
+              </a:rPr>
+              <a:t>Salesforce Developer</a:t>
+            </a:r>
+            <a:endParaRPr lang="en-US" sz="1250" dirty="0"/>
+          </a:p>
+        </p:txBody>
+      </p:sp>
+      <p:sp>
+        <p:nvSpPr>
+          <p:cNvPr id="23" name="Text 21"/>
+          <p:cNvSpPr txBox="1"/>
+          <p:nvPr/>
+        </p:nvSpPr>
+        <p:spPr>
+          <a:xfrm>
+            <a:off x="10094976" y="2532888"/>
+            <a:ext cx="1536192" cy="420624"/>
+          </a:xfrm>
+          <a:prstGeom prst="rect">
+            <a:avLst/>
+          </a:prstGeom>
+          <a:noFill/>
+          <a:ln/>
+        </p:spPr>
+        <p:txBody>
+          <a:bodyPr wrap="square" lIns="0" tIns="0" rIns="0" bIns="0" rtlCol="0" anchor="ctr"/>
+          <a:lstStyle/>
+          <a:p>
+            <a:pPr algn="r" indent="0" marL="0">
+              <a:buNone/>
+            </a:pPr>
+            <a:r>
+              <a:rPr lang="en-US" sz="1250" dirty="0">
+                <a:solidFill>
+                  <a:srgbClr val="000000"/>
+                </a:solidFill>
+              </a:rPr>
+              <a:t>1</a:t>
+            </a:r>
+            <a:endParaRPr lang="en-US" sz="1250" dirty="0"/>
+          </a:p>
+        </p:txBody>
+      </p:sp>
+      <p:sp>
+        <p:nvSpPr>
+          <p:cNvPr id="24" name="Shape 22"/>
+          <p:cNvSpPr/>
+          <p:nvPr/>
+        </p:nvSpPr>
+        <p:spPr>
+          <a:xfrm>
+            <a:off x="5074920" y="2953512"/>
+            <a:ext cx="6611112" cy="0"/>
+          </a:xfrm>
+          <a:prstGeom prst="line">
+            <a:avLst/>
+          </a:prstGeom>
+          <a:noFill/>
+          <a:ln w="9525">
+            <a:solidFill>
+              <a:srgbClr val="A0A0A8"/>
+            </a:solidFill>
+            <a:prstDash val="sysDot"/>
+          </a:ln>
+        </p:spPr>
+      </p:sp>
+      <p:sp>
+        <p:nvSpPr>
           <p:cNvPr id="25" name="Text 23"/>
           <p:cNvSpPr txBox="1"/>
           <p:nvPr/>
         </p:nvSpPr>
         <p:spPr>
           <a:xfrm>
-            <a:off x="5129784" y="2569464"/>
-            <a:ext cx="3182112" cy="457200"/>
+            <a:off x="5129784" y="2953512"/>
+            <a:ext cx="4855464" cy="420624"/>
           </a:xfrm>
           <a:prstGeom prst="rect">
             <a:avLst/>
@@ -24682,14 +24675,14 @@
               <a:buNone/>
             </a:pPr>
             <a:r>
-              <a:rPr lang="en-US" sz="1200" dirty="0">
+              <a:rPr lang="en-US" sz="1250" dirty="0">
                 <a:solidFill>
                   <a:srgbClr val="000000"/>
                 </a:solidFill>
               </a:rPr>
-              <a:t>Build, test and go live</a:t>
-            </a:r>
-            <a:endParaRPr lang="en-US" sz="1200" dirty="0"/>
+              <a:t>QA Engineer</a:t>
+            </a:r>
+            <a:endParaRPr lang="en-US" sz="1250" dirty="0"/>
           </a:p>
         </p:txBody>
       </p:sp>
@@ -24701,8 +24694,8 @@
         </p:nvSpPr>
         <p:spPr>
           <a:xfrm>
-            <a:off x="8421624" y="2569464"/>
-            <a:ext cx="896112" cy="457200"/>
+            <a:off x="10094976" y="2953512"/>
+            <a:ext cx="1536192" cy="420624"/>
           </a:xfrm>
           <a:prstGeom prst="rect">
             <a:avLst/>
@@ -24714,102 +24707,30 @@
           <a:bodyPr wrap="square" lIns="0" tIns="0" rIns="0" bIns="0" rtlCol="0" anchor="ctr"/>
           <a:lstStyle/>
           <a:p>
-            <a:pPr algn="l" indent="0" marL="0">
-              <a:buNone/>
-            </a:pPr>
-            <a:r>
-              <a:rPr lang="en-US" sz="1200" dirty="0">
+            <a:pPr algn="r" indent="0" marL="0">
+              <a:buNone/>
+            </a:pPr>
+            <a:r>
+              <a:rPr lang="en-US" sz="1250" dirty="0">
                 <a:solidFill>
                   <a:srgbClr val="000000"/>
                 </a:solidFill>
               </a:rPr>
-              <a:t>3-8</a:t>
-            </a:r>
-            <a:endParaRPr lang="en-US" sz="1200" dirty="0"/>
-          </a:p>
-        </p:txBody>
-      </p:sp>
-      <p:sp>
-        <p:nvSpPr>
-          <p:cNvPr id="27" name="Text 25"/>
-          <p:cNvSpPr txBox="1"/>
-          <p:nvPr/>
-        </p:nvSpPr>
-        <p:spPr>
-          <a:xfrm>
-            <a:off x="9427464" y="2569464"/>
-            <a:ext cx="1078992" cy="457200"/>
-          </a:xfrm>
-          <a:prstGeom prst="rect">
-            <a:avLst/>
-          </a:prstGeom>
-          <a:noFill/>
-          <a:ln/>
-        </p:spPr>
-        <p:txBody>
-          <a:bodyPr wrap="square" lIns="0" tIns="0" rIns="0" bIns="0" rtlCol="0" anchor="ctr"/>
-          <a:lstStyle/>
-          <a:p>
-            <a:pPr algn="r" indent="0" marL="0">
-              <a:buNone/>
-            </a:pPr>
-            <a:r>
-              <a:rPr lang="en-US" sz="1200" strike="sngStrike" dirty="0">
-                <a:solidFill>
-                  <a:srgbClr val="8C8C8C"/>
-                </a:solidFill>
-              </a:rPr>
-              <a:t>$90,000</a:t>
-            </a:r>
-            <a:endParaRPr lang="en-US" sz="1200" dirty="0"/>
-          </a:p>
-        </p:txBody>
-      </p:sp>
-      <p:sp>
-        <p:nvSpPr>
-          <p:cNvPr id="28" name="Text 26"/>
-          <p:cNvSpPr txBox="1"/>
-          <p:nvPr/>
-        </p:nvSpPr>
-        <p:spPr>
-          <a:xfrm>
-            <a:off x="10616184" y="2569464"/>
-            <a:ext cx="1014984" cy="457200"/>
-          </a:xfrm>
-          <a:prstGeom prst="rect">
-            <a:avLst/>
-          </a:prstGeom>
-          <a:noFill/>
-          <a:ln/>
-        </p:spPr>
-        <p:txBody>
-          <a:bodyPr wrap="square" lIns="0" tIns="0" rIns="0" bIns="0" rtlCol="0" anchor="ctr"/>
-          <a:lstStyle/>
-          <a:p>
-            <a:pPr algn="r" indent="0" marL="0">
-              <a:buNone/>
-            </a:pPr>
-            <a:r>
-              <a:rPr lang="en-US" sz="1200" b="1" dirty="0">
-                <a:solidFill>
-                  <a:srgbClr val="000000"/>
-                </a:solidFill>
-              </a:rPr>
-              <a:t>$45,000</a:t>
-            </a:r>
-            <a:endParaRPr lang="en-US" sz="1200" dirty="0"/>
-          </a:p>
-        </p:txBody>
-      </p:sp>
-      <p:sp>
-        <p:nvSpPr>
-          <p:cNvPr id="29" name="Shape 27"/>
+              <a:t>1</a:t>
+            </a:r>
+            <a:endParaRPr lang="en-US" sz="1250" dirty="0"/>
+          </a:p>
+        </p:txBody>
+      </p:sp>
+      <p:sp>
+        <p:nvSpPr>
+          <p:cNvPr id="27" name="Shape 25"/>
           <p:cNvSpPr/>
           <p:nvPr/>
         </p:nvSpPr>
         <p:spPr>
           <a:xfrm>
-            <a:off x="5074920" y="3026664"/>
+            <a:off x="5074920" y="3374136"/>
             <a:ext cx="6611112" cy="0"/>
           </a:xfrm>
           <a:prstGeom prst="line">
@@ -24826,14 +24747,14 @@
       </p:sp>
       <p:sp>
         <p:nvSpPr>
-          <p:cNvPr id="30" name="Text 28"/>
-          <p:cNvSpPr txBox="1"/>
-          <p:nvPr/>
-        </p:nvSpPr>
-        <p:spPr>
-          <a:xfrm>
-            <a:off x="5129784" y="3026664"/>
-            <a:ext cx="3182112" cy="457200"/>
+          <p:cNvPr id="28" name="Text 26"/>
+          <p:cNvSpPr txBox="1"/>
+          <p:nvPr/>
+        </p:nvSpPr>
+        <p:spPr>
+          <a:xfrm>
+            <a:off x="5129784" y="3374136"/>
+            <a:ext cx="4855464" cy="420624"/>
           </a:xfrm>
           <a:prstGeom prst="rect">
             <a:avLst/>
@@ -24849,27 +24770,27 @@
               <a:buNone/>
             </a:pPr>
             <a:r>
-              <a:rPr lang="en-US" sz="1200" b="1" dirty="0">
+              <a:rPr lang="en-US" sz="1250" b="1" dirty="0">
                 <a:solidFill>
                   <a:srgbClr val="000000"/>
                 </a:solidFill>
               </a:rPr>
-              <a:t>Total program</a:t>
-            </a:r>
-            <a:endParaRPr lang="en-US" sz="1200" dirty="0"/>
-          </a:p>
-        </p:txBody>
-      </p:sp>
-      <p:sp>
-        <p:nvSpPr>
-          <p:cNvPr id="31" name="Text 29"/>
-          <p:cNvSpPr txBox="1"/>
-          <p:nvPr/>
-        </p:nvSpPr>
-        <p:spPr>
-          <a:xfrm>
-            <a:off x="8421624" y="3026664"/>
-            <a:ext cx="896112" cy="457200"/>
+              <a:t>Total</a:t>
+            </a:r>
+            <a:endParaRPr lang="en-US" sz="1250" dirty="0"/>
+          </a:p>
+        </p:txBody>
+      </p:sp>
+      <p:sp>
+        <p:nvSpPr>
+          <p:cNvPr id="29" name="Text 27"/>
+          <p:cNvSpPr txBox="1"/>
+          <p:nvPr/>
+        </p:nvSpPr>
+        <p:spPr>
+          <a:xfrm>
+            <a:off x="10094976" y="3374136"/>
+            <a:ext cx="1536192" cy="420624"/>
           </a:xfrm>
           <a:prstGeom prst="rect">
             <a:avLst/>
@@ -24881,102 +24802,30 @@
           <a:bodyPr wrap="square" lIns="0" tIns="0" rIns="0" bIns="0" rtlCol="0" anchor="ctr"/>
           <a:lstStyle/>
           <a:p>
-            <a:pPr algn="l" indent="0" marL="0">
-              <a:buNone/>
-            </a:pPr>
-            <a:r>
-              <a:rPr lang="en-US" sz="1200" b="1" dirty="0">
+            <a:pPr algn="r" indent="0" marL="0">
+              <a:buNone/>
+            </a:pPr>
+            <a:r>
+              <a:rPr lang="en-US" sz="1250" b="1" dirty="0">
                 <a:solidFill>
                   <a:srgbClr val="000000"/>
                 </a:solidFill>
               </a:rPr>
-              <a:t>8</a:t>
-            </a:r>
-            <a:endParaRPr lang="en-US" sz="1200" dirty="0"/>
-          </a:p>
-        </p:txBody>
-      </p:sp>
-      <p:sp>
-        <p:nvSpPr>
-          <p:cNvPr id="32" name="Text 30"/>
-          <p:cNvSpPr txBox="1"/>
-          <p:nvPr/>
-        </p:nvSpPr>
-        <p:spPr>
-          <a:xfrm>
-            <a:off x="9427464" y="3026664"/>
-            <a:ext cx="1078992" cy="457200"/>
-          </a:xfrm>
-          <a:prstGeom prst="rect">
-            <a:avLst/>
-          </a:prstGeom>
-          <a:noFill/>
-          <a:ln/>
-        </p:spPr>
-        <p:txBody>
-          <a:bodyPr wrap="square" lIns="0" tIns="0" rIns="0" bIns="0" rtlCol="0" anchor="ctr"/>
-          <a:lstStyle/>
-          <a:p>
-            <a:pPr algn="r" indent="0" marL="0">
-              <a:buNone/>
-            </a:pPr>
-            <a:r>
-              <a:rPr lang="en-US" sz="1200" b="1" strike="sngStrike" dirty="0">
-                <a:solidFill>
-                  <a:srgbClr val="8C8C8C"/>
-                </a:solidFill>
-              </a:rPr>
-              <a:t>$120,000</a:t>
-            </a:r>
-            <a:endParaRPr lang="en-US" sz="1200" dirty="0"/>
-          </a:p>
-        </p:txBody>
-      </p:sp>
-      <p:sp>
-        <p:nvSpPr>
-          <p:cNvPr id="33" name="Text 31"/>
-          <p:cNvSpPr txBox="1"/>
-          <p:nvPr/>
-        </p:nvSpPr>
-        <p:spPr>
-          <a:xfrm>
-            <a:off x="10616184" y="3026664"/>
-            <a:ext cx="1014984" cy="457200"/>
-          </a:xfrm>
-          <a:prstGeom prst="rect">
-            <a:avLst/>
-          </a:prstGeom>
-          <a:noFill/>
-          <a:ln/>
-        </p:spPr>
-        <p:txBody>
-          <a:bodyPr wrap="square" lIns="0" tIns="0" rIns="0" bIns="0" rtlCol="0" anchor="ctr"/>
-          <a:lstStyle/>
-          <a:p>
-            <a:pPr algn="r" indent="0" marL="0">
-              <a:buNone/>
-            </a:pPr>
-            <a:r>
-              <a:rPr lang="en-US" sz="1200" b="1" dirty="0">
-                <a:solidFill>
-                  <a:srgbClr val="000000"/>
-                </a:solidFill>
-              </a:rPr>
-              <a:t>$60,000</a:t>
-            </a:r>
-            <a:endParaRPr lang="en-US" sz="1200" dirty="0"/>
-          </a:p>
-        </p:txBody>
-      </p:sp>
-      <p:sp>
-        <p:nvSpPr>
-          <p:cNvPr id="34" name="Shape 32"/>
+              <a:t>3</a:t>
+            </a:r>
+            <a:endParaRPr lang="en-US" sz="1250" dirty="0"/>
+          </a:p>
+        </p:txBody>
+      </p:sp>
+      <p:sp>
+        <p:nvSpPr>
+          <p:cNvPr id="30" name="Shape 28"/>
           <p:cNvSpPr/>
           <p:nvPr/>
         </p:nvSpPr>
         <p:spPr>
           <a:xfrm>
-            <a:off x="5074920" y="3483864"/>
+            <a:off x="5074920" y="3794760"/>
             <a:ext cx="6611112" cy="0"/>
           </a:xfrm>
           <a:prstGeom prst="line">
@@ -24993,13 +24842,13 @@
       </p:sp>
       <p:sp>
         <p:nvSpPr>
-          <p:cNvPr id="35" name="Text 33"/>
-          <p:cNvSpPr txBox="1"/>
-          <p:nvPr/>
-        </p:nvSpPr>
-        <p:spPr>
-          <a:xfrm>
-            <a:off x="5074920" y="3703320"/>
+          <p:cNvPr id="31" name="Text 29"/>
+          <p:cNvSpPr txBox="1"/>
+          <p:nvPr/>
+        </p:nvSpPr>
+        <p:spPr>
+          <a:xfrm>
+            <a:off x="5074920" y="4023360"/>
             <a:ext cx="3200400" cy="274320"/>
           </a:xfrm>
           <a:prstGeom prst="rect">
@@ -25029,14 +24878,14 @@
       </p:sp>
       <p:sp>
         <p:nvSpPr>
-          <p:cNvPr id="36" name="Text 34"/>
-          <p:cNvSpPr txBox="1"/>
-          <p:nvPr/>
-        </p:nvSpPr>
-        <p:spPr>
-          <a:xfrm>
-            <a:off x="5074920" y="4032504"/>
-            <a:ext cx="3291840" cy="1463040"/>
+          <p:cNvPr id="32" name="Text 30"/>
+          <p:cNvSpPr txBox="1"/>
+          <p:nvPr/>
+        </p:nvSpPr>
+        <p:spPr>
+          <a:xfrm>
+            <a:off x="5074920" y="4352544"/>
+            <a:ext cx="3291840" cy="1188720"/>
           </a:xfrm>
           <a:prstGeom prst="rect">
             <a:avLst/>
@@ -25061,7 +24910,7 @@
                   <a:srgbClr val="4D4D4D"/>
                 </a:solidFill>
               </a:rPr>
-              <a:t>Dedicated four-person offshore pod for 8 weeks</a:t>
+              <a:t>Dedicated offshore team for 8 weeks</a:t>
             </a:r>
             <a:endParaRPr lang="en-US" sz="1100" dirty="0"/>
           </a:p>
@@ -25097,7 +24946,7 @@
                   <a:srgbClr val="4D4D4D"/>
                 </a:solidFill>
               </a:rPr>
-              <a:t>Testing, load testing, go-live and hypercare</a:t>
+              <a:t>Testing, go-live and hypercare</a:t>
             </a:r>
             <a:endParaRPr lang="en-US" sz="1100" dirty="0"/>
           </a:p>
@@ -25123,13 +24972,13 @@
       </p:sp>
       <p:sp>
         <p:nvSpPr>
-          <p:cNvPr id="37" name="Text 35"/>
-          <p:cNvSpPr txBox="1"/>
-          <p:nvPr/>
-        </p:nvSpPr>
-        <p:spPr>
-          <a:xfrm>
-            <a:off x="8595360" y="3703320"/>
+          <p:cNvPr id="33" name="Text 31"/>
+          <p:cNvSpPr txBox="1"/>
+          <p:nvPr/>
+        </p:nvSpPr>
+        <p:spPr>
+          <a:xfrm>
+            <a:off x="8595360" y="4023360"/>
             <a:ext cx="3108960" cy="274320"/>
           </a:xfrm>
           <a:prstGeom prst="rect">
@@ -25159,14 +25008,14 @@
       </p:sp>
       <p:sp>
         <p:nvSpPr>
-          <p:cNvPr id="38" name="Text 36"/>
-          <p:cNvSpPr txBox="1"/>
-          <p:nvPr/>
-        </p:nvSpPr>
-        <p:spPr>
-          <a:xfrm>
-            <a:off x="8595360" y="4032504"/>
-            <a:ext cx="3090672" cy="1463040"/>
+          <p:cNvPr id="34" name="Text 32"/>
+          <p:cNvSpPr txBox="1"/>
+          <p:nvPr/>
+        </p:nvSpPr>
+        <p:spPr>
+          <a:xfrm>
+            <a:off x="8595360" y="4352544"/>
+            <a:ext cx="3090672" cy="1188720"/>
           </a:xfrm>
           <a:prstGeom prst="rect">
             <a:avLst/>
@@ -25231,29 +25080,11 @@
             </a:r>
             <a:endParaRPr lang="en-US" sz="1100" dirty="0"/>
           </a:p>
-          <a:p>
-            <a:pPr marL="342900" indent="-342900">
-              <a:spcAft>
-                <a:spcPts val="400"/>
-              </a:spcAft>
-              <a:buSzPct val="100000"/>
-              <a:buChar char="•"/>
-            </a:pPr>
-            <a:r>
-              <a:rPr lang="en-US" sz="1100" dirty="0">
-                <a:solidFill>
-                  <a:srgbClr val="4D4D4D"/>
-                </a:solidFill>
-              </a:rPr>
-              <a:t>Waiting room subscription</a:t>
-            </a:r>
-            <a:endParaRPr lang="en-US" sz="1100" dirty="0"/>
-          </a:p>
-        </p:txBody>
-      </p:sp>
-      <p:sp>
-        <p:nvSpPr>
-          <p:cNvPr id="39" name="Text 37"/>
+        </p:txBody>
+      </p:sp>
+      <p:sp>
+        <p:nvSpPr>
+          <p:cNvPr id="35" name="Text 33"/>
           <p:cNvSpPr txBox="1"/>
           <p:nvPr/>
         </p:nvSpPr>
@@ -25281,7 +25112,7 @@
                   <a:srgbClr val="4D4D4D"/>
                 </a:solidFill>
               </a:rPr>
-              <a:t>Pricing is for an offshore delivery model. Indicative, billed at sprint milestones; final commercials in the statement of work.</a:t>
+              <a:t>Pricing is for an offshore delivery model. Indicative; final commercials in the statement of work.</a:t>
             </a:r>
             <a:endParaRPr lang="en-US" sz="1050" dirty="0"/>
           </a:p>

</xml_diff>